<commit_message>
docs(presentation): update presentation deck file with latest edits
</commit_message>
<xml_diff>
--- a/docs/FINTECHATHON_2026_PRESENTATION.pptx
+++ b/docs/FINTECHATHON_2026_PRESENTATION.pptx
@@ -4,6 +4,9 @@
   <p:sldMasterIdLst>
     <p:sldMasterId id="2147483648" r:id="rId1"/>
   </p:sldMasterIdLst>
+  <p:notesMasterIdLst>
+    <p:notesMasterId r:id="rId12"/>
+  </p:notesMasterIdLst>
   <p:sldIdLst>
     <p:sldId id="256" r:id="rId2"/>
     <p:sldId id="257" r:id="rId3"/>
@@ -16,10 +19,7 @@
     <p:sldId id="264" r:id="rId10"/>
     <p:sldId id="265" r:id="rId11"/>
   </p:sldIdLst>
-  <p:notesMasterIdLst>
-    <p:notesMasterId r:id="rId12"/>
-  </p:notesMasterIdLst>
-  <p:sldSz cx="9144000" cy="5143500"/>
+  <p:sldSz cx="9144000" cy="5143500" type="screen16x9"/>
   <p:notesSz cx="5143500" cy="9144000"/>
   <p:defaultTextStyle>
     <a:lvl1pPr marL="0" algn="l" defTabSz="914400" rtl="0" eaLnBrk="1" latinLnBrk="0" hangingPunct="1">
@@ -113,6 +113,11 @@
       </a:defRPr>
     </a:lvl9pPr>
   </p:defaultTextStyle>
+  <p:extLst>
+    <p:ext uri="{EFAFB233-063F-42B5-8137-9DF3F51BA10A}">
+      <p15:sldGuideLst xmlns:p15="http://schemas.microsoft.com/office/powerpoint/2012/main"/>
+    </p:ext>
+  </p:extLst>
 </p:presentation>
 </file>
 
@@ -138,234 +143,10 @@
           <a:chExt cx="0" cy="0"/>
         </a:xfrm>
       </p:grpSpPr>
-      <p:sp>
-        <p:nvSpPr>
-          <p:cNvPr id="2" name="Header Placeholder 1"/>
-          <p:cNvSpPr>
-            <a:spLocks noGrp="1"/>
-          </p:cNvSpPr>
-          <p:nvPr>
-            <p:ph type="hdr" sz="quarter"/>
-          </p:nvPr>
-        </p:nvSpPr>
-        <p:spPr>
-          <a:xfrm>
-            <a:off x="0" y="0"/>
-            <a:ext cx="2971800" cy="458788"/>
-          </a:xfrm>
-          <a:prstGeom prst="rect">
-            <a:avLst/>
-          </a:prstGeom>
-        </p:spPr>
-        <p:txBody>
-          <a:bodyPr vert="horz" lIns="91440" tIns="45720" rIns="91440" bIns="45720" rtlCol="0"/>
-          <a:lstStyle>
-            <a:lvl1pPr algn="l">
-              <a:defRPr sz="1200"/>
-            </a:lvl1pPr>
-          </a:lstStyle>
-          <a:p>
-            <a:endParaRPr lang="en-US"/>
-          </a:p>
-        </p:txBody>
-      </p:sp>
-      <p:sp>
-        <p:nvSpPr>
-          <p:cNvPr id="3" name="Date Placeholder 2"/>
-          <p:cNvSpPr>
-            <a:spLocks noGrp="1"/>
-          </p:cNvSpPr>
-          <p:nvPr>
-            <p:ph type="dt" idx="1"/>
-          </p:nvPr>
-        </p:nvSpPr>
-        <p:spPr>
-          <a:xfrm>
-            <a:off x="3884613" y="0"/>
-            <a:ext cx="2971800" cy="458788"/>
-          </a:xfrm>
-          <a:prstGeom prst="rect">
-            <a:avLst/>
-          </a:prstGeom>
-        </p:spPr>
-        <p:txBody>
-          <a:bodyPr vert="horz" lIns="91440" tIns="45720" rIns="91440" bIns="45720" rtlCol="0"/>
-          <a:lstStyle>
-            <a:lvl1pPr algn="r">
-              <a:defRPr sz="1200"/>
-            </a:lvl1pPr>
-          </a:lstStyle>
-          <a:p>
-            <a:fld id="{5282F153-3F37-0F45-9E97-73ACFA13230C}" type="datetimeFigureOut">
-              <a:rPr lang="en-US"/>
-              <a:t>7/23/19</a:t>
-            </a:fld>
-            <a:endParaRPr lang="en-US"/>
-          </a:p>
-        </p:txBody>
-      </p:sp>
-      <p:sp>
-        <p:nvSpPr>
-          <p:cNvPr id="4" name="Slide Image Placeholder 3"/>
-          <p:cNvSpPr>
-            <a:spLocks noGrp="1" noRot="1" noChangeAspect="1"/>
-          </p:cNvSpPr>
-          <p:nvPr>
-            <p:ph type="sldImg" idx="2"/>
-          </p:nvPr>
-        </p:nvSpPr>
-        <p:spPr>
-          <a:xfrm>
-            <a:off x="685800" y="1143000"/>
-            <a:ext cx="5486400" cy="3086100"/>
-          </a:xfrm>
-          <a:prstGeom prst="rect">
-            <a:avLst/>
-          </a:prstGeom>
-          <a:noFill/>
-          <a:ln w="12700">
-            <a:solidFill>
-              <a:prstClr val="black"/>
-            </a:solidFill>
-          </a:ln>
-        </p:spPr>
-        <p:txBody>
-          <a:bodyPr vert="horz" lIns="91440" tIns="45720" rIns="91440" bIns="45720" rtlCol="0" anchor="ctr"/>
-          <a:lstStyle/>
-          <a:p>
-            <a:endParaRPr lang="en-US"/>
-          </a:p>
-        </p:txBody>
-      </p:sp>
-      <p:sp>
-        <p:nvSpPr>
-          <p:cNvPr id="5" name="Notes Placeholder 4"/>
-          <p:cNvSpPr>
-            <a:spLocks noGrp="1"/>
-          </p:cNvSpPr>
-          <p:nvPr>
-            <p:ph type="body" sz="quarter" idx="3"/>
-          </p:nvPr>
-        </p:nvSpPr>
-        <p:spPr>
-          <a:xfrm>
-            <a:off x="685800" y="4400550"/>
-            <a:ext cx="5486400" cy="3600450"/>
-          </a:xfrm>
-          <a:prstGeom prst="rect">
-            <a:avLst/>
-          </a:prstGeom>
-        </p:spPr>
-        <p:txBody>
-          <a:bodyPr vert="horz" lIns="91440" tIns="45720" rIns="91440" bIns="45720" rtlCol="0"/>
-          <a:lstStyle/>
-          <a:p>
-            <a:pPr lvl="0"/>
-            <a:r>
-              <a:rPr lang="en-US"/>
-              <a:t>Click to edit Master text styles</a:t>
-            </a:r>
-          </a:p>
-          <a:p>
-            <a:pPr lvl="1"/>
-            <a:r>
-              <a:rPr lang="en-US"/>
-              <a:t>Second level</a:t>
-            </a:r>
-          </a:p>
-          <a:p>
-            <a:pPr lvl="2"/>
-            <a:r>
-              <a:rPr lang="en-US"/>
-              <a:t>Third level</a:t>
-            </a:r>
-          </a:p>
-          <a:p>
-            <a:pPr lvl="3"/>
-            <a:r>
-              <a:rPr lang="en-US"/>
-              <a:t>Fourth level</a:t>
-            </a:r>
-          </a:p>
-          <a:p>
-            <a:pPr lvl="4"/>
-            <a:r>
-              <a:rPr lang="en-US"/>
-              <a:t>Fifth level</a:t>
-            </a:r>
-          </a:p>
-        </p:txBody>
-      </p:sp>
-      <p:sp>
-        <p:nvSpPr>
-          <p:cNvPr id="6" name="Footer Placeholder 5"/>
-          <p:cNvSpPr>
-            <a:spLocks noGrp="1"/>
-          </p:cNvSpPr>
-          <p:nvPr>
-            <p:ph type="ftr" sz="quarter" idx="4"/>
-          </p:nvPr>
-        </p:nvSpPr>
-        <p:spPr>
-          <a:xfrm>
-            <a:off x="0" y="8685213"/>
-            <a:ext cx="2971800" cy="458787"/>
-          </a:xfrm>
-          <a:prstGeom prst="rect">
-            <a:avLst/>
-          </a:prstGeom>
-        </p:spPr>
-        <p:txBody>
-          <a:bodyPr vert="horz" lIns="91440" tIns="45720" rIns="91440" bIns="45720" rtlCol="0" anchor="b"/>
-          <a:lstStyle>
-            <a:lvl1pPr algn="l">
-              <a:defRPr sz="1200"/>
-            </a:lvl1pPr>
-          </a:lstStyle>
-          <a:p>
-            <a:endParaRPr lang="en-US"/>
-          </a:p>
-        </p:txBody>
-      </p:sp>
-      <p:sp>
-        <p:nvSpPr>
-          <p:cNvPr id="7" name="Slide Number Placeholder 6"/>
-          <p:cNvSpPr>
-            <a:spLocks noGrp="1"/>
-          </p:cNvSpPr>
-          <p:nvPr>
-            <p:ph type="sldNum" sz="quarter" idx="5"/>
-          </p:nvPr>
-        </p:nvSpPr>
-        <p:spPr>
-          <a:xfrm>
-            <a:off x="3884613" y="8685213"/>
-            <a:ext cx="2971800" cy="458787"/>
-          </a:xfrm>
-          <a:prstGeom prst="rect">
-            <a:avLst/>
-          </a:prstGeom>
-        </p:spPr>
-        <p:txBody>
-          <a:bodyPr vert="horz" lIns="91440" tIns="45720" rIns="91440" bIns="45720" rtlCol="0" anchor="b"/>
-          <a:lstStyle>
-            <a:lvl1pPr algn="r">
-              <a:defRPr sz="1200"/>
-            </a:lvl1pPr>
-          </a:lstStyle>
-          <a:p>
-            <a:fld id="{CE5E9CC1-C706-0F49-92D6-E571CC5EEA8F}" type="slidenum">
-              <a:rPr lang="en-US"/>
-              <a:t>‹#›</a:t>
-            </a:fld>
-            <a:endParaRPr lang="en-US"/>
-          </a:p>
-        </p:txBody>
-      </p:sp>
     </p:spTree>
     <p:extLst>
       <p:ext uri="{BB962C8B-B14F-4D97-AF65-F5344CB8AC3E}">
-        <p14:creationId xmlns:p14="http://schemas.microsoft.com/office/powerpoint/2010/main" val="1024086991"/>
+        <p14:creationId xmlns:p14="http://schemas.microsoft.com/office/powerpoint/2010/main" val="2477457968"/>
       </p:ext>
     </p:extLst>
   </p:cSld>
@@ -509,10 +290,6 @@
           <a:bodyPr/>
           <a:lstStyle/>
           <a:p>
-            <a:r>
-              <a:rPr lang="en-US" dirty="0"/>
-              <a:t/>
-            </a:r>
             <a:endParaRPr lang="en-US" dirty="0"/>
           </a:p>
         </p:txBody>
@@ -597,10 +374,6 @@
           <a:bodyPr/>
           <a:lstStyle/>
           <a:p>
-            <a:r>
-              <a:rPr lang="en-US" dirty="0"/>
-              <a:t/>
-            </a:r>
             <a:endParaRPr lang="en-US" dirty="0"/>
           </a:p>
         </p:txBody>
@@ -685,10 +458,6 @@
           <a:bodyPr/>
           <a:lstStyle/>
           <a:p>
-            <a:r>
-              <a:rPr lang="en-US" dirty="0"/>
-              <a:t/>
-            </a:r>
             <a:endParaRPr lang="en-US" dirty="0"/>
           </a:p>
         </p:txBody>
@@ -773,10 +542,6 @@
           <a:bodyPr/>
           <a:lstStyle/>
           <a:p>
-            <a:r>
-              <a:rPr lang="en-US" dirty="0"/>
-              <a:t/>
-            </a:r>
             <a:endParaRPr lang="en-US" dirty="0"/>
           </a:p>
         </p:txBody>
@@ -861,10 +626,6 @@
           <a:bodyPr/>
           <a:lstStyle/>
           <a:p>
-            <a:r>
-              <a:rPr lang="en-US" dirty="0"/>
-              <a:t/>
-            </a:r>
             <a:endParaRPr lang="en-US" dirty="0"/>
           </a:p>
         </p:txBody>
@@ -949,10 +710,6 @@
           <a:bodyPr/>
           <a:lstStyle/>
           <a:p>
-            <a:r>
-              <a:rPr lang="en-US" dirty="0"/>
-              <a:t/>
-            </a:r>
             <a:endParaRPr lang="en-US" dirty="0"/>
           </a:p>
         </p:txBody>
@@ -1037,10 +794,6 @@
           <a:bodyPr/>
           <a:lstStyle/>
           <a:p>
-            <a:r>
-              <a:rPr lang="en-US" dirty="0"/>
-              <a:t/>
-            </a:r>
             <a:endParaRPr lang="en-US" dirty="0"/>
           </a:p>
         </p:txBody>
@@ -1125,10 +878,6 @@
           <a:bodyPr/>
           <a:lstStyle/>
           <a:p>
-            <a:r>
-              <a:rPr lang="en-US" dirty="0"/>
-              <a:t/>
-            </a:r>
             <a:endParaRPr lang="en-US" dirty="0"/>
           </a:p>
         </p:txBody>
@@ -1213,10 +962,6 @@
           <a:bodyPr/>
           <a:lstStyle/>
           <a:p>
-            <a:r>
-              <a:rPr lang="en-US" dirty="0"/>
-              <a:t/>
-            </a:r>
             <a:endParaRPr lang="en-US" dirty="0"/>
           </a:p>
         </p:txBody>
@@ -1301,10 +1046,6 @@
           <a:bodyPr/>
           <a:lstStyle/>
           <a:p>
-            <a:r>
-              <a:rPr lang="en-US" dirty="0"/>
-              <a:t/>
-            </a:r>
             <a:endParaRPr lang="en-US" dirty="0"/>
           </a:p>
         </p:txBody>
@@ -1378,6 +1119,11 @@
 <file path=ppt/slideMasters/slideMaster1.xml><?xml version="1.0" encoding="utf-8"?>
 <p:sldMaster xmlns:a="http://schemas.openxmlformats.org/drawingml/2006/main" xmlns:r="http://schemas.openxmlformats.org/officeDocument/2006/relationships" xmlns:p="http://schemas.openxmlformats.org/presentationml/2006/main">
   <p:cSld>
+    <p:bg>
+      <p:bgRef idx="1001">
+        <a:schemeClr val="bg1"/>
+      </p:bgRef>
+    </p:bg>
     <p:spTree>
       <p:nvGrpSpPr>
         <p:cNvPr id="1" name=""/>
@@ -1660,6 +1406,7 @@
         <a:solidFill>
           <a:srgbClr val="0B132B"/>
         </a:solidFill>
+        <a:effectLst/>
       </p:bgPr>
     </p:bg>
     <p:spTree>
@@ -1684,20 +1431,20 @@
         </p:nvSpPr>
         <p:spPr>
           <a:xfrm>
-            <a:off x="731520" y="1097280"/>
-            <a:ext cx="10515600" cy="365760"/>
-          </a:xfrm>
-          <a:prstGeom prst="rect">
-            <a:avLst/>
-          </a:prstGeom>
-          <a:noFill/>
-          <a:ln/>
-        </p:spPr>
-        <p:txBody>
-          <a:bodyPr wrap="square" rtlCol="0" anchor="ctr"/>
-          <a:lstStyle/>
-          <a:p>
-            <a:pPr indent="0" marL="0">
+            <a:off x="603360" y="538380"/>
+            <a:ext cx="7937280" cy="365760"/>
+          </a:xfrm>
+          <a:prstGeom prst="rect">
+            <a:avLst/>
+          </a:prstGeom>
+          <a:noFill/>
+          <a:ln/>
+        </p:spPr>
+        <p:txBody>
+          <a:bodyPr wrap="square" rtlCol="0" anchor="ctr"/>
+          <a:lstStyle/>
+          <a:p>
+            <a:pPr marL="0" indent="0" algn="ctr">
               <a:buNone/>
             </a:pPr>
             <a:r>
@@ -1723,20 +1470,20 @@
         </p:nvSpPr>
         <p:spPr>
           <a:xfrm>
-            <a:off x="731520" y="1554480"/>
-            <a:ext cx="10515600" cy="1097280"/>
-          </a:xfrm>
-          <a:prstGeom prst="rect">
-            <a:avLst/>
-          </a:prstGeom>
-          <a:noFill/>
-          <a:ln/>
-        </p:spPr>
-        <p:txBody>
-          <a:bodyPr wrap="square" rtlCol="0" anchor="ctr"/>
-          <a:lstStyle/>
-          <a:p>
-            <a:pPr indent="0" marL="0">
+            <a:off x="693360" y="838755"/>
+            <a:ext cx="7757280" cy="1097280"/>
+          </a:xfrm>
+          <a:prstGeom prst="rect">
+            <a:avLst/>
+          </a:prstGeom>
+          <a:noFill/>
+          <a:ln/>
+        </p:spPr>
+        <p:txBody>
+          <a:bodyPr wrap="square" rtlCol="0" anchor="ctr"/>
+          <a:lstStyle/>
+          <a:p>
+            <a:pPr marL="0" indent="0" algn="ctr">
               <a:buNone/>
             </a:pPr>
             <a:r>
@@ -1762,20 +1509,20 @@
         </p:nvSpPr>
         <p:spPr>
           <a:xfrm>
-            <a:off x="731520" y="2743200"/>
-            <a:ext cx="10515600" cy="457200"/>
-          </a:xfrm>
-          <a:prstGeom prst="rect">
-            <a:avLst/>
-          </a:prstGeom>
-          <a:noFill/>
-          <a:ln/>
-        </p:spPr>
-        <p:txBody>
-          <a:bodyPr wrap="square" rtlCol="0" anchor="ctr"/>
-          <a:lstStyle/>
-          <a:p>
-            <a:pPr indent="0" marL="0">
+            <a:off x="612000" y="1764720"/>
+            <a:ext cx="8297280" cy="457200"/>
+          </a:xfrm>
+          <a:prstGeom prst="rect">
+            <a:avLst/>
+          </a:prstGeom>
+          <a:noFill/>
+          <a:ln/>
+        </p:spPr>
+        <p:txBody>
+          <a:bodyPr wrap="square" rtlCol="0" anchor="ctr"/>
+          <a:lstStyle/>
+          <a:p>
+            <a:pPr marL="0" indent="0" algn="ctr">
               <a:buNone/>
             </a:pPr>
             <a:r>
@@ -1801,8 +1548,8 @@
         </p:nvSpPr>
         <p:spPr>
           <a:xfrm>
-            <a:off x="731520" y="3657600"/>
-            <a:ext cx="10515600" cy="2011680"/>
+            <a:off x="488160" y="2475000"/>
+            <a:ext cx="8167680" cy="2011680"/>
           </a:xfrm>
           <a:prstGeom prst="rect">
             <a:avLst/>
@@ -1817,6 +1564,14 @@
             <a:prstDash val="solid"/>
           </a:ln>
         </p:spPr>
+        <p:txBody>
+          <a:bodyPr/>
+          <a:lstStyle/>
+          <a:p>
+            <a:pPr algn="ctr"/>
+            <a:endParaRPr lang="en-US"/>
+          </a:p>
+        </p:txBody>
       </p:sp>
       <p:sp>
         <p:nvSpPr>
@@ -1826,7 +1581,7 @@
         </p:nvSpPr>
         <p:spPr>
           <a:xfrm>
-            <a:off x="1097280" y="3931920"/>
+            <a:off x="2286000" y="2761560"/>
             <a:ext cx="4572000" cy="274320"/>
           </a:xfrm>
           <a:prstGeom prst="rect">
@@ -1839,7 +1594,7 @@
           <a:bodyPr wrap="square" rtlCol="0" anchor="ctr"/>
           <a:lstStyle/>
           <a:p>
-            <a:pPr indent="0" marL="0">
+            <a:pPr marL="0" indent="0" algn="ctr">
               <a:buNone/>
             </a:pPr>
             <a:r>
@@ -1865,20 +1620,20 @@
         </p:nvSpPr>
         <p:spPr>
           <a:xfrm>
-            <a:off x="1097280" y="4297680"/>
-            <a:ext cx="9144000" cy="457200"/>
-          </a:xfrm>
-          <a:prstGeom prst="rect">
-            <a:avLst/>
-          </a:prstGeom>
-          <a:noFill/>
-          <a:ln/>
-        </p:spPr>
-        <p:txBody>
-          <a:bodyPr wrap="square" rtlCol="0" anchor="ctr"/>
-          <a:lstStyle/>
-          <a:p>
-            <a:pPr indent="0" marL="0">
+            <a:off x="908640" y="3223890"/>
+            <a:ext cx="7326720" cy="457200"/>
+          </a:xfrm>
+          <a:prstGeom prst="rect">
+            <a:avLst/>
+          </a:prstGeom>
+          <a:noFill/>
+          <a:ln/>
+        </p:spPr>
+        <p:txBody>
+          <a:bodyPr wrap="square" rtlCol="0" anchor="ctr"/>
+          <a:lstStyle/>
+          <a:p>
+            <a:pPr marL="0" indent="0" algn="ctr">
               <a:buNone/>
             </a:pPr>
             <a:r>
@@ -1904,20 +1659,20 @@
         </p:nvSpPr>
         <p:spPr>
           <a:xfrm>
-            <a:off x="1097280" y="4846320"/>
-            <a:ext cx="9144000" cy="365760"/>
-          </a:xfrm>
-          <a:prstGeom prst="rect">
-            <a:avLst/>
-          </a:prstGeom>
-          <a:noFill/>
-          <a:ln/>
-        </p:spPr>
-        <p:txBody>
-          <a:bodyPr wrap="square" rtlCol="0" anchor="ctr"/>
-          <a:lstStyle/>
-          <a:p>
-            <a:pPr indent="0" marL="0">
+            <a:off x="567360" y="3867840"/>
+            <a:ext cx="8009280" cy="365760"/>
+          </a:xfrm>
+          <a:prstGeom prst="rect">
+            <a:avLst/>
+          </a:prstGeom>
+          <a:noFill/>
+          <a:ln/>
+        </p:spPr>
+        <p:txBody>
+          <a:bodyPr wrap="square" rtlCol="0" anchor="ctr"/>
+          <a:lstStyle/>
+          <a:p>
+            <a:pPr marL="0" indent="0" algn="ctr">
               <a:buNone/>
             </a:pPr>
             <a:r>
@@ -1951,6 +1706,7 @@
         <a:solidFill>
           <a:srgbClr val="0B132B"/>
         </a:solidFill>
+        <a:effectLst/>
       </p:bgPr>
     </p:bg>
     <p:spTree>
@@ -1988,7 +1744,7 @@
           <a:bodyPr wrap="square" rtlCol="0" anchor="ctr"/>
           <a:lstStyle/>
           <a:p>
-            <a:pPr indent="0" marL="0">
+            <a:pPr marL="0" indent="0">
               <a:buNone/>
             </a:pPr>
             <a:r>
@@ -2027,7 +1783,7 @@
           <a:bodyPr wrap="square" rtlCol="0" anchor="ctr"/>
           <a:lstStyle/>
           <a:p>
-            <a:pPr indent="0" marL="0">
+            <a:pPr marL="0" indent="0">
               <a:buNone/>
             </a:pPr>
             <a:r>
@@ -2069,6 +1825,13 @@
             <a:prstDash val="solid"/>
           </a:ln>
         </p:spPr>
+        <p:txBody>
+          <a:bodyPr/>
+          <a:lstStyle/>
+          <a:p>
+            <a:endParaRPr lang="en-US"/>
+          </a:p>
+        </p:txBody>
       </p:sp>
       <p:sp>
         <p:nvSpPr>
@@ -2091,7 +1854,7 @@
           <a:bodyPr wrap="square" rtlCol="0" anchor="ctr"/>
           <a:lstStyle/>
           <a:p>
-            <a:pPr indent="0" marL="0">
+            <a:pPr marL="0" indent="0">
               <a:buNone/>
             </a:pPr>
             <a:r>
@@ -2130,7 +1893,7 @@
           <a:bodyPr wrap="square" rtlCol="0" anchor="ctr"/>
           <a:lstStyle/>
           <a:p>
-            <a:pPr indent="0" marL="0">
+            <a:pPr marL="0" indent="0">
               <a:buNone/>
             </a:pPr>
             <a:r>
@@ -2172,6 +1935,13 @@
             <a:prstDash val="solid"/>
           </a:ln>
         </p:spPr>
+        <p:txBody>
+          <a:bodyPr/>
+          <a:lstStyle/>
+          <a:p>
+            <a:endParaRPr lang="en-US"/>
+          </a:p>
+        </p:txBody>
       </p:sp>
       <p:sp>
         <p:nvSpPr>
@@ -2194,7 +1964,7 @@
           <a:bodyPr wrap="square" rtlCol="0" anchor="ctr"/>
           <a:lstStyle/>
           <a:p>
-            <a:pPr indent="0" marL="0">
+            <a:pPr marL="0" indent="0">
               <a:buNone/>
             </a:pPr>
             <a:r>
@@ -2233,7 +2003,7 @@
           <a:bodyPr wrap="square" rtlCol="0" anchor="ctr"/>
           <a:lstStyle/>
           <a:p>
-            <a:pPr indent="0" marL="0">
+            <a:pPr marL="0" indent="0">
               <a:buNone/>
             </a:pPr>
             <a:r>
@@ -2275,6 +2045,13 @@
             <a:prstDash val="solid"/>
           </a:ln>
         </p:spPr>
+        <p:txBody>
+          <a:bodyPr/>
+          <a:lstStyle/>
+          <a:p>
+            <a:endParaRPr lang="en-US"/>
+          </a:p>
+        </p:txBody>
       </p:sp>
       <p:sp>
         <p:nvSpPr>
@@ -2297,7 +2074,7 @@
           <a:bodyPr wrap="square" rtlCol="0" anchor="ctr"/>
           <a:lstStyle/>
           <a:p>
-            <a:pPr indent="0" marL="0">
+            <a:pPr marL="0" indent="0">
               <a:buNone/>
             </a:pPr>
             <a:r>
@@ -2336,7 +2113,7 @@
           <a:bodyPr wrap="square" rtlCol="0" anchor="ctr"/>
           <a:lstStyle/>
           <a:p>
-            <a:pPr indent="0" marL="0">
+            <a:pPr marL="0" indent="0">
               <a:buNone/>
             </a:pPr>
             <a:r>
@@ -2375,7 +2152,7 @@
           <a:bodyPr wrap="square" rtlCol="0" anchor="ctr"/>
           <a:lstStyle/>
           <a:p>
-            <a:pPr algn="ctr" indent="0" marL="0">
+            <a:pPr marL="0" indent="0" algn="ctr">
               <a:buNone/>
             </a:pPr>
             <a:r>
@@ -2409,6 +2186,7 @@
         <a:solidFill>
           <a:srgbClr val="0B132B"/>
         </a:solidFill>
+        <a:effectLst/>
       </p:bgPr>
     </p:bg>
     <p:spTree>
@@ -2427,92 +2205,20 @@
       </p:grpSpPr>
       <p:sp>
         <p:nvSpPr>
-          <p:cNvPr id="2" name="Text 0"/>
-          <p:cNvSpPr/>
-          <p:nvPr/>
-        </p:nvSpPr>
-        <p:spPr>
-          <a:xfrm>
-            <a:off x="731520" y="365760"/>
-            <a:ext cx="7315200" cy="274320"/>
-          </a:xfrm>
-          <a:prstGeom prst="rect">
-            <a:avLst/>
-          </a:prstGeom>
-          <a:noFill/>
-          <a:ln/>
-        </p:spPr>
-        <p:txBody>
-          <a:bodyPr wrap="square" rtlCol="0" anchor="ctr"/>
-          <a:lstStyle/>
-          <a:p>
-            <a:pPr indent="0" marL="0">
-              <a:buNone/>
-            </a:pPr>
-            <a:r>
-              <a:rPr lang="en-US" sz="1000" b="1" dirty="0">
-                <a:solidFill>
-                  <a:srgbClr val="38BDF8"/>
-                </a:solidFill>
-                <a:latin typeface="Arial" pitchFamily="34" charset="0"/>
-                <a:ea typeface="Arial" pitchFamily="34" charset="-122"/>
-                <a:cs typeface="Arial" pitchFamily="34" charset="-120"/>
-              </a:rPr>
-              <a:t>PROBLEM BACKGROUND</a:t>
-            </a:r>
-            <a:endParaRPr lang="en-US" sz="1000" dirty="0"/>
-          </a:p>
-        </p:txBody>
-      </p:sp>
-      <p:sp>
-        <p:nvSpPr>
-          <p:cNvPr id="3" name="Text 1"/>
-          <p:cNvSpPr/>
-          <p:nvPr/>
-        </p:nvSpPr>
-        <p:spPr>
-          <a:xfrm>
-            <a:off x="731520" y="640080"/>
-            <a:ext cx="10515600" cy="548640"/>
-          </a:xfrm>
-          <a:prstGeom prst="rect">
-            <a:avLst/>
-          </a:prstGeom>
-          <a:noFill/>
-          <a:ln/>
-        </p:spPr>
-        <p:txBody>
-          <a:bodyPr wrap="square" rtlCol="0" anchor="ctr"/>
-          <a:lstStyle/>
-          <a:p>
-            <a:pPr indent="0" marL="0">
-              <a:buNone/>
-            </a:pPr>
-            <a:r>
-              <a:rPr lang="en-US" sz="2200" b="1" dirty="0">
-                <a:solidFill>
-                  <a:srgbClr val="F8FAFC"/>
-                </a:solidFill>
-                <a:latin typeface="Arial" pitchFamily="34" charset="0"/>
-                <a:ea typeface="Arial" pitchFamily="34" charset="-122"/>
-                <a:cs typeface="Arial" pitchFamily="34" charset="-120"/>
-              </a:rPr>
-              <a:t>The International Tuition Remittance Challenge</a:t>
-            </a:r>
-            <a:endParaRPr lang="en-US" sz="2200" dirty="0"/>
-          </a:p>
-        </p:txBody>
-      </p:sp>
-      <p:sp>
-        <p:nvSpPr>
-          <p:cNvPr id="4" name="Shape 2"/>
-          <p:cNvSpPr/>
-          <p:nvPr/>
-        </p:nvSpPr>
-        <p:spPr>
-          <a:xfrm>
-            <a:off x="731520" y="1463040"/>
-            <a:ext cx="3291840" cy="4389120"/>
+          <p:cNvPr id="16" name="Shape 2">
+            <a:extLst>
+              <a:ext uri="{FF2B5EF4-FFF2-40B4-BE49-F238E27FC236}">
+                <a16:creationId xmlns:a16="http://schemas.microsoft.com/office/drawing/2014/main" id="{078546F0-57EA-FCCD-D08A-99E178B35490}"/>
+              </a:ext>
+            </a:extLst>
+          </p:cNvPr>
+          <p:cNvSpPr/>
+          <p:nvPr/>
+        </p:nvSpPr>
+        <p:spPr>
+          <a:xfrm>
+            <a:off x="5975280" y="1656361"/>
+            <a:ext cx="2630880" cy="3121379"/>
           </a:xfrm>
           <a:prstGeom prst="rect">
             <a:avLst/>
@@ -2527,95 +2233,30 @@
             <a:prstDash val="solid"/>
           </a:ln>
         </p:spPr>
-      </p:sp>
-      <p:sp>
-        <p:nvSpPr>
-          <p:cNvPr id="5" name="Text 3"/>
-          <p:cNvSpPr/>
-          <p:nvPr/>
-        </p:nvSpPr>
-        <p:spPr>
-          <a:xfrm>
-            <a:off x="1005840" y="1737360"/>
-            <a:ext cx="2743200" cy="365760"/>
-          </a:xfrm>
-          <a:prstGeom prst="rect">
-            <a:avLst/>
-          </a:prstGeom>
-          <a:noFill/>
-          <a:ln/>
-        </p:spPr>
-        <p:txBody>
-          <a:bodyPr wrap="square" rtlCol="0" anchor="ctr"/>
-          <a:lstStyle/>
-          <a:p>
-            <a:pPr indent="0" marL="0">
-              <a:buNone/>
-            </a:pPr>
-            <a:r>
-              <a:rPr lang="en-US" sz="1600" b="1" dirty="0">
-                <a:solidFill>
-                  <a:srgbClr val="F59E0B"/>
-                </a:solidFill>
-                <a:latin typeface="Arial" pitchFamily="34" charset="0"/>
-                <a:ea typeface="Arial" pitchFamily="34" charset="-122"/>
-                <a:cs typeface="Arial" pitchFamily="34" charset="-120"/>
-              </a:rPr>
-              <a:t>Opaque FX Markups</a:t>
-            </a:r>
-            <a:endParaRPr lang="en-US" sz="1600" dirty="0"/>
-          </a:p>
-        </p:txBody>
-      </p:sp>
-      <p:sp>
-        <p:nvSpPr>
-          <p:cNvPr id="6" name="Text 4"/>
-          <p:cNvSpPr/>
-          <p:nvPr/>
-        </p:nvSpPr>
-        <p:spPr>
-          <a:xfrm>
-            <a:off x="1005840" y="2286000"/>
-            <a:ext cx="2743200" cy="3200400"/>
-          </a:xfrm>
-          <a:prstGeom prst="rect">
-            <a:avLst/>
-          </a:prstGeom>
-          <a:noFill/>
-          <a:ln/>
-        </p:spPr>
-        <p:txBody>
-          <a:bodyPr wrap="square" rtlCol="0" anchor="ctr"/>
-          <a:lstStyle/>
-          <a:p>
-            <a:pPr indent="0" marL="0">
-              <a:buNone/>
-            </a:pPr>
-            <a:r>
-              <a:rPr lang="en-US" sz="1300" dirty="0">
-                <a:solidFill>
-                  <a:srgbClr val="94A3B8"/>
-                </a:solidFill>
-                <a:latin typeface="Arial" pitchFamily="34" charset="0"/>
-                <a:ea typeface="Arial" pitchFamily="34" charset="-122"/>
-                <a:cs typeface="Arial" pitchFamily="34" charset="-120"/>
-              </a:rPr>
-              <a:t>Banks advertise low upfront fees but conceal 2%–5% exchange rate markups in the BDT/USD conversion rate, costing families tens of thousands of extra BDT each semester.</a:t>
-            </a:r>
-            <a:endParaRPr lang="en-US" sz="1300" dirty="0"/>
-          </a:p>
-        </p:txBody>
-      </p:sp>
-      <p:sp>
-        <p:nvSpPr>
-          <p:cNvPr id="7" name="Shape 5"/>
-          <p:cNvSpPr/>
-          <p:nvPr/>
-        </p:nvSpPr>
-        <p:spPr>
-          <a:xfrm>
-            <a:off x="4389120" y="1463040"/>
-            <a:ext cx="3291840" cy="4389120"/>
+        <p:txBody>
+          <a:bodyPr/>
+          <a:lstStyle/>
+          <a:p>
+            <a:endParaRPr lang="en-US"/>
+          </a:p>
+        </p:txBody>
+      </p:sp>
+      <p:sp>
+        <p:nvSpPr>
+          <p:cNvPr id="14" name="Shape 2">
+            <a:extLst>
+              <a:ext uri="{FF2B5EF4-FFF2-40B4-BE49-F238E27FC236}">
+                <a16:creationId xmlns:a16="http://schemas.microsoft.com/office/drawing/2014/main" id="{F29982FB-C641-6C78-A921-E8911BB8E56D}"/>
+              </a:ext>
+            </a:extLst>
+          </p:cNvPr>
+          <p:cNvSpPr/>
+          <p:nvPr/>
+        </p:nvSpPr>
+        <p:spPr>
+          <a:xfrm>
+            <a:off x="3192000" y="1656361"/>
+            <a:ext cx="2630880" cy="3121379"/>
           </a:xfrm>
           <a:prstGeom prst="rect">
             <a:avLst/>
@@ -2630,95 +2271,102 @@
             <a:prstDash val="solid"/>
           </a:ln>
         </p:spPr>
-      </p:sp>
-      <p:sp>
-        <p:nvSpPr>
-          <p:cNvPr id="8" name="Text 6"/>
-          <p:cNvSpPr/>
-          <p:nvPr/>
-        </p:nvSpPr>
-        <p:spPr>
-          <a:xfrm>
-            <a:off x="4663440" y="1737360"/>
-            <a:ext cx="2743200" cy="365760"/>
-          </a:xfrm>
-          <a:prstGeom prst="rect">
-            <a:avLst/>
-          </a:prstGeom>
-          <a:noFill/>
-          <a:ln/>
-        </p:spPr>
-        <p:txBody>
-          <a:bodyPr wrap="square" rtlCol="0" anchor="ctr"/>
-          <a:lstStyle/>
-          <a:p>
-            <a:pPr indent="0" marL="0">
-              <a:buNone/>
-            </a:pPr>
-            <a:r>
-              <a:rPr lang="en-US" sz="1600" b="1" dirty="0">
-                <a:solidFill>
-                  <a:srgbClr val="EF4444"/>
-                </a:solidFill>
-                <a:latin typeface="Arial" pitchFamily="34" charset="0"/>
-                <a:ea typeface="Arial" pitchFamily="34" charset="-122"/>
-                <a:cs typeface="Arial" pitchFamily="34" charset="-120"/>
-              </a:rPr>
-              <a:t>Intermediary Wire Delays</a:t>
-            </a:r>
-            <a:endParaRPr lang="en-US" sz="1600" dirty="0"/>
-          </a:p>
-        </p:txBody>
-      </p:sp>
-      <p:sp>
-        <p:nvSpPr>
-          <p:cNvPr id="9" name="Text 7"/>
-          <p:cNvSpPr/>
-          <p:nvPr/>
-        </p:nvSpPr>
-        <p:spPr>
-          <a:xfrm>
-            <a:off x="4663440" y="2286000"/>
-            <a:ext cx="2743200" cy="3200400"/>
-          </a:xfrm>
-          <a:prstGeom prst="rect">
-            <a:avLst/>
-          </a:prstGeom>
-          <a:noFill/>
-          <a:ln/>
-        </p:spPr>
-        <p:txBody>
-          <a:bodyPr wrap="square" rtlCol="0" anchor="ctr"/>
-          <a:lstStyle/>
-          <a:p>
-            <a:pPr indent="0" marL="0">
-              <a:buNone/>
-            </a:pPr>
-            <a:r>
-              <a:rPr lang="en-US" sz="1300" dirty="0">
-                <a:solidFill>
-                  <a:srgbClr val="94A3B8"/>
-                </a:solidFill>
-                <a:latin typeface="Arial" pitchFamily="34" charset="0"/>
-                <a:ea typeface="Arial" pitchFamily="34" charset="-122"/>
-                <a:cs typeface="Arial" pitchFamily="34" charset="-120"/>
-              </a:rPr>
-              <a:t>Traditional SWIFT wire transfers pass through multiple correspondent banks, taking 3 to 5 business days and triggering university enrollment holds or late penalty fees.</a:t>
-            </a:r>
-            <a:endParaRPr lang="en-US" sz="1300" dirty="0"/>
-          </a:p>
-        </p:txBody>
-      </p:sp>
-      <p:sp>
-        <p:nvSpPr>
-          <p:cNvPr id="10" name="Shape 8"/>
-          <p:cNvSpPr/>
-          <p:nvPr/>
-        </p:nvSpPr>
-        <p:spPr>
-          <a:xfrm>
-            <a:off x="8046720" y="1463040"/>
-            <a:ext cx="3291840" cy="4389120"/>
+        <p:txBody>
+          <a:bodyPr/>
+          <a:lstStyle/>
+          <a:p>
+            <a:endParaRPr lang="en-US"/>
+          </a:p>
+        </p:txBody>
+      </p:sp>
+      <p:sp>
+        <p:nvSpPr>
+          <p:cNvPr id="2" name="Text 0"/>
+          <p:cNvSpPr/>
+          <p:nvPr/>
+        </p:nvSpPr>
+        <p:spPr>
+          <a:xfrm>
+            <a:off x="0" y="365760"/>
+            <a:ext cx="9144000" cy="274320"/>
+          </a:xfrm>
+          <a:prstGeom prst="rect">
+            <a:avLst/>
+          </a:prstGeom>
+          <a:noFill/>
+          <a:ln/>
+        </p:spPr>
+        <p:txBody>
+          <a:bodyPr wrap="square" rtlCol="0" anchor="ctr"/>
+          <a:lstStyle/>
+          <a:p>
+            <a:pPr marL="0" indent="0" algn="ctr">
+              <a:buNone/>
+            </a:pPr>
+            <a:r>
+              <a:rPr lang="en-US" sz="1000" b="1" dirty="0">
+                <a:solidFill>
+                  <a:srgbClr val="38BDF8"/>
+                </a:solidFill>
+                <a:latin typeface="Arial" pitchFamily="34" charset="0"/>
+                <a:ea typeface="Arial" pitchFamily="34" charset="-122"/>
+                <a:cs typeface="Arial" pitchFamily="34" charset="-120"/>
+              </a:rPr>
+              <a:t>PROBLEM BACKGROUND</a:t>
+            </a:r>
+            <a:endParaRPr lang="en-US" sz="1000" dirty="0"/>
+          </a:p>
+        </p:txBody>
+      </p:sp>
+      <p:sp>
+        <p:nvSpPr>
+          <p:cNvPr id="3" name="Text 1"/>
+          <p:cNvSpPr/>
+          <p:nvPr/>
+        </p:nvSpPr>
+        <p:spPr>
+          <a:xfrm>
+            <a:off x="0" y="725447"/>
+            <a:ext cx="9144000" cy="548640"/>
+          </a:xfrm>
+          <a:prstGeom prst="rect">
+            <a:avLst/>
+          </a:prstGeom>
+          <a:noFill/>
+          <a:ln/>
+        </p:spPr>
+        <p:txBody>
+          <a:bodyPr wrap="square" rtlCol="0" anchor="ctr"/>
+          <a:lstStyle/>
+          <a:p>
+            <a:pPr marL="0" indent="0" algn="ctr">
+              <a:buNone/>
+            </a:pPr>
+            <a:r>
+              <a:rPr lang="en-US" sz="2200" b="1" dirty="0">
+                <a:solidFill>
+                  <a:srgbClr val="F8FAFC"/>
+                </a:solidFill>
+                <a:latin typeface="Arial" pitchFamily="34" charset="0"/>
+                <a:ea typeface="Arial" pitchFamily="34" charset="-122"/>
+                <a:cs typeface="Arial" pitchFamily="34" charset="-120"/>
+              </a:rPr>
+              <a:t>The International Tuition Remittance Challenge</a:t>
+            </a:r>
+            <a:endParaRPr lang="en-US" sz="2200" dirty="0"/>
+          </a:p>
+        </p:txBody>
+      </p:sp>
+      <p:sp>
+        <p:nvSpPr>
+          <p:cNvPr id="4" name="Shape 2"/>
+          <p:cNvSpPr/>
+          <p:nvPr/>
+        </p:nvSpPr>
+        <p:spPr>
+          <a:xfrm>
+            <a:off x="408720" y="1656361"/>
+            <a:ext cx="2630880" cy="3121379"/>
           </a:xfrm>
           <a:prstGeom prst="rect">
             <a:avLst/>
@@ -2733,6 +2381,169 @@
             <a:prstDash val="solid"/>
           </a:ln>
         </p:spPr>
+        <p:txBody>
+          <a:bodyPr/>
+          <a:lstStyle/>
+          <a:p>
+            <a:endParaRPr lang="en-US"/>
+          </a:p>
+        </p:txBody>
+      </p:sp>
+      <p:sp>
+        <p:nvSpPr>
+          <p:cNvPr id="5" name="Text 3"/>
+          <p:cNvSpPr/>
+          <p:nvPr/>
+        </p:nvSpPr>
+        <p:spPr>
+          <a:xfrm>
+            <a:off x="408720" y="1987921"/>
+            <a:ext cx="2630880" cy="365760"/>
+          </a:xfrm>
+          <a:prstGeom prst="rect">
+            <a:avLst/>
+          </a:prstGeom>
+          <a:noFill/>
+          <a:ln/>
+        </p:spPr>
+        <p:txBody>
+          <a:bodyPr wrap="square" rtlCol="0" anchor="ctr"/>
+          <a:lstStyle/>
+          <a:p>
+            <a:pPr marL="0" indent="0" algn="ctr">
+              <a:buNone/>
+            </a:pPr>
+            <a:r>
+              <a:rPr lang="en-US" sz="1600" b="1" dirty="0">
+                <a:solidFill>
+                  <a:srgbClr val="F59E0B"/>
+                </a:solidFill>
+                <a:latin typeface="Arial" pitchFamily="34" charset="0"/>
+                <a:ea typeface="Arial" pitchFamily="34" charset="-122"/>
+                <a:cs typeface="Arial" pitchFamily="34" charset="-120"/>
+              </a:rPr>
+              <a:t>Opaque FX Markups</a:t>
+            </a:r>
+            <a:endParaRPr lang="en-US" sz="1600" dirty="0"/>
+          </a:p>
+        </p:txBody>
+      </p:sp>
+      <p:sp>
+        <p:nvSpPr>
+          <p:cNvPr id="6" name="Text 4"/>
+          <p:cNvSpPr/>
+          <p:nvPr/>
+        </p:nvSpPr>
+        <p:spPr>
+          <a:xfrm>
+            <a:off x="408720" y="2652120"/>
+            <a:ext cx="2630880" cy="2073239"/>
+          </a:xfrm>
+          <a:prstGeom prst="rect">
+            <a:avLst/>
+          </a:prstGeom>
+          <a:noFill/>
+          <a:ln/>
+        </p:spPr>
+        <p:txBody>
+          <a:bodyPr wrap="square" rtlCol="0" anchor="ctr"/>
+          <a:lstStyle/>
+          <a:p>
+            <a:pPr marL="0" indent="0" algn="just">
+              <a:buNone/>
+            </a:pPr>
+            <a:r>
+              <a:rPr lang="en-US" sz="1300" dirty="0">
+                <a:solidFill>
+                  <a:srgbClr val="94A3B8"/>
+                </a:solidFill>
+                <a:latin typeface="Arial" pitchFamily="34" charset="0"/>
+                <a:ea typeface="Arial" pitchFamily="34" charset="-122"/>
+                <a:cs typeface="Arial" pitchFamily="34" charset="-120"/>
+              </a:rPr>
+              <a:t>Banks advertise low upfront fees but conceal 2%–5% exchange rate markups in the BDT/USD conversion rate, costing families tens of thousands of extra BDT each semester.</a:t>
+            </a:r>
+            <a:endParaRPr lang="en-US" sz="1300" dirty="0"/>
+          </a:p>
+        </p:txBody>
+      </p:sp>
+      <p:sp>
+        <p:nvSpPr>
+          <p:cNvPr id="8" name="Text 6"/>
+          <p:cNvSpPr/>
+          <p:nvPr/>
+        </p:nvSpPr>
+        <p:spPr>
+          <a:xfrm>
+            <a:off x="3192000" y="1990081"/>
+            <a:ext cx="2630880" cy="365760"/>
+          </a:xfrm>
+          <a:prstGeom prst="rect">
+            <a:avLst/>
+          </a:prstGeom>
+          <a:noFill/>
+          <a:ln/>
+        </p:spPr>
+        <p:txBody>
+          <a:bodyPr wrap="square" rtlCol="0" anchor="ctr"/>
+          <a:lstStyle/>
+          <a:p>
+            <a:pPr marL="0" indent="0" algn="ctr">
+              <a:buNone/>
+            </a:pPr>
+            <a:r>
+              <a:rPr lang="en-US" sz="1600" b="1" dirty="0">
+                <a:solidFill>
+                  <a:srgbClr val="EF4444"/>
+                </a:solidFill>
+                <a:latin typeface="Arial" pitchFamily="34" charset="0"/>
+                <a:ea typeface="Arial" pitchFamily="34" charset="-122"/>
+                <a:cs typeface="Arial" pitchFamily="34" charset="-120"/>
+              </a:rPr>
+              <a:t>Intermediary Wire Delays</a:t>
+            </a:r>
+            <a:endParaRPr lang="en-US" sz="1600" dirty="0"/>
+          </a:p>
+        </p:txBody>
+      </p:sp>
+      <p:sp>
+        <p:nvSpPr>
+          <p:cNvPr id="9" name="Text 7"/>
+          <p:cNvSpPr/>
+          <p:nvPr/>
+        </p:nvSpPr>
+        <p:spPr>
+          <a:xfrm>
+            <a:off x="3192000" y="2571750"/>
+            <a:ext cx="2630880" cy="2205990"/>
+          </a:xfrm>
+          <a:prstGeom prst="rect">
+            <a:avLst/>
+          </a:prstGeom>
+          <a:noFill/>
+          <a:ln/>
+        </p:spPr>
+        <p:txBody>
+          <a:bodyPr wrap="square" rtlCol="0" anchor="ctr"/>
+          <a:lstStyle/>
+          <a:p>
+            <a:pPr marL="0" indent="0" algn="just">
+              <a:buNone/>
+            </a:pPr>
+            <a:r>
+              <a:rPr lang="en-US" sz="1300" dirty="0">
+                <a:solidFill>
+                  <a:srgbClr val="94A3B8"/>
+                </a:solidFill>
+                <a:latin typeface="Arial" pitchFamily="34" charset="0"/>
+                <a:ea typeface="Arial" pitchFamily="34" charset="-122"/>
+                <a:cs typeface="Arial" pitchFamily="34" charset="-120"/>
+              </a:rPr>
+              <a:t>Traditional SWIFT wire transfers pass through multiple correspondent banks, taking 3 to 5 business days and triggering university enrollment holds or late penalty fees.</a:t>
+            </a:r>
+            <a:endParaRPr lang="en-US" sz="1300" dirty="0"/>
+          </a:p>
+        </p:txBody>
       </p:sp>
       <p:sp>
         <p:nvSpPr>
@@ -2742,20 +2553,20 @@
         </p:nvSpPr>
         <p:spPr>
           <a:xfrm>
-            <a:off x="8321040" y="1737360"/>
-            <a:ext cx="2743200" cy="365760"/>
-          </a:xfrm>
-          <a:prstGeom prst="rect">
-            <a:avLst/>
-          </a:prstGeom>
-          <a:noFill/>
-          <a:ln/>
-        </p:spPr>
-        <p:txBody>
-          <a:bodyPr wrap="square" rtlCol="0" anchor="ctr"/>
-          <a:lstStyle/>
-          <a:p>
-            <a:pPr indent="0" marL="0">
+            <a:off x="5975280" y="1990081"/>
+            <a:ext cx="2630880" cy="365760"/>
+          </a:xfrm>
+          <a:prstGeom prst="rect">
+            <a:avLst/>
+          </a:prstGeom>
+          <a:noFill/>
+          <a:ln/>
+        </p:spPr>
+        <p:txBody>
+          <a:bodyPr wrap="square" rtlCol="0" anchor="ctr"/>
+          <a:lstStyle/>
+          <a:p>
+            <a:pPr marL="0" indent="0" algn="ctr">
               <a:buNone/>
             </a:pPr>
             <a:r>
@@ -2781,20 +2592,20 @@
         </p:nvSpPr>
         <p:spPr>
           <a:xfrm>
-            <a:off x="8321040" y="2286000"/>
-            <a:ext cx="2743200" cy="3200400"/>
-          </a:xfrm>
-          <a:prstGeom prst="rect">
-            <a:avLst/>
-          </a:prstGeom>
-          <a:noFill/>
-          <a:ln/>
-        </p:spPr>
-        <p:txBody>
-          <a:bodyPr wrap="square" rtlCol="0" anchor="ctr"/>
-          <a:lstStyle/>
-          <a:p>
-            <a:pPr indent="0" marL="0">
+            <a:off x="5975280" y="2571750"/>
+            <a:ext cx="2630880" cy="2205990"/>
+          </a:xfrm>
+          <a:prstGeom prst="rect">
+            <a:avLst/>
+          </a:prstGeom>
+          <a:noFill/>
+          <a:ln/>
+        </p:spPr>
+        <p:txBody>
+          <a:bodyPr wrap="square" rtlCol="0" anchor="ctr"/>
+          <a:lstStyle/>
+          <a:p>
+            <a:pPr marL="0" indent="0" algn="just">
               <a:buNone/>
             </a:pPr>
             <a:r>
@@ -2828,6 +2639,7 @@
         <a:solidFill>
           <a:srgbClr val="0B132B"/>
         </a:solidFill>
+        <a:effectLst/>
       </p:bgPr>
     </p:bg>
     <p:spTree>
@@ -2846,92 +2658,20 @@
       </p:grpSpPr>
       <p:sp>
         <p:nvSpPr>
-          <p:cNvPr id="2" name="Text 0"/>
-          <p:cNvSpPr/>
-          <p:nvPr/>
-        </p:nvSpPr>
-        <p:spPr>
-          <a:xfrm>
-            <a:off x="731520" y="365760"/>
-            <a:ext cx="7315200" cy="274320"/>
-          </a:xfrm>
-          <a:prstGeom prst="rect">
-            <a:avLst/>
-          </a:prstGeom>
-          <a:noFill/>
-          <a:ln/>
-        </p:spPr>
-        <p:txBody>
-          <a:bodyPr wrap="square" rtlCol="0" anchor="ctr"/>
-          <a:lstStyle/>
-          <a:p>
-            <a:pPr indent="0" marL="0">
-              <a:buNone/>
-            </a:pPr>
-            <a:r>
-              <a:rPr lang="en-US" sz="1000" b="1" dirty="0">
-                <a:solidFill>
-                  <a:srgbClr val="38BDF8"/>
-                </a:solidFill>
-                <a:latin typeface="Arial" pitchFamily="34" charset="0"/>
-                <a:ea typeface="Arial" pitchFamily="34" charset="-122"/>
-                <a:cs typeface="Arial" pitchFamily="34" charset="-120"/>
-              </a:rPr>
-              <a:t>INNOVATION &amp; ARCHITECTURE</a:t>
-            </a:r>
-            <a:endParaRPr lang="en-US" sz="1000" dirty="0"/>
-          </a:p>
-        </p:txBody>
-      </p:sp>
-      <p:sp>
-        <p:nvSpPr>
-          <p:cNvPr id="3" name="Text 1"/>
-          <p:cNvSpPr/>
-          <p:nvPr/>
-        </p:nvSpPr>
-        <p:spPr>
-          <a:xfrm>
-            <a:off x="731520" y="640080"/>
-            <a:ext cx="10515600" cy="548640"/>
-          </a:xfrm>
-          <a:prstGeom prst="rect">
-            <a:avLst/>
-          </a:prstGeom>
-          <a:noFill/>
-          <a:ln/>
-        </p:spPr>
-        <p:txBody>
-          <a:bodyPr wrap="square" rtlCol="0" anchor="ctr"/>
-          <a:lstStyle/>
-          <a:p>
-            <a:pPr indent="0" marL="0">
-              <a:buNone/>
-            </a:pPr>
-            <a:r>
-              <a:rPr lang="en-US" sz="2200" b="1" dirty="0">
-                <a:solidFill>
-                  <a:srgbClr val="F8FAFC"/>
-                </a:solidFill>
-                <a:latin typeface="Arial" pitchFamily="34" charset="0"/>
-                <a:ea typeface="Arial" pitchFamily="34" charset="-122"/>
-                <a:cs typeface="Arial" pitchFamily="34" charset="-120"/>
-              </a:rPr>
-              <a:t>Our Solution: Autonomous Tuition Payment Agent</a:t>
-            </a:r>
-            <a:endParaRPr lang="en-US" sz="2200" dirty="0"/>
-          </a:p>
-        </p:txBody>
-      </p:sp>
-      <p:sp>
-        <p:nvSpPr>
-          <p:cNvPr id="4" name="Shape 2"/>
-          <p:cNvSpPr/>
-          <p:nvPr/>
-        </p:nvSpPr>
-        <p:spPr>
-          <a:xfrm>
-            <a:off x="731520" y="1463040"/>
-            <a:ext cx="10607040" cy="1005840"/>
+          <p:cNvPr id="21" name="Shape 2">
+            <a:extLst>
+              <a:ext uri="{FF2B5EF4-FFF2-40B4-BE49-F238E27FC236}">
+                <a16:creationId xmlns:a16="http://schemas.microsoft.com/office/drawing/2014/main" id="{72C12C2F-D149-1D5D-0574-FA356DED0507}"/>
+              </a:ext>
+            </a:extLst>
+          </p:cNvPr>
+          <p:cNvSpPr/>
+          <p:nvPr/>
+        </p:nvSpPr>
+        <p:spPr>
+          <a:xfrm>
+            <a:off x="0" y="4111935"/>
+            <a:ext cx="9144000" cy="708660"/>
           </a:xfrm>
           <a:prstGeom prst="rect">
             <a:avLst/>
@@ -2946,95 +2686,30 @@
             <a:prstDash val="solid"/>
           </a:ln>
         </p:spPr>
-      </p:sp>
-      <p:sp>
-        <p:nvSpPr>
-          <p:cNvPr id="5" name="Text 3"/>
-          <p:cNvSpPr/>
-          <p:nvPr/>
-        </p:nvSpPr>
-        <p:spPr>
-          <a:xfrm>
-            <a:off x="1005840" y="1600200"/>
-            <a:ext cx="10058400" cy="320040"/>
-          </a:xfrm>
-          <a:prstGeom prst="rect">
-            <a:avLst/>
-          </a:prstGeom>
-          <a:noFill/>
-          <a:ln/>
-        </p:spPr>
-        <p:txBody>
-          <a:bodyPr wrap="square" rtlCol="0" anchor="ctr"/>
-          <a:lstStyle/>
-          <a:p>
-            <a:pPr indent="0" marL="0">
-              <a:buNone/>
-            </a:pPr>
-            <a:r>
-              <a:rPr lang="en-US" sz="1500" b="1" dirty="0">
-                <a:solidFill>
-                  <a:srgbClr val="38BDF8"/>
-                </a:solidFill>
-                <a:latin typeface="Arial" pitchFamily="34" charset="0"/>
-                <a:ea typeface="Arial" pitchFamily="34" charset="-122"/>
-                <a:cs typeface="Arial" pitchFamily="34" charset="-120"/>
-              </a:rPr>
-              <a:t>Multi-Objective Route Optimization</a:t>
-            </a:r>
-            <a:endParaRPr lang="en-US" sz="1500" dirty="0"/>
-          </a:p>
-        </p:txBody>
-      </p:sp>
-      <p:sp>
-        <p:nvSpPr>
-          <p:cNvPr id="6" name="Text 4"/>
-          <p:cNvSpPr/>
-          <p:nvPr/>
-        </p:nvSpPr>
-        <p:spPr>
-          <a:xfrm>
-            <a:off x="1005840" y="1920240"/>
-            <a:ext cx="10058400" cy="411480"/>
-          </a:xfrm>
-          <a:prstGeom prst="rect">
-            <a:avLst/>
-          </a:prstGeom>
-          <a:noFill/>
-          <a:ln/>
-        </p:spPr>
-        <p:txBody>
-          <a:bodyPr wrap="square" rtlCol="0" anchor="ctr"/>
-          <a:lstStyle/>
-          <a:p>
-            <a:pPr indent="0" marL="0">
-              <a:buNone/>
-            </a:pPr>
-            <a:r>
-              <a:rPr lang="en-US" sz="1200" dirty="0">
-                <a:solidFill>
-                  <a:srgbClr val="94A3B8"/>
-                </a:solidFill>
-                <a:latin typeface="Arial" pitchFamily="34" charset="0"/>
-                <a:ea typeface="Arial" pitchFamily="34" charset="-122"/>
-                <a:cs typeface="Arial" pitchFamily="34" charset="-120"/>
-              </a:rPr>
-              <a:t>Dynamically balances total landed cost (exchange markup + fees), delivery speed (hours), and corridor historical reliability score (0-100%).</a:t>
-            </a:r>
-            <a:endParaRPr lang="en-US" sz="1200" dirty="0"/>
-          </a:p>
-        </p:txBody>
-      </p:sp>
-      <p:sp>
-        <p:nvSpPr>
-          <p:cNvPr id="7" name="Shape 5"/>
-          <p:cNvSpPr/>
-          <p:nvPr/>
-        </p:nvSpPr>
-        <p:spPr>
-          <a:xfrm>
-            <a:off x="731520" y="2606040"/>
-            <a:ext cx="10607040" cy="1005840"/>
+        <p:txBody>
+          <a:bodyPr/>
+          <a:lstStyle/>
+          <a:p>
+            <a:endParaRPr lang="en-US"/>
+          </a:p>
+        </p:txBody>
+      </p:sp>
+      <p:sp>
+        <p:nvSpPr>
+          <p:cNvPr id="19" name="Shape 2">
+            <a:extLst>
+              <a:ext uri="{FF2B5EF4-FFF2-40B4-BE49-F238E27FC236}">
+                <a16:creationId xmlns:a16="http://schemas.microsoft.com/office/drawing/2014/main" id="{A1E25330-F0BA-AEDF-55D0-E876F8279F5E}"/>
+              </a:ext>
+            </a:extLst>
+          </p:cNvPr>
+          <p:cNvSpPr/>
+          <p:nvPr/>
+        </p:nvSpPr>
+        <p:spPr>
+          <a:xfrm>
+            <a:off x="0" y="3141705"/>
+            <a:ext cx="9144000" cy="708660"/>
           </a:xfrm>
           <a:prstGeom prst="rect">
             <a:avLst/>
@@ -3049,95 +2724,30 @@
             <a:prstDash val="solid"/>
           </a:ln>
         </p:spPr>
-      </p:sp>
-      <p:sp>
-        <p:nvSpPr>
-          <p:cNvPr id="8" name="Text 6"/>
-          <p:cNvSpPr/>
-          <p:nvPr/>
-        </p:nvSpPr>
-        <p:spPr>
-          <a:xfrm>
-            <a:off x="1005840" y="2743200"/>
-            <a:ext cx="10058400" cy="320040"/>
-          </a:xfrm>
-          <a:prstGeom prst="rect">
-            <a:avLst/>
-          </a:prstGeom>
-          <a:noFill/>
-          <a:ln/>
-        </p:spPr>
-        <p:txBody>
-          <a:bodyPr wrap="square" rtlCol="0" anchor="ctr"/>
-          <a:lstStyle/>
-          <a:p>
-            <a:pPr indent="0" marL="0">
-              <a:buNone/>
-            </a:pPr>
-            <a:r>
-              <a:rPr lang="en-US" sz="1500" b="1" dirty="0">
-                <a:solidFill>
-                  <a:srgbClr val="38BDF8"/>
-                </a:solidFill>
-                <a:latin typeface="Arial" pitchFamily="34" charset="0"/>
-                <a:ea typeface="Arial" pitchFamily="34" charset="-122"/>
-                <a:cs typeface="Arial" pitchFamily="34" charset="-120"/>
-              </a:rPr>
-              <a:t>Proactive Deadline Sentinel</a:t>
-            </a:r>
-            <a:endParaRPr lang="en-US" sz="1500" dirty="0"/>
-          </a:p>
-        </p:txBody>
-      </p:sp>
-      <p:sp>
-        <p:nvSpPr>
-          <p:cNvPr id="9" name="Text 7"/>
-          <p:cNvSpPr/>
-          <p:nvPr/>
-        </p:nvSpPr>
-        <p:spPr>
-          <a:xfrm>
-            <a:off x="1005840" y="3063240"/>
-            <a:ext cx="10058400" cy="411480"/>
-          </a:xfrm>
-          <a:prstGeom prst="rect">
-            <a:avLst/>
-          </a:prstGeom>
-          <a:noFill/>
-          <a:ln/>
-        </p:spPr>
-        <p:txBody>
-          <a:bodyPr wrap="square" rtlCol="0" anchor="ctr"/>
-          <a:lstStyle/>
-          <a:p>
-            <a:pPr indent="0" marL="0">
-              <a:buNone/>
-            </a:pPr>
-            <a:r>
-              <a:rPr lang="en-US" sz="1200" dirty="0">
-                <a:solidFill>
-                  <a:srgbClr val="94A3B8"/>
-                </a:solidFill>
-                <a:latin typeface="Arial" pitchFamily="34" charset="0"/>
-                <a:ea typeface="Arial" pitchFamily="34" charset="-122"/>
-                <a:cs typeface="Arial" pitchFamily="34" charset="-120"/>
-              </a:rPr>
-              <a:t>Calculates expected arrival dates against the university tuition invoice deadline, injecting urgent warnings when routes risk missing registration.</a:t>
-            </a:r>
-            <a:endParaRPr lang="en-US" sz="1200" dirty="0"/>
-          </a:p>
-        </p:txBody>
-      </p:sp>
-      <p:sp>
-        <p:nvSpPr>
-          <p:cNvPr id="10" name="Shape 8"/>
-          <p:cNvSpPr/>
-          <p:nvPr/>
-        </p:nvSpPr>
-        <p:spPr>
-          <a:xfrm>
-            <a:off x="731520" y="3749040"/>
-            <a:ext cx="10607040" cy="1005840"/>
+        <p:txBody>
+          <a:bodyPr/>
+          <a:lstStyle/>
+          <a:p>
+            <a:endParaRPr lang="en-US"/>
+          </a:p>
+        </p:txBody>
+      </p:sp>
+      <p:sp>
+        <p:nvSpPr>
+          <p:cNvPr id="17" name="Shape 2">
+            <a:extLst>
+              <a:ext uri="{FF2B5EF4-FFF2-40B4-BE49-F238E27FC236}">
+                <a16:creationId xmlns:a16="http://schemas.microsoft.com/office/drawing/2014/main" id="{9CBA6D69-5C81-6F91-E923-2AC5D75ABA67}"/>
+              </a:ext>
+            </a:extLst>
+          </p:cNvPr>
+          <p:cNvSpPr/>
+          <p:nvPr/>
+        </p:nvSpPr>
+        <p:spPr>
+          <a:xfrm>
+            <a:off x="0" y="2188815"/>
+            <a:ext cx="9144000" cy="708660"/>
           </a:xfrm>
           <a:prstGeom prst="rect">
             <a:avLst/>
@@ -3152,33 +2762,40 @@
             <a:prstDash val="solid"/>
           </a:ln>
         </p:spPr>
-      </p:sp>
-      <p:sp>
-        <p:nvSpPr>
-          <p:cNvPr id="11" name="Text 9"/>
-          <p:cNvSpPr/>
-          <p:nvPr/>
-        </p:nvSpPr>
-        <p:spPr>
-          <a:xfrm>
-            <a:off x="1005840" y="3886200"/>
-            <a:ext cx="10058400" cy="320040"/>
-          </a:xfrm>
-          <a:prstGeom prst="rect">
-            <a:avLst/>
-          </a:prstGeom>
-          <a:noFill/>
-          <a:ln/>
-        </p:spPr>
-        <p:txBody>
-          <a:bodyPr wrap="square" rtlCol="0" anchor="ctr"/>
-          <a:lstStyle/>
-          <a:p>
-            <a:pPr indent="0" marL="0">
-              <a:buNone/>
-            </a:pPr>
-            <a:r>
-              <a:rPr lang="en-US" sz="1500" b="1" dirty="0">
+        <p:txBody>
+          <a:bodyPr/>
+          <a:lstStyle/>
+          <a:p>
+            <a:endParaRPr lang="en-US"/>
+          </a:p>
+        </p:txBody>
+      </p:sp>
+      <p:sp>
+        <p:nvSpPr>
+          <p:cNvPr id="2" name="Text 0"/>
+          <p:cNvSpPr/>
+          <p:nvPr/>
+        </p:nvSpPr>
+        <p:spPr>
+          <a:xfrm>
+            <a:off x="0" y="259650"/>
+            <a:ext cx="9144000" cy="274320"/>
+          </a:xfrm>
+          <a:prstGeom prst="rect">
+            <a:avLst/>
+          </a:prstGeom>
+          <a:noFill/>
+          <a:ln/>
+        </p:spPr>
+        <p:txBody>
+          <a:bodyPr wrap="square" rtlCol="0" anchor="ctr"/>
+          <a:lstStyle/>
+          <a:p>
+            <a:pPr marL="0" indent="0" algn="ctr">
+              <a:buNone/>
+            </a:pPr>
+            <a:r>
+              <a:rPr lang="en-US" sz="1000" b="1" dirty="0">
                 <a:solidFill>
                   <a:srgbClr val="38BDF8"/>
                 </a:solidFill>
@@ -3186,61 +2803,61 @@
                 <a:ea typeface="Arial" pitchFamily="34" charset="-122"/>
                 <a:cs typeface="Arial" pitchFamily="34" charset="-120"/>
               </a:rPr>
-              <a:t>Tri-Tier Permission Safety System</a:t>
-            </a:r>
-            <a:endParaRPr lang="en-US" sz="1500" dirty="0"/>
-          </a:p>
-        </p:txBody>
-      </p:sp>
-      <p:sp>
-        <p:nvSpPr>
-          <p:cNvPr id="12" name="Text 10"/>
-          <p:cNvSpPr/>
-          <p:nvPr/>
-        </p:nvSpPr>
-        <p:spPr>
-          <a:xfrm>
-            <a:off x="1005840" y="4206240"/>
-            <a:ext cx="10058400" cy="411480"/>
-          </a:xfrm>
-          <a:prstGeom prst="rect">
-            <a:avLst/>
-          </a:prstGeom>
-          <a:noFill/>
-          <a:ln/>
-        </p:spPr>
-        <p:txBody>
-          <a:bodyPr wrap="square" rtlCol="0" anchor="ctr"/>
-          <a:lstStyle/>
-          <a:p>
-            <a:pPr indent="0" marL="0">
-              <a:buNone/>
-            </a:pPr>
-            <a:r>
-              <a:rPr lang="en-US" sz="1200" dirty="0">
-                <a:solidFill>
-                  <a:srgbClr val="94A3B8"/>
-                </a:solidFill>
-                <a:latin typeface="Arial" pitchFamily="34" charset="0"/>
-                <a:ea typeface="Arial" pitchFamily="34" charset="-122"/>
-                <a:cs typeface="Arial" pitchFamily="34" charset="-120"/>
-              </a:rPr>
-              <a:t>Enforces strict READ_ONLY, DRAFT, and EXECUTE tiers. Autonomous AI operates only in READ_ONLY/DRAFT; moving funds requires explicit human authorization.</a:t>
-            </a:r>
-            <a:endParaRPr lang="en-US" sz="1200" dirty="0"/>
-          </a:p>
-        </p:txBody>
-      </p:sp>
-      <p:sp>
-        <p:nvSpPr>
-          <p:cNvPr id="13" name="Shape 11"/>
-          <p:cNvSpPr/>
-          <p:nvPr/>
-        </p:nvSpPr>
-        <p:spPr>
-          <a:xfrm>
-            <a:off x="731520" y="4892040"/>
-            <a:ext cx="10607040" cy="1005840"/>
+              <a:t>INNOVATION &amp; ARCHITECTURE</a:t>
+            </a:r>
+            <a:endParaRPr lang="en-US" sz="1000" dirty="0"/>
+          </a:p>
+        </p:txBody>
+      </p:sp>
+      <p:sp>
+        <p:nvSpPr>
+          <p:cNvPr id="3" name="Text 1"/>
+          <p:cNvSpPr/>
+          <p:nvPr/>
+        </p:nvSpPr>
+        <p:spPr>
+          <a:xfrm>
+            <a:off x="0" y="527265"/>
+            <a:ext cx="9144000" cy="548640"/>
+          </a:xfrm>
+          <a:prstGeom prst="rect">
+            <a:avLst/>
+          </a:prstGeom>
+          <a:noFill/>
+          <a:ln/>
+        </p:spPr>
+        <p:txBody>
+          <a:bodyPr wrap="square" rtlCol="0" anchor="ctr"/>
+          <a:lstStyle/>
+          <a:p>
+            <a:pPr marL="0" indent="0" algn="ctr">
+              <a:buNone/>
+            </a:pPr>
+            <a:r>
+              <a:rPr lang="en-US" sz="2200" b="1" dirty="0">
+                <a:solidFill>
+                  <a:srgbClr val="F8FAFC"/>
+                </a:solidFill>
+                <a:latin typeface="Arial" pitchFamily="34" charset="0"/>
+                <a:ea typeface="Arial" pitchFamily="34" charset="-122"/>
+                <a:cs typeface="Arial" pitchFamily="34" charset="-120"/>
+              </a:rPr>
+              <a:t>Our Solution: Autonomous Tuition Payment Agent</a:t>
+            </a:r>
+            <a:endParaRPr lang="en-US" sz="2200" dirty="0"/>
+          </a:p>
+        </p:txBody>
+      </p:sp>
+      <p:sp>
+        <p:nvSpPr>
+          <p:cNvPr id="4" name="Shape 2"/>
+          <p:cNvSpPr/>
+          <p:nvPr/>
+        </p:nvSpPr>
+        <p:spPr>
+          <a:xfrm>
+            <a:off x="0" y="1224495"/>
+            <a:ext cx="9144000" cy="708660"/>
           </a:xfrm>
           <a:prstGeom prst="rect">
             <a:avLst/>
@@ -3255,6 +2872,247 @@
             <a:prstDash val="solid"/>
           </a:ln>
         </p:spPr>
+        <p:txBody>
+          <a:bodyPr/>
+          <a:lstStyle/>
+          <a:p>
+            <a:endParaRPr lang="en-US"/>
+          </a:p>
+        </p:txBody>
+      </p:sp>
+      <p:sp>
+        <p:nvSpPr>
+          <p:cNvPr id="5" name="Text 3"/>
+          <p:cNvSpPr/>
+          <p:nvPr/>
+        </p:nvSpPr>
+        <p:spPr>
+          <a:xfrm>
+            <a:off x="0" y="1224495"/>
+            <a:ext cx="9144000" cy="320040"/>
+          </a:xfrm>
+          <a:prstGeom prst="rect">
+            <a:avLst/>
+          </a:prstGeom>
+          <a:noFill/>
+          <a:ln/>
+        </p:spPr>
+        <p:txBody>
+          <a:bodyPr wrap="square" rtlCol="0" anchor="ctr"/>
+          <a:lstStyle/>
+          <a:p>
+            <a:pPr marL="0" indent="0">
+              <a:buNone/>
+            </a:pPr>
+            <a:r>
+              <a:rPr lang="en-US" sz="1500" b="1" dirty="0">
+                <a:solidFill>
+                  <a:srgbClr val="38BDF8"/>
+                </a:solidFill>
+                <a:latin typeface="Arial" pitchFamily="34" charset="0"/>
+                <a:ea typeface="Arial" pitchFamily="34" charset="-122"/>
+                <a:cs typeface="Arial" pitchFamily="34" charset="-120"/>
+              </a:rPr>
+              <a:t>Multi-Objective Route Optimization</a:t>
+            </a:r>
+            <a:endParaRPr lang="en-US" sz="1500" dirty="0"/>
+          </a:p>
+        </p:txBody>
+      </p:sp>
+      <p:sp>
+        <p:nvSpPr>
+          <p:cNvPr id="6" name="Text 4"/>
+          <p:cNvSpPr/>
+          <p:nvPr/>
+        </p:nvSpPr>
+        <p:spPr>
+          <a:xfrm>
+            <a:off x="0" y="1521675"/>
+            <a:ext cx="9144000" cy="411480"/>
+          </a:xfrm>
+          <a:prstGeom prst="rect">
+            <a:avLst/>
+          </a:prstGeom>
+          <a:noFill/>
+          <a:ln/>
+        </p:spPr>
+        <p:txBody>
+          <a:bodyPr wrap="square" rtlCol="0" anchor="ctr"/>
+          <a:lstStyle/>
+          <a:p>
+            <a:pPr marL="0" indent="0">
+              <a:buNone/>
+            </a:pPr>
+            <a:r>
+              <a:rPr lang="en-US" sz="1200" dirty="0">
+                <a:solidFill>
+                  <a:srgbClr val="94A3B8"/>
+                </a:solidFill>
+                <a:latin typeface="Arial" pitchFamily="34" charset="0"/>
+                <a:ea typeface="Arial" pitchFamily="34" charset="-122"/>
+                <a:cs typeface="Arial" pitchFamily="34" charset="-120"/>
+              </a:rPr>
+              <a:t>Dynamically balances total landed cost (exchange markup + fees), delivery speed (hours), and corridor historical reliability score (0-100%).</a:t>
+            </a:r>
+            <a:endParaRPr lang="en-US" sz="1200" dirty="0"/>
+          </a:p>
+        </p:txBody>
+      </p:sp>
+      <p:sp>
+        <p:nvSpPr>
+          <p:cNvPr id="8" name="Text 6"/>
+          <p:cNvSpPr/>
+          <p:nvPr/>
+        </p:nvSpPr>
+        <p:spPr>
+          <a:xfrm>
+            <a:off x="0" y="2177385"/>
+            <a:ext cx="9144000" cy="320040"/>
+          </a:xfrm>
+          <a:prstGeom prst="rect">
+            <a:avLst/>
+          </a:prstGeom>
+          <a:noFill/>
+          <a:ln/>
+        </p:spPr>
+        <p:txBody>
+          <a:bodyPr wrap="square" rtlCol="0" anchor="ctr"/>
+          <a:lstStyle/>
+          <a:p>
+            <a:pPr marL="0" indent="0">
+              <a:buNone/>
+            </a:pPr>
+            <a:r>
+              <a:rPr lang="en-US" sz="1500" b="1" dirty="0">
+                <a:solidFill>
+                  <a:srgbClr val="38BDF8"/>
+                </a:solidFill>
+                <a:latin typeface="Arial" pitchFamily="34" charset="0"/>
+                <a:ea typeface="Arial" pitchFamily="34" charset="-122"/>
+                <a:cs typeface="Arial" pitchFamily="34" charset="-120"/>
+              </a:rPr>
+              <a:t>Proactive Deadline Sentinel</a:t>
+            </a:r>
+            <a:endParaRPr lang="en-US" sz="1500" dirty="0"/>
+          </a:p>
+        </p:txBody>
+      </p:sp>
+      <p:sp>
+        <p:nvSpPr>
+          <p:cNvPr id="9" name="Text 7"/>
+          <p:cNvSpPr/>
+          <p:nvPr/>
+        </p:nvSpPr>
+        <p:spPr>
+          <a:xfrm>
+            <a:off x="0" y="2466375"/>
+            <a:ext cx="9144000" cy="411480"/>
+          </a:xfrm>
+          <a:prstGeom prst="rect">
+            <a:avLst/>
+          </a:prstGeom>
+          <a:noFill/>
+          <a:ln/>
+        </p:spPr>
+        <p:txBody>
+          <a:bodyPr wrap="square" rtlCol="0" anchor="ctr"/>
+          <a:lstStyle/>
+          <a:p>
+            <a:pPr marL="0" indent="0">
+              <a:buNone/>
+            </a:pPr>
+            <a:r>
+              <a:rPr lang="en-US" sz="1200" dirty="0">
+                <a:solidFill>
+                  <a:srgbClr val="94A3B8"/>
+                </a:solidFill>
+                <a:latin typeface="Arial" pitchFamily="34" charset="0"/>
+                <a:ea typeface="Arial" pitchFamily="34" charset="-122"/>
+                <a:cs typeface="Arial" pitchFamily="34" charset="-120"/>
+              </a:rPr>
+              <a:t>Calculates expected arrival dates against the university tuition invoice deadline, injecting urgent warnings when routes risk missing registration.</a:t>
+            </a:r>
+            <a:endParaRPr lang="en-US" sz="1200" dirty="0"/>
+          </a:p>
+        </p:txBody>
+      </p:sp>
+      <p:sp>
+        <p:nvSpPr>
+          <p:cNvPr id="11" name="Text 9"/>
+          <p:cNvSpPr/>
+          <p:nvPr/>
+        </p:nvSpPr>
+        <p:spPr>
+          <a:xfrm>
+            <a:off x="0" y="3153795"/>
+            <a:ext cx="9144000" cy="320040"/>
+          </a:xfrm>
+          <a:prstGeom prst="rect">
+            <a:avLst/>
+          </a:prstGeom>
+          <a:noFill/>
+          <a:ln/>
+        </p:spPr>
+        <p:txBody>
+          <a:bodyPr wrap="square" rtlCol="0" anchor="ctr"/>
+          <a:lstStyle/>
+          <a:p>
+            <a:pPr marL="0" indent="0">
+              <a:buNone/>
+            </a:pPr>
+            <a:r>
+              <a:rPr lang="en-US" sz="1500" b="1" dirty="0">
+                <a:solidFill>
+                  <a:srgbClr val="38BDF8"/>
+                </a:solidFill>
+                <a:latin typeface="Arial" pitchFamily="34" charset="0"/>
+                <a:ea typeface="Arial" pitchFamily="34" charset="-122"/>
+                <a:cs typeface="Arial" pitchFamily="34" charset="-120"/>
+              </a:rPr>
+              <a:t>Tri-Tier Permission Safety System</a:t>
+            </a:r>
+            <a:endParaRPr lang="en-US" sz="1500" dirty="0"/>
+          </a:p>
+        </p:txBody>
+      </p:sp>
+      <p:sp>
+        <p:nvSpPr>
+          <p:cNvPr id="12" name="Text 10"/>
+          <p:cNvSpPr/>
+          <p:nvPr/>
+        </p:nvSpPr>
+        <p:spPr>
+          <a:xfrm>
+            <a:off x="0" y="3450975"/>
+            <a:ext cx="9144000" cy="411480"/>
+          </a:xfrm>
+          <a:prstGeom prst="rect">
+            <a:avLst/>
+          </a:prstGeom>
+          <a:noFill/>
+          <a:ln/>
+        </p:spPr>
+        <p:txBody>
+          <a:bodyPr wrap="square" rtlCol="0" anchor="ctr"/>
+          <a:lstStyle/>
+          <a:p>
+            <a:pPr marL="0" indent="0">
+              <a:buNone/>
+            </a:pPr>
+            <a:r>
+              <a:rPr lang="en-US" sz="1200" dirty="0">
+                <a:solidFill>
+                  <a:srgbClr val="94A3B8"/>
+                </a:solidFill>
+                <a:latin typeface="Arial" pitchFamily="34" charset="0"/>
+                <a:ea typeface="Arial" pitchFamily="34" charset="-122"/>
+                <a:cs typeface="Arial" pitchFamily="34" charset="-120"/>
+              </a:rPr>
+              <a:t>Enforces strict READ_ONLY, DRAFT, and EXECUTE tiers. Autonomous AI operates only in READ_ONLY/DRAFT; moving funds requires explicit human authorization.</a:t>
+            </a:r>
+            <a:endParaRPr lang="en-US" sz="1200" dirty="0"/>
+          </a:p>
+        </p:txBody>
       </p:sp>
       <p:sp>
         <p:nvSpPr>
@@ -3264,20 +3122,20 @@
         </p:nvSpPr>
         <p:spPr>
           <a:xfrm>
-            <a:off x="1005840" y="5029200"/>
-            <a:ext cx="10058400" cy="320040"/>
-          </a:xfrm>
-          <a:prstGeom prst="rect">
-            <a:avLst/>
-          </a:prstGeom>
-          <a:noFill/>
-          <a:ln/>
-        </p:spPr>
-        <p:txBody>
-          <a:bodyPr wrap="square" rtlCol="0" anchor="ctr"/>
-          <a:lstStyle/>
-          <a:p>
-            <a:pPr indent="0" marL="0">
+            <a:off x="0" y="4106685"/>
+            <a:ext cx="9144000" cy="320040"/>
+          </a:xfrm>
+          <a:prstGeom prst="rect">
+            <a:avLst/>
+          </a:prstGeom>
+          <a:noFill/>
+          <a:ln/>
+        </p:spPr>
+        <p:txBody>
+          <a:bodyPr wrap="square" rtlCol="0" anchor="ctr"/>
+          <a:lstStyle/>
+          <a:p>
+            <a:pPr marL="0" indent="0">
               <a:buNone/>
             </a:pPr>
             <a:r>
@@ -3303,20 +3161,20 @@
         </p:nvSpPr>
         <p:spPr>
           <a:xfrm>
-            <a:off x="1005840" y="5349240"/>
-            <a:ext cx="10058400" cy="411480"/>
-          </a:xfrm>
-          <a:prstGeom prst="rect">
-            <a:avLst/>
-          </a:prstGeom>
-          <a:noFill/>
-          <a:ln/>
-        </p:spPr>
-        <p:txBody>
-          <a:bodyPr wrap="square" rtlCol="0" anchor="ctr"/>
-          <a:lstStyle/>
-          <a:p>
-            <a:pPr indent="0" marL="0">
+            <a:off x="0" y="4407570"/>
+            <a:ext cx="9144000" cy="411480"/>
+          </a:xfrm>
+          <a:prstGeom prst="rect">
+            <a:avLst/>
+          </a:prstGeom>
+          <a:noFill/>
+          <a:ln/>
+        </p:spPr>
+        <p:txBody>
+          <a:bodyPr wrap="square" rtlCol="0" anchor="ctr"/>
+          <a:lstStyle/>
+          <a:p>
+            <a:pPr marL="0" indent="0">
               <a:buNone/>
             </a:pPr>
             <a:r>
@@ -3350,6 +3208,7 @@
         <a:solidFill>
           <a:srgbClr val="0B132B"/>
         </a:solidFill>
+        <a:effectLst/>
       </p:bgPr>
     </p:bg>
     <p:spTree>
@@ -3387,7 +3246,7 @@
           <a:bodyPr wrap="square" rtlCol="0" anchor="ctr"/>
           <a:lstStyle/>
           <a:p>
-            <a:pPr indent="0" marL="0">
+            <a:pPr marL="0" indent="0">
               <a:buNone/>
             </a:pPr>
             <a:r>
@@ -3426,7 +3285,7 @@
           <a:bodyPr wrap="square" rtlCol="0" anchor="ctr"/>
           <a:lstStyle/>
           <a:p>
-            <a:pPr indent="0" marL="0">
+            <a:pPr marL="0" indent="0">
               <a:buNone/>
             </a:pPr>
             <a:r>
@@ -3468,6 +3327,13 @@
             <a:prstDash val="solid"/>
           </a:ln>
         </p:spPr>
+        <p:txBody>
+          <a:bodyPr/>
+          <a:lstStyle/>
+          <a:p>
+            <a:endParaRPr lang="en-US"/>
+          </a:p>
+        </p:txBody>
       </p:sp>
       <p:sp>
         <p:nvSpPr>
@@ -3490,7 +3356,7 @@
           <a:bodyPr wrap="square" rtlCol="0" anchor="ctr"/>
           <a:lstStyle/>
           <a:p>
-            <a:pPr indent="0" marL="0">
+            <a:pPr marL="0" indent="0">
               <a:buNone/>
             </a:pPr>
             <a:r>
@@ -3529,7 +3395,7 @@
           <a:bodyPr wrap="square" rtlCol="0" anchor="ctr"/>
           <a:lstStyle/>
           <a:p>
-            <a:pPr indent="0" marL="0">
+            <a:pPr marL="0" indent="0">
               <a:buNone/>
             </a:pPr>
             <a:r>
@@ -3568,7 +3434,7 @@
           <a:bodyPr wrap="square" rtlCol="0" anchor="ctr"/>
           <a:lstStyle/>
           <a:p>
-            <a:pPr indent="0" marL="0">
+            <a:pPr marL="0" indent="0">
               <a:buNone/>
             </a:pPr>
             <a:r>
@@ -3585,13 +3451,13 @@
             <a:endParaRPr lang="en-US" sz="1100" dirty="0"/>
           </a:p>
           <a:p>
-            <a:pPr indent="0" marL="0">
-              <a:buNone/>
-            </a:pPr>
-            <a:endParaRPr lang="en-US" sz="1100" dirty="0"/>
-          </a:p>
-          <a:p>
-            <a:pPr indent="0" marL="0">
+            <a:pPr marL="0" indent="0">
+              <a:buNone/>
+            </a:pPr>
+            <a:endParaRPr lang="en-US" sz="1100" dirty="0"/>
+          </a:p>
+          <a:p>
+            <a:pPr marL="0" indent="0">
               <a:buNone/>
             </a:pPr>
             <a:r>
@@ -3608,13 +3474,13 @@
             <a:endParaRPr lang="en-US" sz="1100" dirty="0"/>
           </a:p>
           <a:p>
-            <a:pPr indent="0" marL="0">
-              <a:buNone/>
-            </a:pPr>
-            <a:endParaRPr lang="en-US" sz="1100" dirty="0"/>
-          </a:p>
-          <a:p>
-            <a:pPr indent="0" marL="0">
+            <a:pPr marL="0" indent="0">
+              <a:buNone/>
+            </a:pPr>
+            <a:endParaRPr lang="en-US" sz="1100" dirty="0"/>
+          </a:p>
+          <a:p>
+            <a:pPr marL="0" indent="0">
               <a:buNone/>
             </a:pPr>
             <a:r>
@@ -3631,13 +3497,13 @@
             <a:endParaRPr lang="en-US" sz="1100" dirty="0"/>
           </a:p>
           <a:p>
-            <a:pPr indent="0" marL="0">
-              <a:buNone/>
-            </a:pPr>
-            <a:endParaRPr lang="en-US" sz="1100" dirty="0"/>
-          </a:p>
-          <a:p>
-            <a:pPr indent="0" marL="0">
+            <a:pPr marL="0" indent="0">
+              <a:buNone/>
+            </a:pPr>
+            <a:endParaRPr lang="en-US" sz="1100" dirty="0"/>
+          </a:p>
+          <a:p>
+            <a:pPr marL="0" indent="0">
               <a:buNone/>
             </a:pPr>
             <a:r>
@@ -3679,6 +3545,13 @@
             <a:prstDash val="solid"/>
           </a:ln>
         </p:spPr>
+        <p:txBody>
+          <a:bodyPr/>
+          <a:lstStyle/>
+          <a:p>
+            <a:endParaRPr lang="en-US"/>
+          </a:p>
+        </p:txBody>
       </p:sp>
       <p:sp>
         <p:nvSpPr>
@@ -3701,7 +3574,7 @@
           <a:bodyPr wrap="square" rtlCol="0" anchor="ctr"/>
           <a:lstStyle/>
           <a:p>
-            <a:pPr indent="0" marL="0">
+            <a:pPr marL="0" indent="0">
               <a:buNone/>
             </a:pPr>
             <a:r>
@@ -3740,7 +3613,7 @@
           <a:bodyPr wrap="square" rtlCol="0" anchor="ctr"/>
           <a:lstStyle/>
           <a:p>
-            <a:pPr indent="0" marL="0">
+            <a:pPr marL="0" indent="0">
               <a:buNone/>
             </a:pPr>
             <a:r>
@@ -3779,7 +3652,7 @@
           <a:bodyPr wrap="square" rtlCol="0" anchor="ctr"/>
           <a:lstStyle/>
           <a:p>
-            <a:pPr indent="0" marL="0">
+            <a:pPr marL="0" indent="0">
               <a:buNone/>
             </a:pPr>
             <a:r>
@@ -3796,13 +3669,13 @@
             <a:endParaRPr lang="en-US" sz="1100" dirty="0"/>
           </a:p>
           <a:p>
-            <a:pPr indent="0" marL="0">
-              <a:buNone/>
-            </a:pPr>
-            <a:endParaRPr lang="en-US" sz="1100" dirty="0"/>
-          </a:p>
-          <a:p>
-            <a:pPr indent="0" marL="0">
+            <a:pPr marL="0" indent="0">
+              <a:buNone/>
+            </a:pPr>
+            <a:endParaRPr lang="en-US" sz="1100" dirty="0"/>
+          </a:p>
+          <a:p>
+            <a:pPr marL="0" indent="0">
               <a:buNone/>
             </a:pPr>
             <a:r>
@@ -3819,13 +3692,13 @@
             <a:endParaRPr lang="en-US" sz="1100" dirty="0"/>
           </a:p>
           <a:p>
-            <a:pPr indent="0" marL="0">
-              <a:buNone/>
-            </a:pPr>
-            <a:endParaRPr lang="en-US" sz="1100" dirty="0"/>
-          </a:p>
-          <a:p>
-            <a:pPr indent="0" marL="0">
+            <a:pPr marL="0" indent="0">
+              <a:buNone/>
+            </a:pPr>
+            <a:endParaRPr lang="en-US" sz="1100" dirty="0"/>
+          </a:p>
+          <a:p>
+            <a:pPr marL="0" indent="0">
               <a:buNone/>
             </a:pPr>
             <a:r>
@@ -3842,13 +3715,13 @@
             <a:endParaRPr lang="en-US" sz="1100" dirty="0"/>
           </a:p>
           <a:p>
-            <a:pPr indent="0" marL="0">
-              <a:buNone/>
-            </a:pPr>
-            <a:endParaRPr lang="en-US" sz="1100" dirty="0"/>
-          </a:p>
-          <a:p>
-            <a:pPr indent="0" marL="0">
+            <a:pPr marL="0" indent="0">
+              <a:buNone/>
+            </a:pPr>
+            <a:endParaRPr lang="en-US" sz="1100" dirty="0"/>
+          </a:p>
+          <a:p>
+            <a:pPr marL="0" indent="0">
               <a:buNone/>
             </a:pPr>
             <a:r>
@@ -3890,6 +3763,13 @@
             <a:prstDash val="solid"/>
           </a:ln>
         </p:spPr>
+        <p:txBody>
+          <a:bodyPr/>
+          <a:lstStyle/>
+          <a:p>
+            <a:endParaRPr lang="en-US"/>
+          </a:p>
+        </p:txBody>
       </p:sp>
       <p:sp>
         <p:nvSpPr>
@@ -3912,7 +3792,7 @@
           <a:bodyPr wrap="square" rtlCol="0" anchor="ctr"/>
           <a:lstStyle/>
           <a:p>
-            <a:pPr indent="0" marL="0">
+            <a:pPr marL="0" indent="0">
               <a:buNone/>
             </a:pPr>
             <a:r>
@@ -3951,7 +3831,7 @@
           <a:bodyPr wrap="square" rtlCol="0" anchor="ctr"/>
           <a:lstStyle/>
           <a:p>
-            <a:pPr indent="0" marL="0">
+            <a:pPr marL="0" indent="0">
               <a:buNone/>
             </a:pPr>
             <a:r>
@@ -3990,7 +3870,7 @@
           <a:bodyPr wrap="square" rtlCol="0" anchor="ctr"/>
           <a:lstStyle/>
           <a:p>
-            <a:pPr indent="0" marL="0">
+            <a:pPr marL="0" indent="0">
               <a:buNone/>
             </a:pPr>
             <a:r>
@@ -4007,13 +3887,13 @@
             <a:endParaRPr lang="en-US" sz="1100" dirty="0"/>
           </a:p>
           <a:p>
-            <a:pPr indent="0" marL="0">
-              <a:buNone/>
-            </a:pPr>
-            <a:endParaRPr lang="en-US" sz="1100" dirty="0"/>
-          </a:p>
-          <a:p>
-            <a:pPr indent="0" marL="0">
+            <a:pPr marL="0" indent="0">
+              <a:buNone/>
+            </a:pPr>
+            <a:endParaRPr lang="en-US" sz="1100" dirty="0"/>
+          </a:p>
+          <a:p>
+            <a:pPr marL="0" indent="0">
               <a:buNone/>
             </a:pPr>
             <a:r>
@@ -4030,13 +3910,13 @@
             <a:endParaRPr lang="en-US" sz="1100" dirty="0"/>
           </a:p>
           <a:p>
-            <a:pPr indent="0" marL="0">
-              <a:buNone/>
-            </a:pPr>
-            <a:endParaRPr lang="en-US" sz="1100" dirty="0"/>
-          </a:p>
-          <a:p>
-            <a:pPr indent="0" marL="0">
+            <a:pPr marL="0" indent="0">
+              <a:buNone/>
+            </a:pPr>
+            <a:endParaRPr lang="en-US" sz="1100" dirty="0"/>
+          </a:p>
+          <a:p>
+            <a:pPr marL="0" indent="0">
               <a:buNone/>
             </a:pPr>
             <a:r>
@@ -4053,13 +3933,13 @@
             <a:endParaRPr lang="en-US" sz="1100" dirty="0"/>
           </a:p>
           <a:p>
-            <a:pPr indent="0" marL="0">
-              <a:buNone/>
-            </a:pPr>
-            <a:endParaRPr lang="en-US" sz="1100" dirty="0"/>
-          </a:p>
-          <a:p>
-            <a:pPr indent="0" marL="0">
+            <a:pPr marL="0" indent="0">
+              <a:buNone/>
+            </a:pPr>
+            <a:endParaRPr lang="en-US" sz="1100" dirty="0"/>
+          </a:p>
+          <a:p>
+            <a:pPr marL="0" indent="0">
               <a:buNone/>
             </a:pPr>
             <a:r>
@@ -4101,6 +3981,13 @@
             <a:prstDash val="solid"/>
           </a:ln>
         </p:spPr>
+        <p:txBody>
+          <a:bodyPr/>
+          <a:lstStyle/>
+          <a:p>
+            <a:endParaRPr lang="en-US"/>
+          </a:p>
+        </p:txBody>
       </p:sp>
       <p:sp>
         <p:nvSpPr>
@@ -4123,7 +4010,7 @@
           <a:bodyPr wrap="square" rtlCol="0" anchor="ctr"/>
           <a:lstStyle/>
           <a:p>
-            <a:pPr indent="0" marL="0">
+            <a:pPr marL="0" indent="0">
               <a:buNone/>
             </a:pPr>
             <a:r>
@@ -4162,7 +4049,7 @@
           <a:bodyPr wrap="square" rtlCol="0" anchor="ctr"/>
           <a:lstStyle/>
           <a:p>
-            <a:pPr indent="0" marL="0">
+            <a:pPr marL="0" indent="0">
               <a:buNone/>
             </a:pPr>
             <a:r>
@@ -4201,7 +4088,7 @@
           <a:bodyPr wrap="square" rtlCol="0" anchor="ctr"/>
           <a:lstStyle/>
           <a:p>
-            <a:pPr indent="0" marL="0">
+            <a:pPr marL="0" indent="0">
               <a:buNone/>
             </a:pPr>
             <a:r>
@@ -4218,13 +4105,13 @@
             <a:endParaRPr lang="en-US" sz="1100" dirty="0"/>
           </a:p>
           <a:p>
-            <a:pPr indent="0" marL="0">
-              <a:buNone/>
-            </a:pPr>
-            <a:endParaRPr lang="en-US" sz="1100" dirty="0"/>
-          </a:p>
-          <a:p>
-            <a:pPr indent="0" marL="0">
+            <a:pPr marL="0" indent="0">
+              <a:buNone/>
+            </a:pPr>
+            <a:endParaRPr lang="en-US" sz="1100" dirty="0"/>
+          </a:p>
+          <a:p>
+            <a:pPr marL="0" indent="0">
               <a:buNone/>
             </a:pPr>
             <a:r>
@@ -4241,13 +4128,13 @@
             <a:endParaRPr lang="en-US" sz="1100" dirty="0"/>
           </a:p>
           <a:p>
-            <a:pPr indent="0" marL="0">
-              <a:buNone/>
-            </a:pPr>
-            <a:endParaRPr lang="en-US" sz="1100" dirty="0"/>
-          </a:p>
-          <a:p>
-            <a:pPr indent="0" marL="0">
+            <a:pPr marL="0" indent="0">
+              <a:buNone/>
+            </a:pPr>
+            <a:endParaRPr lang="en-US" sz="1100" dirty="0"/>
+          </a:p>
+          <a:p>
+            <a:pPr marL="0" indent="0">
               <a:buNone/>
             </a:pPr>
             <a:r>
@@ -4264,13 +4151,13 @@
             <a:endParaRPr lang="en-US" sz="1100" dirty="0"/>
           </a:p>
           <a:p>
-            <a:pPr indent="0" marL="0">
-              <a:buNone/>
-            </a:pPr>
-            <a:endParaRPr lang="en-US" sz="1100" dirty="0"/>
-          </a:p>
-          <a:p>
-            <a:pPr indent="0" marL="0">
+            <a:pPr marL="0" indent="0">
+              <a:buNone/>
+            </a:pPr>
+            <a:endParaRPr lang="en-US" sz="1100" dirty="0"/>
+          </a:p>
+          <a:p>
+            <a:pPr marL="0" indent="0">
               <a:buNone/>
             </a:pPr>
             <a:r>
@@ -4304,6 +4191,7 @@
         <a:solidFill>
           <a:srgbClr val="0B132B"/>
         </a:solidFill>
+        <a:effectLst/>
       </p:bgPr>
     </p:bg>
     <p:spTree>
@@ -4341,7 +4229,7 @@
           <a:bodyPr wrap="square" rtlCol="0" anchor="ctr"/>
           <a:lstStyle/>
           <a:p>
-            <a:pPr indent="0" marL="0">
+            <a:pPr marL="0" indent="0">
               <a:buNone/>
             </a:pPr>
             <a:r>
@@ -4380,7 +4268,7 @@
           <a:bodyPr wrap="square" rtlCol="0" anchor="ctr"/>
           <a:lstStyle/>
           <a:p>
-            <a:pPr indent="0" marL="0">
+            <a:pPr marL="0" indent="0">
               <a:buNone/>
             </a:pPr>
             <a:r>
@@ -4422,6 +4310,13 @@
             <a:prstDash val="solid"/>
           </a:ln>
         </p:spPr>
+        <p:txBody>
+          <a:bodyPr/>
+          <a:lstStyle/>
+          <a:p>
+            <a:endParaRPr lang="en-US"/>
+          </a:p>
+        </p:txBody>
       </p:sp>
       <p:sp>
         <p:nvSpPr>
@@ -4444,7 +4339,7 @@
           <a:bodyPr wrap="square" rtlCol="0" anchor="ctr"/>
           <a:lstStyle/>
           <a:p>
-            <a:pPr indent="0" marL="0">
+            <a:pPr marL="0" indent="0">
               <a:buNone/>
             </a:pPr>
             <a:r>
@@ -4483,7 +4378,7 @@
           <a:bodyPr wrap="square" rtlCol="0" anchor="ctr"/>
           <a:lstStyle/>
           <a:p>
-            <a:pPr indent="0" marL="0">
+            <a:pPr marL="0" indent="0">
               <a:buNone/>
             </a:pPr>
             <a:r>
@@ -4522,7 +4417,7 @@
           <a:bodyPr wrap="square" rtlCol="0" anchor="ctr"/>
           <a:lstStyle/>
           <a:p>
-            <a:pPr indent="0" marL="0">
+            <a:pPr marL="0" indent="0">
               <a:buNone/>
             </a:pPr>
             <a:r>
@@ -4561,7 +4456,7 @@
           <a:bodyPr wrap="square" rtlCol="0" anchor="ctr"/>
           <a:lstStyle/>
           <a:p>
-            <a:pPr indent="0" marL="0">
+            <a:pPr marL="0" indent="0">
               <a:buNone/>
             </a:pPr>
             <a:r>
@@ -4603,6 +4498,13 @@
             <a:prstDash val="solid"/>
           </a:ln>
         </p:spPr>
+        <p:txBody>
+          <a:bodyPr/>
+          <a:lstStyle/>
+          <a:p>
+            <a:endParaRPr lang="en-US"/>
+          </a:p>
+        </p:txBody>
       </p:sp>
       <p:sp>
         <p:nvSpPr>
@@ -4625,7 +4527,7 @@
           <a:bodyPr wrap="square" rtlCol="0" anchor="ctr"/>
           <a:lstStyle/>
           <a:p>
-            <a:pPr indent="0" marL="0">
+            <a:pPr marL="0" indent="0">
               <a:buNone/>
             </a:pPr>
             <a:r>
@@ -4664,7 +4566,7 @@
           <a:bodyPr wrap="square" rtlCol="0" anchor="ctr"/>
           <a:lstStyle/>
           <a:p>
-            <a:pPr indent="0" marL="0">
+            <a:pPr marL="0" indent="0">
               <a:buNone/>
             </a:pPr>
             <a:r>
@@ -4703,7 +4605,7 @@
           <a:bodyPr wrap="square" rtlCol="0" anchor="ctr"/>
           <a:lstStyle/>
           <a:p>
-            <a:pPr indent="0" marL="0">
+            <a:pPr marL="0" indent="0">
               <a:buNone/>
             </a:pPr>
             <a:r>
@@ -4742,7 +4644,7 @@
           <a:bodyPr wrap="square" rtlCol="0" anchor="ctr"/>
           <a:lstStyle/>
           <a:p>
-            <a:pPr indent="0" marL="0">
+            <a:pPr marL="0" indent="0">
               <a:buNone/>
             </a:pPr>
             <a:r>
@@ -4784,6 +4686,13 @@
             <a:prstDash val="solid"/>
           </a:ln>
         </p:spPr>
+        <p:txBody>
+          <a:bodyPr/>
+          <a:lstStyle/>
+          <a:p>
+            <a:endParaRPr lang="en-US"/>
+          </a:p>
+        </p:txBody>
       </p:sp>
       <p:sp>
         <p:nvSpPr>
@@ -4806,7 +4715,7 @@
           <a:bodyPr wrap="square" rtlCol="0" anchor="ctr"/>
           <a:lstStyle/>
           <a:p>
-            <a:pPr indent="0" marL="0">
+            <a:pPr marL="0" indent="0">
               <a:buNone/>
             </a:pPr>
             <a:r>
@@ -4845,7 +4754,7 @@
           <a:bodyPr wrap="square" rtlCol="0" anchor="ctr"/>
           <a:lstStyle/>
           <a:p>
-            <a:pPr indent="0" marL="0">
+            <a:pPr marL="0" indent="0">
               <a:buNone/>
             </a:pPr>
             <a:r>
@@ -4884,7 +4793,7 @@
           <a:bodyPr wrap="square" rtlCol="0" anchor="ctr"/>
           <a:lstStyle/>
           <a:p>
-            <a:pPr indent="0" marL="0">
+            <a:pPr marL="0" indent="0">
               <a:buNone/>
             </a:pPr>
             <a:r>
@@ -4923,7 +4832,7 @@
           <a:bodyPr wrap="square" rtlCol="0" anchor="ctr"/>
           <a:lstStyle/>
           <a:p>
-            <a:pPr indent="0" marL="0">
+            <a:pPr marL="0" indent="0">
               <a:buNone/>
             </a:pPr>
             <a:r>
@@ -4957,6 +4866,7 @@
         <a:solidFill>
           <a:srgbClr val="0B132B"/>
         </a:solidFill>
+        <a:effectLst/>
       </p:bgPr>
     </p:bg>
     <p:spTree>
@@ -4994,7 +4904,7 @@
           <a:bodyPr wrap="square" rtlCol="0" anchor="ctr"/>
           <a:lstStyle/>
           <a:p>
-            <a:pPr indent="0" marL="0">
+            <a:pPr marL="0" indent="0">
               <a:buNone/>
             </a:pPr>
             <a:r>
@@ -5033,7 +4943,7 @@
           <a:bodyPr wrap="square" rtlCol="0" anchor="ctr"/>
           <a:lstStyle/>
           <a:p>
-            <a:pPr indent="0" marL="0">
+            <a:pPr marL="0" indent="0">
               <a:buNone/>
             </a:pPr>
             <a:r>
@@ -5075,6 +4985,13 @@
             <a:prstDash val="solid"/>
           </a:ln>
         </p:spPr>
+        <p:txBody>
+          <a:bodyPr/>
+          <a:lstStyle/>
+          <a:p>
+            <a:endParaRPr lang="en-US"/>
+          </a:p>
+        </p:txBody>
       </p:sp>
       <p:sp>
         <p:nvSpPr>
@@ -5097,7 +5014,7 @@
           <a:bodyPr wrap="square" rtlCol="0" anchor="ctr"/>
           <a:lstStyle/>
           <a:p>
-            <a:pPr indent="0" marL="0">
+            <a:pPr marL="0" indent="0">
               <a:buNone/>
             </a:pPr>
             <a:r>
@@ -5136,7 +5053,7 @@
           <a:bodyPr wrap="square" rtlCol="0" anchor="ctr"/>
           <a:lstStyle/>
           <a:p>
-            <a:pPr indent="0" marL="0">
+            <a:pPr marL="0" indent="0">
               <a:buNone/>
             </a:pPr>
             <a:r>
@@ -5178,6 +5095,13 @@
             <a:prstDash val="solid"/>
           </a:ln>
         </p:spPr>
+        <p:txBody>
+          <a:bodyPr/>
+          <a:lstStyle/>
+          <a:p>
+            <a:endParaRPr lang="en-US"/>
+          </a:p>
+        </p:txBody>
       </p:sp>
       <p:sp>
         <p:nvSpPr>
@@ -5200,7 +5124,7 @@
           <a:bodyPr wrap="square" rtlCol="0" anchor="ctr"/>
           <a:lstStyle/>
           <a:p>
-            <a:pPr indent="0" marL="0">
+            <a:pPr marL="0" indent="0">
               <a:buNone/>
             </a:pPr>
             <a:r>
@@ -5239,7 +5163,7 @@
           <a:bodyPr wrap="square" rtlCol="0" anchor="ctr"/>
           <a:lstStyle/>
           <a:p>
-            <a:pPr indent="0" marL="0">
+            <a:pPr marL="0" indent="0">
               <a:buNone/>
             </a:pPr>
             <a:r>
@@ -5278,7 +5202,7 @@
           <a:bodyPr wrap="square" rtlCol="0" anchor="ctr"/>
           <a:lstStyle/>
           <a:p>
-            <a:pPr indent="0" marL="0">
+            <a:pPr marL="0" indent="0">
               <a:buNone/>
             </a:pPr>
             <a:r>
@@ -5295,7 +5219,7 @@
             <a:endParaRPr lang="en-US" sz="1100" dirty="0"/>
           </a:p>
           <a:p>
-            <a:pPr indent="0" marL="0">
+            <a:pPr marL="0" indent="0">
               <a:buNone/>
             </a:pPr>
             <a:r>
@@ -5312,7 +5236,7 @@
             <a:endParaRPr lang="en-US" sz="1100" dirty="0"/>
           </a:p>
           <a:p>
-            <a:pPr indent="0" marL="0">
+            <a:pPr marL="0" indent="0">
               <a:buNone/>
             </a:pPr>
             <a:r>
@@ -5329,7 +5253,7 @@
             <a:endParaRPr lang="en-US" sz="1100" dirty="0"/>
           </a:p>
           <a:p>
-            <a:pPr indent="0" marL="0">
+            <a:pPr marL="0" indent="0">
               <a:buNone/>
             </a:pPr>
             <a:r>
@@ -5371,6 +5295,13 @@
             <a:prstDash val="solid"/>
           </a:ln>
         </p:spPr>
+        <p:txBody>
+          <a:bodyPr/>
+          <a:lstStyle/>
+          <a:p>
+            <a:endParaRPr lang="en-US"/>
+          </a:p>
+        </p:txBody>
       </p:sp>
       <p:sp>
         <p:nvSpPr>
@@ -5393,7 +5324,7 @@
           <a:bodyPr wrap="square" rtlCol="0" anchor="ctr"/>
           <a:lstStyle/>
           <a:p>
-            <a:pPr indent="0" marL="0">
+            <a:pPr marL="0" indent="0">
               <a:buNone/>
             </a:pPr>
             <a:r>
@@ -5432,7 +5363,7 @@
           <a:bodyPr wrap="square" rtlCol="0" anchor="ctr"/>
           <a:lstStyle/>
           <a:p>
-            <a:pPr indent="0" marL="0">
+            <a:pPr marL="0" indent="0">
               <a:buNone/>
             </a:pPr>
             <a:r>
@@ -5471,7 +5402,7 @@
           <a:bodyPr wrap="square" rtlCol="0" anchor="ctr"/>
           <a:lstStyle/>
           <a:p>
-            <a:pPr indent="0" marL="0">
+            <a:pPr marL="0" indent="0">
               <a:buNone/>
             </a:pPr>
             <a:r>
@@ -5488,7 +5419,7 @@
             <a:endParaRPr lang="en-US" sz="1100" dirty="0"/>
           </a:p>
           <a:p>
-            <a:pPr indent="0" marL="0">
+            <a:pPr marL="0" indent="0">
               <a:buNone/>
             </a:pPr>
             <a:r>
@@ -5505,7 +5436,7 @@
             <a:endParaRPr lang="en-US" sz="1100" dirty="0"/>
           </a:p>
           <a:p>
-            <a:pPr indent="0" marL="0">
+            <a:pPr marL="0" indent="0">
               <a:buNone/>
             </a:pPr>
             <a:r>
@@ -5522,7 +5453,7 @@
             <a:endParaRPr lang="en-US" sz="1100" dirty="0"/>
           </a:p>
           <a:p>
-            <a:pPr indent="0" marL="0">
+            <a:pPr marL="0" indent="0">
               <a:buNone/>
             </a:pPr>
             <a:r>
@@ -5564,6 +5495,13 @@
             <a:prstDash val="solid"/>
           </a:ln>
         </p:spPr>
+        <p:txBody>
+          <a:bodyPr/>
+          <a:lstStyle/>
+          <a:p>
+            <a:endParaRPr lang="en-US"/>
+          </a:p>
+        </p:txBody>
       </p:sp>
       <p:sp>
         <p:nvSpPr>
@@ -5586,7 +5524,7 @@
           <a:bodyPr wrap="square" rtlCol="0" anchor="ctr"/>
           <a:lstStyle/>
           <a:p>
-            <a:pPr indent="0" marL="0">
+            <a:pPr marL="0" indent="0">
               <a:buNone/>
             </a:pPr>
             <a:r>
@@ -5625,7 +5563,7 @@
           <a:bodyPr wrap="square" rtlCol="0" anchor="ctr"/>
           <a:lstStyle/>
           <a:p>
-            <a:pPr indent="0" marL="0">
+            <a:pPr marL="0" indent="0">
               <a:buNone/>
             </a:pPr>
             <a:r>
@@ -5664,7 +5602,7 @@
           <a:bodyPr wrap="square" rtlCol="0" anchor="ctr"/>
           <a:lstStyle/>
           <a:p>
-            <a:pPr indent="0" marL="0">
+            <a:pPr marL="0" indent="0">
               <a:buNone/>
             </a:pPr>
             <a:r>
@@ -5681,7 +5619,7 @@
             <a:endParaRPr lang="en-US" sz="1100" dirty="0"/>
           </a:p>
           <a:p>
-            <a:pPr indent="0" marL="0">
+            <a:pPr marL="0" indent="0">
               <a:buNone/>
             </a:pPr>
             <a:r>
@@ -5698,7 +5636,7 @@
             <a:endParaRPr lang="en-US" sz="1100" dirty="0"/>
           </a:p>
           <a:p>
-            <a:pPr indent="0" marL="0">
+            <a:pPr marL="0" indent="0">
               <a:buNone/>
             </a:pPr>
             <a:r>
@@ -5715,7 +5653,7 @@
             <a:endParaRPr lang="en-US" sz="1100" dirty="0"/>
           </a:p>
           <a:p>
-            <a:pPr indent="0" marL="0">
+            <a:pPr marL="0" indent="0">
               <a:buNone/>
             </a:pPr>
             <a:r>
@@ -5757,6 +5695,13 @@
             <a:prstDash val="solid"/>
           </a:ln>
         </p:spPr>
+        <p:txBody>
+          <a:bodyPr/>
+          <a:lstStyle/>
+          <a:p>
+            <a:endParaRPr lang="en-US"/>
+          </a:p>
+        </p:txBody>
       </p:sp>
       <p:sp>
         <p:nvSpPr>
@@ -5779,7 +5724,7 @@
           <a:bodyPr wrap="square" rtlCol="0" anchor="ctr"/>
           <a:lstStyle/>
           <a:p>
-            <a:pPr indent="0" marL="0">
+            <a:pPr marL="0" indent="0">
               <a:buNone/>
             </a:pPr>
             <a:r>
@@ -5818,7 +5763,7 @@
           <a:bodyPr wrap="square" rtlCol="0" anchor="ctr"/>
           <a:lstStyle/>
           <a:p>
-            <a:pPr indent="0" marL="0">
+            <a:pPr marL="0" indent="0">
               <a:buNone/>
             </a:pPr>
             <a:r>
@@ -5857,7 +5802,7 @@
           <a:bodyPr wrap="square" rtlCol="0" anchor="ctr"/>
           <a:lstStyle/>
           <a:p>
-            <a:pPr indent="0" marL="0">
+            <a:pPr marL="0" indent="0">
               <a:buNone/>
             </a:pPr>
             <a:r>
@@ -5874,7 +5819,7 @@
             <a:endParaRPr lang="en-US" sz="1100" dirty="0"/>
           </a:p>
           <a:p>
-            <a:pPr indent="0" marL="0">
+            <a:pPr marL="0" indent="0">
               <a:buNone/>
             </a:pPr>
             <a:r>
@@ -5891,7 +5836,7 @@
             <a:endParaRPr lang="en-US" sz="1100" dirty="0"/>
           </a:p>
           <a:p>
-            <a:pPr indent="0" marL="0">
+            <a:pPr marL="0" indent="0">
               <a:buNone/>
             </a:pPr>
             <a:r>
@@ -5908,7 +5853,7 @@
             <a:endParaRPr lang="en-US" sz="1100" dirty="0"/>
           </a:p>
           <a:p>
-            <a:pPr indent="0" marL="0">
+            <a:pPr marL="0" indent="0">
               <a:buNone/>
             </a:pPr>
             <a:r>
@@ -5942,6 +5887,7 @@
         <a:solidFill>
           <a:srgbClr val="0B132B"/>
         </a:solidFill>
+        <a:effectLst/>
       </p:bgPr>
     </p:bg>
     <p:spTree>
@@ -5979,7 +5925,7 @@
           <a:bodyPr wrap="square" rtlCol="0" anchor="ctr"/>
           <a:lstStyle/>
           <a:p>
-            <a:pPr indent="0" marL="0">
+            <a:pPr marL="0" indent="0">
               <a:buNone/>
             </a:pPr>
             <a:r>
@@ -6018,7 +5964,7 @@
           <a:bodyPr wrap="square" rtlCol="0" anchor="ctr"/>
           <a:lstStyle/>
           <a:p>
-            <a:pPr indent="0" marL="0">
+            <a:pPr marL="0" indent="0">
               <a:buNone/>
             </a:pPr>
             <a:r>
@@ -6060,6 +6006,13 @@
             <a:prstDash val="solid"/>
           </a:ln>
         </p:spPr>
+        <p:txBody>
+          <a:bodyPr/>
+          <a:lstStyle/>
+          <a:p>
+            <a:endParaRPr lang="en-US"/>
+          </a:p>
+        </p:txBody>
       </p:sp>
       <p:sp>
         <p:nvSpPr>
@@ -6082,7 +6035,7 @@
           <a:bodyPr wrap="square" rtlCol="0" anchor="ctr"/>
           <a:lstStyle/>
           <a:p>
-            <a:pPr indent="0" marL="0">
+            <a:pPr marL="0" indent="0">
               <a:buNone/>
             </a:pPr>
             <a:r>
@@ -6121,7 +6074,7 @@
           <a:bodyPr wrap="square" rtlCol="0" anchor="ctr"/>
           <a:lstStyle/>
           <a:p>
-            <a:pPr indent="0" marL="0">
+            <a:pPr marL="0" indent="0">
               <a:buNone/>
             </a:pPr>
             <a:r>
@@ -6163,6 +6116,13 @@
             <a:prstDash val="solid"/>
           </a:ln>
         </p:spPr>
+        <p:txBody>
+          <a:bodyPr/>
+          <a:lstStyle/>
+          <a:p>
+            <a:endParaRPr lang="en-US"/>
+          </a:p>
+        </p:txBody>
       </p:sp>
       <p:sp>
         <p:nvSpPr>
@@ -6185,7 +6145,7 @@
           <a:bodyPr wrap="square" rtlCol="0" anchor="ctr"/>
           <a:lstStyle/>
           <a:p>
-            <a:pPr indent="0" marL="0">
+            <a:pPr marL="0" indent="0">
               <a:buNone/>
             </a:pPr>
             <a:r>
@@ -6224,7 +6184,7 @@
           <a:bodyPr wrap="square" rtlCol="0" anchor="ctr"/>
           <a:lstStyle/>
           <a:p>
-            <a:pPr indent="0" marL="0">
+            <a:pPr marL="0" indent="0">
               <a:buNone/>
             </a:pPr>
             <a:r>
@@ -6266,6 +6226,13 @@
             <a:prstDash val="solid"/>
           </a:ln>
         </p:spPr>
+        <p:txBody>
+          <a:bodyPr/>
+          <a:lstStyle/>
+          <a:p>
+            <a:endParaRPr lang="en-US"/>
+          </a:p>
+        </p:txBody>
       </p:sp>
       <p:sp>
         <p:nvSpPr>
@@ -6288,7 +6255,7 @@
           <a:bodyPr wrap="square" rtlCol="0" anchor="ctr"/>
           <a:lstStyle/>
           <a:p>
-            <a:pPr indent="0" marL="0">
+            <a:pPr marL="0" indent="0">
               <a:buNone/>
             </a:pPr>
             <a:r>
@@ -6327,7 +6294,7 @@
           <a:bodyPr wrap="square" rtlCol="0" anchor="ctr"/>
           <a:lstStyle/>
           <a:p>
-            <a:pPr indent="0" marL="0">
+            <a:pPr marL="0" indent="0">
               <a:buNone/>
             </a:pPr>
             <a:r>
@@ -6369,6 +6336,13 @@
             <a:prstDash val="solid"/>
           </a:ln>
         </p:spPr>
+        <p:txBody>
+          <a:bodyPr/>
+          <a:lstStyle/>
+          <a:p>
+            <a:endParaRPr lang="en-US"/>
+          </a:p>
+        </p:txBody>
       </p:sp>
       <p:sp>
         <p:nvSpPr>
@@ -6391,7 +6365,7 @@
           <a:bodyPr wrap="square" rtlCol="0" anchor="ctr"/>
           <a:lstStyle/>
           <a:p>
-            <a:pPr indent="0" marL="0">
+            <a:pPr marL="0" indent="0">
               <a:buNone/>
             </a:pPr>
             <a:r>
@@ -6430,7 +6404,7 @@
           <a:bodyPr wrap="square" rtlCol="0" anchor="ctr"/>
           <a:lstStyle/>
           <a:p>
-            <a:pPr indent="0" marL="0">
+            <a:pPr marL="0" indent="0">
               <a:buNone/>
             </a:pPr>
             <a:r>
@@ -6472,6 +6446,13 @@
             <a:prstDash val="solid"/>
           </a:ln>
         </p:spPr>
+        <p:txBody>
+          <a:bodyPr/>
+          <a:lstStyle/>
+          <a:p>
+            <a:endParaRPr lang="en-US"/>
+          </a:p>
+        </p:txBody>
       </p:sp>
       <p:sp>
         <p:nvSpPr>
@@ -6494,7 +6475,7 @@
           <a:bodyPr wrap="square" rtlCol="0" anchor="ctr"/>
           <a:lstStyle/>
           <a:p>
-            <a:pPr indent="0" marL="0">
+            <a:pPr marL="0" indent="0">
               <a:buNone/>
             </a:pPr>
             <a:r>
@@ -6533,7 +6514,7 @@
           <a:bodyPr wrap="square" rtlCol="0" anchor="ctr"/>
           <a:lstStyle/>
           <a:p>
-            <a:pPr indent="0" marL="0">
+            <a:pPr marL="0" indent="0">
               <a:buNone/>
             </a:pPr>
             <a:r>
@@ -6575,6 +6556,13 @@
             <a:prstDash val="solid"/>
           </a:ln>
         </p:spPr>
+        <p:txBody>
+          <a:bodyPr/>
+          <a:lstStyle/>
+          <a:p>
+            <a:endParaRPr lang="en-US"/>
+          </a:p>
+        </p:txBody>
       </p:sp>
       <p:sp>
         <p:nvSpPr>
@@ -6597,7 +6585,7 @@
           <a:bodyPr wrap="square" rtlCol="0" anchor="ctr"/>
           <a:lstStyle/>
           <a:p>
-            <a:pPr indent="0" marL="0">
+            <a:pPr marL="0" indent="0">
               <a:buNone/>
             </a:pPr>
             <a:r>
@@ -6636,7 +6624,7 @@
           <a:bodyPr wrap="square" rtlCol="0" anchor="ctr"/>
           <a:lstStyle/>
           <a:p>
-            <a:pPr indent="0" marL="0">
+            <a:pPr marL="0" indent="0">
               <a:buNone/>
             </a:pPr>
             <a:r>
@@ -6670,6 +6658,7 @@
         <a:solidFill>
           <a:srgbClr val="0B132B"/>
         </a:solidFill>
+        <a:effectLst/>
       </p:bgPr>
     </p:bg>
     <p:spTree>
@@ -6707,7 +6696,7 @@
           <a:bodyPr wrap="square" rtlCol="0" anchor="ctr"/>
           <a:lstStyle/>
           <a:p>
-            <a:pPr indent="0" marL="0">
+            <a:pPr marL="0" indent="0">
               <a:buNone/>
             </a:pPr>
             <a:r>
@@ -6746,7 +6735,7 @@
           <a:bodyPr wrap="square" rtlCol="0" anchor="ctr"/>
           <a:lstStyle/>
           <a:p>
-            <a:pPr indent="0" marL="0">
+            <a:pPr marL="0" indent="0">
               <a:buNone/>
             </a:pPr>
             <a:r>
@@ -6788,6 +6777,13 @@
             <a:prstDash val="solid"/>
           </a:ln>
         </p:spPr>
+        <p:txBody>
+          <a:bodyPr/>
+          <a:lstStyle/>
+          <a:p>
+            <a:endParaRPr lang="en-US"/>
+          </a:p>
+        </p:txBody>
       </p:sp>
       <p:sp>
         <p:nvSpPr>
@@ -6810,7 +6806,7 @@
           <a:bodyPr wrap="square" rtlCol="0" anchor="ctr"/>
           <a:lstStyle/>
           <a:p>
-            <a:pPr indent="0" marL="0">
+            <a:pPr marL="0" indent="0">
               <a:buNone/>
             </a:pPr>
             <a:r>
@@ -6849,7 +6845,7 @@
           <a:bodyPr wrap="square" rtlCol="0" anchor="ctr"/>
           <a:lstStyle/>
           <a:p>
-            <a:pPr indent="0" marL="0">
+            <a:pPr marL="0" indent="0">
               <a:buNone/>
             </a:pPr>
             <a:r>
@@ -6866,13 +6862,13 @@
             <a:endParaRPr lang="en-US" sz="1100" dirty="0"/>
           </a:p>
           <a:p>
-            <a:pPr indent="0" marL="0">
-              <a:buNone/>
-            </a:pPr>
-            <a:endParaRPr lang="en-US" sz="1100" dirty="0"/>
-          </a:p>
-          <a:p>
-            <a:pPr indent="0" marL="0">
+            <a:pPr marL="0" indent="0">
+              <a:buNone/>
+            </a:pPr>
+            <a:endParaRPr lang="en-US" sz="1100" dirty="0"/>
+          </a:p>
+          <a:p>
+            <a:pPr marL="0" indent="0">
               <a:buNone/>
             </a:pPr>
             <a:r>
@@ -6889,13 +6885,13 @@
             <a:endParaRPr lang="en-US" sz="1100" dirty="0"/>
           </a:p>
           <a:p>
-            <a:pPr indent="0" marL="0">
-              <a:buNone/>
-            </a:pPr>
-            <a:endParaRPr lang="en-US" sz="1100" dirty="0"/>
-          </a:p>
-          <a:p>
-            <a:pPr indent="0" marL="0">
+            <a:pPr marL="0" indent="0">
+              <a:buNone/>
+            </a:pPr>
+            <a:endParaRPr lang="en-US" sz="1100" dirty="0"/>
+          </a:p>
+          <a:p>
+            <a:pPr marL="0" indent="0">
               <a:buNone/>
             </a:pPr>
             <a:r>
@@ -6912,13 +6908,13 @@
             <a:endParaRPr lang="en-US" sz="1100" dirty="0"/>
           </a:p>
           <a:p>
-            <a:pPr indent="0" marL="0">
-              <a:buNone/>
-            </a:pPr>
-            <a:endParaRPr lang="en-US" sz="1100" dirty="0"/>
-          </a:p>
-          <a:p>
-            <a:pPr indent="0" marL="0">
+            <a:pPr marL="0" indent="0">
+              <a:buNone/>
+            </a:pPr>
+            <a:endParaRPr lang="en-US" sz="1100" dirty="0"/>
+          </a:p>
+          <a:p>
+            <a:pPr marL="0" indent="0">
               <a:buNone/>
             </a:pPr>
             <a:r>
@@ -6935,13 +6931,13 @@
             <a:endParaRPr lang="en-US" sz="1100" dirty="0"/>
           </a:p>
           <a:p>
-            <a:pPr indent="0" marL="0">
-              <a:buNone/>
-            </a:pPr>
-            <a:endParaRPr lang="en-US" sz="1100" dirty="0"/>
-          </a:p>
-          <a:p>
-            <a:pPr indent="0" marL="0">
+            <a:pPr marL="0" indent="0">
+              <a:buNone/>
+            </a:pPr>
+            <a:endParaRPr lang="en-US" sz="1100" dirty="0"/>
+          </a:p>
+          <a:p>
+            <a:pPr marL="0" indent="0">
               <a:buNone/>
             </a:pPr>
             <a:r>
@@ -6958,13 +6954,13 @@
             <a:endParaRPr lang="en-US" sz="1100" dirty="0"/>
           </a:p>
           <a:p>
-            <a:pPr indent="0" marL="0">
-              <a:buNone/>
-            </a:pPr>
-            <a:endParaRPr lang="en-US" sz="1100" dirty="0"/>
-          </a:p>
-          <a:p>
-            <a:pPr indent="0" marL="0">
+            <a:pPr marL="0" indent="0">
+              <a:buNone/>
+            </a:pPr>
+            <a:endParaRPr lang="en-US" sz="1100" dirty="0"/>
+          </a:p>
+          <a:p>
+            <a:pPr marL="0" indent="0">
               <a:buNone/>
             </a:pPr>
             <a:r>
@@ -6981,13 +6977,13 @@
             <a:endParaRPr lang="en-US" sz="1100" dirty="0"/>
           </a:p>
           <a:p>
-            <a:pPr indent="0" marL="0">
-              <a:buNone/>
-            </a:pPr>
-            <a:endParaRPr lang="en-US" sz="1100" dirty="0"/>
-          </a:p>
-          <a:p>
-            <a:pPr indent="0" marL="0">
+            <a:pPr marL="0" indent="0">
+              <a:buNone/>
+            </a:pPr>
+            <a:endParaRPr lang="en-US" sz="1100" dirty="0"/>
+          </a:p>
+          <a:p>
+            <a:pPr marL="0" indent="0">
               <a:buNone/>
             </a:pPr>
             <a:r>
@@ -7004,13 +7000,13 @@
             <a:endParaRPr lang="en-US" sz="1100" dirty="0"/>
           </a:p>
           <a:p>
-            <a:pPr indent="0" marL="0">
-              <a:buNone/>
-            </a:pPr>
-            <a:endParaRPr lang="en-US" sz="1100" dirty="0"/>
-          </a:p>
-          <a:p>
-            <a:pPr indent="0" marL="0">
+            <a:pPr marL="0" indent="0">
+              <a:buNone/>
+            </a:pPr>
+            <a:endParaRPr lang="en-US" sz="1100" dirty="0"/>
+          </a:p>
+          <a:p>
+            <a:pPr marL="0" indent="0">
               <a:buNone/>
             </a:pPr>
             <a:r>
@@ -7044,6 +7040,7 @@
         <a:solidFill>
           <a:srgbClr val="0B132B"/>
         </a:solidFill>
+        <a:effectLst/>
       </p:bgPr>
     </p:bg>
     <p:spTree>
@@ -7081,7 +7078,7 @@
           <a:bodyPr wrap="square" rtlCol="0" anchor="ctr"/>
           <a:lstStyle/>
           <a:p>
-            <a:pPr indent="0" marL="0">
+            <a:pPr marL="0" indent="0">
               <a:buNone/>
             </a:pPr>
             <a:r>
@@ -7120,7 +7117,7 @@
           <a:bodyPr wrap="square" rtlCol="0" anchor="ctr"/>
           <a:lstStyle/>
           <a:p>
-            <a:pPr indent="0" marL="0">
+            <a:pPr marL="0" indent="0">
               <a:buNone/>
             </a:pPr>
             <a:r>
@@ -7162,6 +7159,13 @@
             <a:prstDash val="solid"/>
           </a:ln>
         </p:spPr>
+        <p:txBody>
+          <a:bodyPr/>
+          <a:lstStyle/>
+          <a:p>
+            <a:endParaRPr lang="en-US"/>
+          </a:p>
+        </p:txBody>
       </p:sp>
       <p:sp>
         <p:nvSpPr>
@@ -7184,7 +7188,7 @@
           <a:bodyPr wrap="square" rtlCol="0" anchor="ctr"/>
           <a:lstStyle/>
           <a:p>
-            <a:pPr indent="0" marL="0">
+            <a:pPr marL="0" indent="0">
               <a:buNone/>
             </a:pPr>
             <a:r>
@@ -7223,7 +7227,7 @@
           <a:bodyPr wrap="square" rtlCol="0" anchor="ctr"/>
           <a:lstStyle/>
           <a:p>
-            <a:pPr indent="0" marL="0">
+            <a:pPr marL="0" indent="0">
               <a:buNone/>
             </a:pPr>
             <a:r>
@@ -7240,13 +7244,13 @@
             <a:endParaRPr lang="en-US" sz="1100" dirty="0"/>
           </a:p>
           <a:p>
-            <a:pPr indent="0" marL="0">
-              <a:buNone/>
-            </a:pPr>
-            <a:endParaRPr lang="en-US" sz="1100" dirty="0"/>
-          </a:p>
-          <a:p>
-            <a:pPr indent="0" marL="0">
+            <a:pPr marL="0" indent="0">
+              <a:buNone/>
+            </a:pPr>
+            <a:endParaRPr lang="en-US" sz="1100" dirty="0"/>
+          </a:p>
+          <a:p>
+            <a:pPr marL="0" indent="0">
               <a:buNone/>
             </a:pPr>
             <a:r>
@@ -7263,7 +7267,7 @@
             <a:endParaRPr lang="en-US" sz="1100" dirty="0"/>
           </a:p>
           <a:p>
-            <a:pPr indent="0" marL="0">
+            <a:pPr marL="0" indent="0">
               <a:buNone/>
             </a:pPr>
             <a:r>
@@ -7280,7 +7284,7 @@
             <a:endParaRPr lang="en-US" sz="1100" dirty="0"/>
           </a:p>
           <a:p>
-            <a:pPr indent="0" marL="0">
+            <a:pPr marL="0" indent="0">
               <a:buNone/>
             </a:pPr>
             <a:r>
@@ -7297,7 +7301,7 @@
             <a:endParaRPr lang="en-US" sz="1100" dirty="0"/>
           </a:p>
           <a:p>
-            <a:pPr indent="0" marL="0">
+            <a:pPr marL="0" indent="0">
               <a:buNone/>
             </a:pPr>
             <a:r>
@@ -7314,7 +7318,7 @@
             <a:endParaRPr lang="en-US" sz="1100" dirty="0"/>
           </a:p>
           <a:p>
-            <a:pPr indent="0" marL="0">
+            <a:pPr marL="0" indent="0">
               <a:buNone/>
             </a:pPr>
             <a:r>
@@ -7331,7 +7335,7 @@
             <a:endParaRPr lang="en-US" sz="1100" dirty="0"/>
           </a:p>
           <a:p>
-            <a:pPr indent="0" marL="0">
+            <a:pPr marL="0" indent="0">
               <a:buNone/>
             </a:pPr>
             <a:r>
@@ -7348,7 +7352,7 @@
             <a:endParaRPr lang="en-US" sz="1100" dirty="0"/>
           </a:p>
           <a:p>
-            <a:pPr indent="0" marL="0">
+            <a:pPr marL="0" indent="0">
               <a:buNone/>
             </a:pPr>
             <a:r>
@@ -7365,7 +7369,7 @@
             <a:endParaRPr lang="en-US" sz="1100" dirty="0"/>
           </a:p>
           <a:p>
-            <a:pPr indent="0" marL="0">
+            <a:pPr marL="0" indent="0">
               <a:buNone/>
             </a:pPr>
             <a:r>
@@ -7382,7 +7386,7 @@
             <a:endParaRPr lang="en-US" sz="1100" dirty="0"/>
           </a:p>
           <a:p>
-            <a:pPr indent="0" marL="0">
+            <a:pPr marL="0" indent="0">
               <a:buNone/>
             </a:pPr>
             <a:r>
@@ -7424,6 +7428,13 @@
             <a:prstDash val="solid"/>
           </a:ln>
         </p:spPr>
+        <p:txBody>
+          <a:bodyPr/>
+          <a:lstStyle/>
+          <a:p>
+            <a:endParaRPr lang="en-US"/>
+          </a:p>
+        </p:txBody>
       </p:sp>
       <p:sp>
         <p:nvSpPr>
@@ -7446,7 +7457,7 @@
           <a:bodyPr wrap="square" rtlCol="0" anchor="ctr"/>
           <a:lstStyle/>
           <a:p>
-            <a:pPr indent="0" marL="0">
+            <a:pPr marL="0" indent="0">
               <a:buNone/>
             </a:pPr>
             <a:r>
@@ -7485,7 +7496,7 @@
           <a:bodyPr wrap="square" rtlCol="0" anchor="ctr"/>
           <a:lstStyle/>
           <a:p>
-            <a:pPr indent="0" marL="0">
+            <a:pPr marL="0" indent="0">
               <a:buNone/>
             </a:pPr>
             <a:r>
@@ -7502,13 +7513,13 @@
             <a:endParaRPr lang="en-US" sz="1100" dirty="0"/>
           </a:p>
           <a:p>
-            <a:pPr indent="0" marL="0">
-              <a:buNone/>
-            </a:pPr>
-            <a:endParaRPr lang="en-US" sz="1100" dirty="0"/>
-          </a:p>
-          <a:p>
-            <a:pPr indent="0" marL="0">
+            <a:pPr marL="0" indent="0">
+              <a:buNone/>
+            </a:pPr>
+            <a:endParaRPr lang="en-US" sz="1100" dirty="0"/>
+          </a:p>
+          <a:p>
+            <a:pPr marL="0" indent="0">
               <a:buNone/>
             </a:pPr>
             <a:r>
@@ -7525,7 +7536,7 @@
             <a:endParaRPr lang="en-US" sz="1100" dirty="0"/>
           </a:p>
           <a:p>
-            <a:pPr indent="0" marL="0">
+            <a:pPr marL="0" indent="0">
               <a:buNone/>
             </a:pPr>
             <a:r>
@@ -7542,7 +7553,7 @@
             <a:endParaRPr lang="en-US" sz="1100" dirty="0"/>
           </a:p>
           <a:p>
-            <a:pPr indent="0" marL="0">
+            <a:pPr marL="0" indent="0">
               <a:buNone/>
             </a:pPr>
             <a:r>
@@ -7559,7 +7570,7 @@
             <a:endParaRPr lang="en-US" sz="1100" dirty="0"/>
           </a:p>
           <a:p>
-            <a:pPr indent="0" marL="0">
+            <a:pPr marL="0" indent="0">
               <a:buNone/>
             </a:pPr>
             <a:r>
@@ -7576,7 +7587,7 @@
             <a:endParaRPr lang="en-US" sz="1100" dirty="0"/>
           </a:p>
           <a:p>
-            <a:pPr indent="0" marL="0">
+            <a:pPr marL="0" indent="0">
               <a:buNone/>
             </a:pPr>
             <a:r>
@@ -7593,7 +7604,7 @@
             <a:endParaRPr lang="en-US" sz="1100" dirty="0"/>
           </a:p>
           <a:p>
-            <a:pPr indent="0" marL="0">
+            <a:pPr marL="0" indent="0">
               <a:buNone/>
             </a:pPr>
             <a:r>
@@ -7610,7 +7621,7 @@
             <a:endParaRPr lang="en-US" sz="1100" dirty="0"/>
           </a:p>
           <a:p>
-            <a:pPr indent="0" marL="0">
+            <a:pPr marL="0" indent="0">
               <a:buNone/>
             </a:pPr>
             <a:r>
@@ -7627,7 +7638,7 @@
             <a:endParaRPr lang="en-US" sz="1100" dirty="0"/>
           </a:p>
           <a:p>
-            <a:pPr indent="0" marL="0">
+            <a:pPr marL="0" indent="0">
               <a:buNone/>
             </a:pPr>
             <a:r>
@@ -7644,7 +7655,7 @@
             <a:endParaRPr lang="en-US" sz="1100" dirty="0"/>
           </a:p>
           <a:p>
-            <a:pPr indent="0" marL="0">
+            <a:pPr marL="0" indent="0">
               <a:buNone/>
             </a:pPr>
             <a:r>
@@ -7963,4 +7974,319 @@
     </a:ext>
   </a:extLst>
 </a:theme>
+</file>
+
+<file path=ppt/theme/theme2.xml><?xml version="1.0" encoding="utf-8"?>
+<a:theme xmlns:a="http://schemas.openxmlformats.org/drawingml/2006/main" name="Office Theme">
+  <a:themeElements>
+    <a:clrScheme name="Office">
+      <a:dk1>
+        <a:sysClr val="windowText" lastClr="000000"/>
+      </a:dk1>
+      <a:lt1>
+        <a:sysClr val="window" lastClr="FFFFFF"/>
+      </a:lt1>
+      <a:dk2>
+        <a:srgbClr val="0E2841"/>
+      </a:dk2>
+      <a:lt2>
+        <a:srgbClr val="E8E8E8"/>
+      </a:lt2>
+      <a:accent1>
+        <a:srgbClr val="156082"/>
+      </a:accent1>
+      <a:accent2>
+        <a:srgbClr val="E97132"/>
+      </a:accent2>
+      <a:accent3>
+        <a:srgbClr val="196B24"/>
+      </a:accent3>
+      <a:accent4>
+        <a:srgbClr val="0F9ED5"/>
+      </a:accent4>
+      <a:accent5>
+        <a:srgbClr val="A02B93"/>
+      </a:accent5>
+      <a:accent6>
+        <a:srgbClr val="4EA72E"/>
+      </a:accent6>
+      <a:hlink>
+        <a:srgbClr val="467886"/>
+      </a:hlink>
+      <a:folHlink>
+        <a:srgbClr val="96607D"/>
+      </a:folHlink>
+    </a:clrScheme>
+    <a:fontScheme name="Office">
+      <a:majorFont>
+        <a:latin typeface="Aptos Display" panose="02110004020202020204"/>
+        <a:ea typeface=""/>
+        <a:cs typeface=""/>
+        <a:font script="Jpan" typeface="游ゴシック Light"/>
+        <a:font script="Hang" typeface="맑은 고딕"/>
+        <a:font script="Hans" typeface="等线 Light"/>
+        <a:font script="Hant" typeface="新細明體"/>
+        <a:font script="Arab" typeface="Times New Roman"/>
+        <a:font script="Hebr" typeface="Times New Roman"/>
+        <a:font script="Thai" typeface="Angsana New"/>
+        <a:font script="Ethi" typeface="Nyala"/>
+        <a:font script="Beng" typeface="Vrinda"/>
+        <a:font script="Gujr" typeface="Shruti"/>
+        <a:font script="Khmr" typeface="MoolBoran"/>
+        <a:font script="Knda" typeface="Tunga"/>
+        <a:font script="Guru" typeface="Raavi"/>
+        <a:font script="Cans" typeface="Euphemia"/>
+        <a:font script="Cher" typeface="Plantagenet Cherokee"/>
+        <a:font script="Yiii" typeface="Microsoft Yi Baiti"/>
+        <a:font script="Tibt" typeface="Microsoft Himalaya"/>
+        <a:font script="Thaa" typeface="MV Boli"/>
+        <a:font script="Deva" typeface="Mangal"/>
+        <a:font script="Telu" typeface="Gautami"/>
+        <a:font script="Taml" typeface="Latha"/>
+        <a:font script="Syrc" typeface="Estrangelo Edessa"/>
+        <a:font script="Orya" typeface="Kalinga"/>
+        <a:font script="Mlym" typeface="Kartika"/>
+        <a:font script="Laoo" typeface="DokChampa"/>
+        <a:font script="Sinh" typeface="Iskoola Pota"/>
+        <a:font script="Mong" typeface="Mongolian Baiti"/>
+        <a:font script="Viet" typeface="Times New Roman"/>
+        <a:font script="Uigh" typeface="Microsoft Uighur"/>
+        <a:font script="Geor" typeface="Sylfaen"/>
+        <a:font script="Armn" typeface="Arial"/>
+        <a:font script="Bugi" typeface="Leelawadee UI"/>
+        <a:font script="Bopo" typeface="Microsoft JhengHei"/>
+        <a:font script="Java" typeface="Javanese Text"/>
+        <a:font script="Lisu" typeface="Segoe UI"/>
+        <a:font script="Mymr" typeface="Myanmar Text"/>
+        <a:font script="Nkoo" typeface="Ebrima"/>
+        <a:font script="Olck" typeface="Nirmala UI"/>
+        <a:font script="Osma" typeface="Ebrima"/>
+        <a:font script="Phag" typeface="Phagspa"/>
+        <a:font script="Syrn" typeface="Estrangelo Edessa"/>
+        <a:font script="Syrj" typeface="Estrangelo Edessa"/>
+        <a:font script="Syre" typeface="Estrangelo Edessa"/>
+        <a:font script="Sora" typeface="Nirmala UI"/>
+        <a:font script="Tale" typeface="Microsoft Tai Le"/>
+        <a:font script="Talu" typeface="Microsoft New Tai Lue"/>
+        <a:font script="Tfng" typeface="Ebrima"/>
+      </a:majorFont>
+      <a:minorFont>
+        <a:latin typeface="Aptos" panose="02110004020202020204"/>
+        <a:ea typeface=""/>
+        <a:cs typeface=""/>
+        <a:font script="Jpan" typeface="游ゴシック"/>
+        <a:font script="Hang" typeface="맑은 고딕"/>
+        <a:font script="Hans" typeface="等线"/>
+        <a:font script="Hant" typeface="新細明體"/>
+        <a:font script="Arab" typeface="Arial"/>
+        <a:font script="Hebr" typeface="Arial"/>
+        <a:font script="Thai" typeface="Cordia New"/>
+        <a:font script="Ethi" typeface="Nyala"/>
+        <a:font script="Beng" typeface="Vrinda"/>
+        <a:font script="Gujr" typeface="Shruti"/>
+        <a:font script="Khmr" typeface="DaunPenh"/>
+        <a:font script="Knda" typeface="Tunga"/>
+        <a:font script="Guru" typeface="Raavi"/>
+        <a:font script="Cans" typeface="Euphemia"/>
+        <a:font script="Cher" typeface="Plantagenet Cherokee"/>
+        <a:font script="Yiii" typeface="Microsoft Yi Baiti"/>
+        <a:font script="Tibt" typeface="Microsoft Himalaya"/>
+        <a:font script="Thaa" typeface="MV Boli"/>
+        <a:font script="Deva" typeface="Mangal"/>
+        <a:font script="Telu" typeface="Gautami"/>
+        <a:font script="Taml" typeface="Latha"/>
+        <a:font script="Syrc" typeface="Estrangelo Edessa"/>
+        <a:font script="Orya" typeface="Kalinga"/>
+        <a:font script="Mlym" typeface="Kartika"/>
+        <a:font script="Laoo" typeface="DokChampa"/>
+        <a:font script="Sinh" typeface="Iskoola Pota"/>
+        <a:font script="Mong" typeface="Mongolian Baiti"/>
+        <a:font script="Viet" typeface="Arial"/>
+        <a:font script="Uigh" typeface="Microsoft Uighur"/>
+        <a:font script="Geor" typeface="Sylfaen"/>
+        <a:font script="Armn" typeface="Arial"/>
+        <a:font script="Bugi" typeface="Leelawadee UI"/>
+        <a:font script="Bopo" typeface="Microsoft JhengHei"/>
+        <a:font script="Java" typeface="Javanese Text"/>
+        <a:font script="Lisu" typeface="Segoe UI"/>
+        <a:font script="Mymr" typeface="Myanmar Text"/>
+        <a:font script="Nkoo" typeface="Ebrima"/>
+        <a:font script="Olck" typeface="Nirmala UI"/>
+        <a:font script="Osma" typeface="Ebrima"/>
+        <a:font script="Phag" typeface="Phagspa"/>
+        <a:font script="Syrn" typeface="Estrangelo Edessa"/>
+        <a:font script="Syrj" typeface="Estrangelo Edessa"/>
+        <a:font script="Syre" typeface="Estrangelo Edessa"/>
+        <a:font script="Sora" typeface="Nirmala UI"/>
+        <a:font script="Tale" typeface="Microsoft Tai Le"/>
+        <a:font script="Talu" typeface="Microsoft New Tai Lue"/>
+        <a:font script="Tfng" typeface="Ebrima"/>
+      </a:minorFont>
+    </a:fontScheme>
+    <a:fmtScheme name="Office">
+      <a:fillStyleLst>
+        <a:solidFill>
+          <a:schemeClr val="phClr"/>
+        </a:solidFill>
+        <a:gradFill rotWithShape="1">
+          <a:gsLst>
+            <a:gs pos="0">
+              <a:schemeClr val="phClr">
+                <a:lumMod val="110000"/>
+                <a:satMod val="105000"/>
+                <a:tint val="67000"/>
+              </a:schemeClr>
+            </a:gs>
+            <a:gs pos="50000">
+              <a:schemeClr val="phClr">
+                <a:lumMod val="105000"/>
+                <a:satMod val="103000"/>
+                <a:tint val="73000"/>
+              </a:schemeClr>
+            </a:gs>
+            <a:gs pos="100000">
+              <a:schemeClr val="phClr">
+                <a:lumMod val="105000"/>
+                <a:satMod val="109000"/>
+                <a:tint val="81000"/>
+              </a:schemeClr>
+            </a:gs>
+          </a:gsLst>
+          <a:lin ang="5400000" scaled="0"/>
+        </a:gradFill>
+        <a:gradFill rotWithShape="1">
+          <a:gsLst>
+            <a:gs pos="0">
+              <a:schemeClr val="phClr">
+                <a:satMod val="103000"/>
+                <a:lumMod val="102000"/>
+                <a:tint val="94000"/>
+              </a:schemeClr>
+            </a:gs>
+            <a:gs pos="50000">
+              <a:schemeClr val="phClr">
+                <a:satMod val="110000"/>
+                <a:lumMod val="100000"/>
+                <a:shade val="100000"/>
+              </a:schemeClr>
+            </a:gs>
+            <a:gs pos="100000">
+              <a:schemeClr val="phClr">
+                <a:lumMod val="99000"/>
+                <a:satMod val="120000"/>
+                <a:shade val="78000"/>
+              </a:schemeClr>
+            </a:gs>
+          </a:gsLst>
+          <a:lin ang="5400000" scaled="0"/>
+        </a:gradFill>
+      </a:fillStyleLst>
+      <a:lnStyleLst>
+        <a:ln w="12700" cap="flat" cmpd="sng" algn="ctr">
+          <a:solidFill>
+            <a:schemeClr val="phClr"/>
+          </a:solidFill>
+          <a:prstDash val="solid"/>
+          <a:miter lim="800000"/>
+        </a:ln>
+        <a:ln w="19050" cap="flat" cmpd="sng" algn="ctr">
+          <a:solidFill>
+            <a:schemeClr val="phClr"/>
+          </a:solidFill>
+          <a:prstDash val="solid"/>
+          <a:miter lim="800000"/>
+        </a:ln>
+        <a:ln w="25400" cap="flat" cmpd="sng" algn="ctr">
+          <a:solidFill>
+            <a:schemeClr val="phClr"/>
+          </a:solidFill>
+          <a:prstDash val="solid"/>
+          <a:miter lim="800000"/>
+        </a:ln>
+      </a:lnStyleLst>
+      <a:effectStyleLst>
+        <a:effectStyle>
+          <a:effectLst/>
+        </a:effectStyle>
+        <a:effectStyle>
+          <a:effectLst/>
+        </a:effectStyle>
+        <a:effectStyle>
+          <a:effectLst>
+            <a:outerShdw blurRad="57150" dist="19050" dir="5400000" algn="ctr" rotWithShape="0">
+              <a:srgbClr val="000000">
+                <a:alpha val="63000"/>
+              </a:srgbClr>
+            </a:outerShdw>
+          </a:effectLst>
+        </a:effectStyle>
+      </a:effectStyleLst>
+      <a:bgFillStyleLst>
+        <a:solidFill>
+          <a:schemeClr val="phClr"/>
+        </a:solidFill>
+        <a:solidFill>
+          <a:schemeClr val="phClr">
+            <a:tint val="95000"/>
+            <a:satMod val="170000"/>
+          </a:schemeClr>
+        </a:solidFill>
+        <a:gradFill rotWithShape="1">
+          <a:gsLst>
+            <a:gs pos="0">
+              <a:schemeClr val="phClr">
+                <a:tint val="93000"/>
+                <a:satMod val="150000"/>
+                <a:shade val="98000"/>
+                <a:lumMod val="102000"/>
+              </a:schemeClr>
+            </a:gs>
+            <a:gs pos="50000">
+              <a:schemeClr val="phClr">
+                <a:tint val="98000"/>
+                <a:satMod val="130000"/>
+                <a:shade val="90000"/>
+                <a:lumMod val="103000"/>
+              </a:schemeClr>
+            </a:gs>
+            <a:gs pos="100000">
+              <a:schemeClr val="phClr">
+                <a:shade val="63000"/>
+                <a:satMod val="120000"/>
+              </a:schemeClr>
+            </a:gs>
+          </a:gsLst>
+          <a:lin ang="5400000" scaled="0"/>
+        </a:gradFill>
+      </a:bgFillStyleLst>
+    </a:fmtScheme>
+  </a:themeElements>
+  <a:objectDefaults>
+    <a:lnDef>
+      <a:spPr/>
+      <a:bodyPr/>
+      <a:lstStyle/>
+      <a:style>
+        <a:lnRef idx="2">
+          <a:schemeClr val="accent1"/>
+        </a:lnRef>
+        <a:fillRef idx="0">
+          <a:schemeClr val="accent1"/>
+        </a:fillRef>
+        <a:effectRef idx="1">
+          <a:schemeClr val="accent1"/>
+        </a:effectRef>
+        <a:fontRef idx="minor">
+          <a:schemeClr val="tx1"/>
+        </a:fontRef>
+      </a:style>
+    </a:lnDef>
+  </a:objectDefaults>
+  <a:extraClrSchemeLst/>
+  <a:extLst>
+    <a:ext uri="{05A4C25C-085E-4340-85A3-A5531E510DB2}">
+      <thm15:themeFamily xmlns:thm15="http://schemas.microsoft.com/office/thememl/2012/main" name="Office Theme" id="{2E142A2C-CD16-42D6-873A-C26D2A0506FA}" vid="{1BDDFF52-6CD6-40A5-AB3C-68EB2F1E4D0A}"/>
+    </a:ext>
+  </a:extLst>
+</a:theme>
 </file>
</xml_diff>

<commit_message>
docs: update FINTECHATHON_2026_PRESENTATION.pptx with latest slide revisions
</commit_message>
<xml_diff>
--- a/docs/FINTECHATHON_2026_PRESENTATION.pptx
+++ b/docs/FINTECHATHON_2026_PRESENTATION.pptx
@@ -116,32 +116,32 @@
   <p:extLst>
     <p:ext uri="{521415D9-36F7-43E2-AB2F-B90AF26B5E84}">
       <p14:sectionLst xmlns:p14="http://schemas.microsoft.com/office/powerpoint/2010/main">
-        <p14:section name="Introduction" id="{bb1d2582-5f4c-ddc9-de17-1b8d4ae31dfc}">
+        <p14:section name="Introduction" id="{e2224552-74b0-5fd0-b4cf-54c856d85627}">
           <p14:sldIdLst>
             <p14:sldId id="256"/>
           </p14:sldIdLst>
         </p14:section>
-        <p14:section name="Problem &amp; Solution" id="{9f813074-b796-4234-c30f-e8fe569baeda}">
+        <p14:section name="Problem &amp; Solution" id="{fd823ae9-73bb-6b0c-607b-03a5bb0c3ca1}">
           <p14:sldIdLst>
             <p14:sldId id="257"/>
             <p14:sldId id="258"/>
           </p14:sldIdLst>
         </p14:section>
-        <p14:section name="Architecture &amp; Safety" id="{b7ccc9ed-6a8c-b008-afb0-08ec6798126e}">
+        <p14:section name="Architecture &amp; Safety" id="{01f93cc5-7508-7318-46a6-7055c3d19803}">
           <p14:sldIdLst>
             <p14:sldId id="259"/>
             <p14:sldId id="260"/>
             <p14:sldId id="261"/>
           </p14:sldIdLst>
         </p14:section>
-        <p14:section name="Demo &amp; Evidence" id="{559ab212-aae2-ac31-ae9e-49acc6908e48}">
+        <p14:section name="Demo &amp; Evidence" id="{3d9a5fd1-dc44-c6eb-6cd6-fbdb42f2f758}">
           <p14:sldIdLst>
             <p14:sldId id="262"/>
             <p14:sldId id="263"/>
             <p14:sldId id="264"/>
           </p14:sldIdLst>
         </p14:section>
-        <p14:section name="Roadmap" id="{993b9e81-ba16-de8b-736c-a748bef0b327}">
+        <p14:section name="Roadmap" id="{592048cf-3b92-21d6-7b00-ef8aa71d39cb}">
           <p14:sldIdLst>
             <p14:sldId id="265"/>
           </p14:sldIdLst>
@@ -638,7 +638,7 @@
           <a:p>
             <a:r>
               <a:rPr lang="en-US" dirty="0"/>
-              <a:t>For next steps, in the short term we would connect to university portals to import tuition invoices. In the medium term we would work with a central bank sandbox and real-time gross settlement rails. In the long term we would support split payments, for example part from family savings and part from an education loan. Before going live, we would also add KYC and AML screening, distributed rate limiting, and an independent security audit. Thank you to the judges and the organizers. We are happy to answer questions.</a:t>
+              <a:t>For next steps, in the short term we would connect to university portals to import tuition invoices. In the medium term we would work with a central bank sandbox and real-time gross settlement rails. In the long term we would support split payments, for example part from family savings and part from an education loan. Before going live, we would also connect real KYC and AML providers, distributed rate limiting, and an independent security audit. Thank you to the judges and the organizers. We are happy to answer questions.</a:t>
             </a:r>
             <a:endParaRPr lang="en-US" dirty="0"/>
           </a:p>
@@ -990,7 +990,7 @@
           <a:p>
             <a:r>
               <a:rPr lang="en-US" dirty="0"/>
-              <a:t>Security is thirty percent of the score, so this is the core of our design. There are three permission tiers. Read-only lets the AI check balances, compare routes, and read the audit log, and no money moves. Draft lets the AI create a pending transfer with a one-time token, but the balance does not change. Execute is human only: the student must confirm with the token and explicit consent, and the AI is blocked from this tier. On top of that, hard limits of four hundred thousand taka per transfer and one million per day are enforced in backend code, not in the AI prompt, so a clever message cannot change them.</a:t>
+              <a:t>Security is thirty percent of the score, so this is the core of our design. There are three permission tiers. Read-only lets the AI check balances, compare routes, and read the audit log, and no money moves. Draft lets the AI create a pending transfer with a one-time token, but the balance does not change. Execute is human only: the student must confirm with the one-time token, explicit consent, and a six-digit two-factor code, and the AI is blocked from this tier. On top of that, hard limits of four hundred thousand taka per transfer and one million per day are enforced in backend code, not in the AI prompt, so a clever message cannot change them. For transparency, our sandbox accepts a documented test PIN so evaluators are not blocked. It is listed as risk SEC-10 in our security report and is disabled in production mode.</a:t>
             </a:r>
             <a:endParaRPr lang="en-US" dirty="0"/>
           </a:p>
@@ -1166,7 +1166,7 @@
           <a:p>
             <a:r>
               <a:rPr lang="en-US" dirty="0"/>
-              <a:t>Now the demo flow, which matches the real run in our evidence file. Step one: the student asks to pay three thousand dollars of tuition, and the agent ranks four routes. Step two: it drafts a transfer with EduPay Prime for about 358 thousand taka, and the balance does not change. Step three: the student confirms and the balance goes from 850 thousand to about 491 thousand. Step four: a Saga rollback restores the money. Step five: a four thousand five hundred dollar request is blocked by the limit. Step six: prompt injection and shell-bomb attacks are blocked and logged. We will show this live in the demo video.</a:t>
+              <a:t>Now the demo flow, which matches the real run in our evidence file. Step one: the student asks to pay three thousand dollars of tuition, and the agent ranks four routes. Step two: it drafts a transfer with EduPay Prime for about 358 thousand taka, and the balance does not change. Step three: the student enters a six-digit two-factor code and confirms, and the balance goes from 850 thousand to about 491 thousand. Step four: a Saga rollback restores the money. Step five: a four thousand five hundred dollar request is blocked by the limit. Step six: prompt injection and shell-bomb attacks are blocked and logged. We will show this live in the demo video.</a:t>
             </a:r>
             <a:endParaRPr lang="en-US" dirty="0"/>
           </a:p>
@@ -1254,7 +1254,7 @@
           <a:p>
             <a:r>
               <a:rPr lang="en-US" dirty="0"/>
-              <a:t>Every action in the system is written to an audit log. This table shows real entries from our sandbox export, with the event type, the permission tier, and the result. You can see successful actions, the rollback, the blocked over-limit transfer, the flagged prompt injection, and the blocked shell-bomb attack. The log is append-only by design. Administrators can only prune it in sandbox mode. For production, we would stream the logs to write-once storage. The raw file, execution-evidence.json, is in our repository and matches these entries exactly.</a:t>
+              <a:t>Every action in the system is written to an audit log. This table shows key entries from our sandbox export, with the event type, the permission tier, and the result. You can see registration, the AML screening, the two-factor code being issued, the confirmed payment, the rollback, the blocked over-limit transfer, the flagged prompt injection, and the blocked shell-bomb attack. The log is append-only by design. Administrators can only prune it in sandbox mode. For production, we would stream the logs to write-once storage. The raw file, execution-evidence.json, is in our repository and matches these entries exactly.</a:t>
             </a:r>
             <a:endParaRPr lang="en-US" dirty="0"/>
           </a:p>
@@ -1342,7 +1342,7 @@
           <a:p>
             <a:r>
               <a:rPr lang="en-US" dirty="0"/>
-              <a:t>Our backend has eighty automated Jest tests, and all of them pass. They are split across a security suite and a hardening suite. The tests cover the financial rules: limits are enforced, the AI cannot confirm a payment, consent and the token are required, and a rollback restores the funds. They also cover security hardening: rate limits on login and chat, isolation between students, rejection of tampered tokens, blocking of injection and shell-bomb attacks, and admin-only sandbox reset. The test output is included in our execution evidence.</a:t>
+              <a:t>Our backend has eighty automated Jest tests, and all of them pass. They are split across a security suite and a hardening suite. The tests cover the financial rules: limits are enforced, the AI cannot confirm a payment, consent, the token, and the two-factor code are all required, and a rollback restores the funds. They also cover security hardening: rate limits on login and chat, isolation between students, rejection of tampered tokens, blocking of injection and shell-bomb attacks, and admin-only sandbox reset. The test output is included in our execution evidence.</a:t>
             </a:r>
             <a:endParaRPr lang="en-US" dirty="0"/>
           </a:p>
@@ -3064,7 +3064,7 @@
                   <a:schemeClr val="bg2"/>
                 </a:solidFill>
               </a:rPr>
-              <a:t>Before going live: KYC and AML screening, distributed rate limiting, and an independent security audit.</a:t>
+              <a:t>Before going live: real KYC/AML providers, distributed rate limiting, and an independent security audit.</a:t>
             </a:r>
             <a:endParaRPr lang="en-US" sz="1400" dirty="0"/>
           </a:p>
@@ -5702,11 +5702,11 @@
         <p:spPr>
           <a:xfrm>
             <a:off x="457200" y="1280160"/>
-            <a:ext cx="2606040" cy="2377440"/>
+            <a:ext cx="2606040" cy="2286000"/>
           </a:xfrm>
           <a:prstGeom prst="roundRect">
             <a:avLst>
-              <a:gd name="adj" fmla="val 3077"/>
+              <a:gd name="adj" fmla="val 3200"/>
             </a:avLst>
           </a:prstGeom>
           <a:solidFill>
@@ -5881,11 +5881,11 @@
         <p:spPr>
           <a:xfrm>
             <a:off x="3268980" y="1280160"/>
-            <a:ext cx="2606040" cy="2377440"/>
+            <a:ext cx="2606040" cy="2286000"/>
           </a:xfrm>
           <a:prstGeom prst="roundRect">
             <a:avLst>
-              <a:gd name="adj" fmla="val 3077"/>
+              <a:gd name="adj" fmla="val 3200"/>
             </a:avLst>
           </a:prstGeom>
           <a:solidFill>
@@ -6060,11 +6060,11 @@
         <p:spPr>
           <a:xfrm>
             <a:off x="6080760" y="1280160"/>
-            <a:ext cx="2606040" cy="2377440"/>
+            <a:ext cx="2606040" cy="2286000"/>
           </a:xfrm>
           <a:prstGeom prst="roundRect">
             <a:avLst>
-              <a:gd name="adj" fmla="val 3077"/>
+              <a:gd name="adj" fmla="val 3200"/>
             </a:avLst>
           </a:prstGeom>
           <a:solidFill>
@@ -6207,7 +6207,7 @@
                   <a:schemeClr val="tx1"/>
                 </a:solidFill>
               </a:rPr>
-              <a:t>Confirm payment with the token and explicit consent.</a:t>
+              <a:t>Confirm with the token and a 6-digit 2FA code.</a:t>
             </a:r>
             <a:endParaRPr lang="en-US" sz="1600" dirty="0"/>
           </a:p>
@@ -6238,12 +6238,12 @@
         </p:nvSpPr>
         <p:spPr>
           <a:xfrm>
-            <a:off x="457200" y="3931920"/>
-            <a:ext cx="8229600" cy="731520"/>
+            <a:off x="457200" y="3703320"/>
+            <a:ext cx="8229600" cy="914400"/>
           </a:xfrm>
           <a:prstGeom prst="roundRect">
             <a:avLst>
-              <a:gd name="adj" fmla="val 10000"/>
+              <a:gd name="adj" fmla="val 8000"/>
             </a:avLst>
           </a:prstGeom>
           <a:solidFill>
@@ -6260,8 +6260,8 @@
         </p:nvSpPr>
         <p:spPr>
           <a:xfrm>
-            <a:off x="640080" y="3931920"/>
-            <a:ext cx="7863840" cy="731520"/>
+            <a:off x="640080" y="3703320"/>
+            <a:ext cx="7863840" cy="914400"/>
           </a:xfrm>
           <a:prstGeom prst="rect">
             <a:avLst/>
@@ -6297,6 +6297,20 @@
                 </a:solidFill>
               </a:rPr>
               <a:t>Enforced in backend code, not in the AI prompt.</a:t>
+            </a:r>
+            <a:endParaRPr lang="en-US" sz="1600" dirty="0"/>
+          </a:p>
+          <a:p>
+            <a:pPr indent="0" marL="0">
+              <a:buNone/>
+            </a:pPr>
+            <a:r>
+              <a:rPr lang="en-US" sz="1200" dirty="0">
+                <a:solidFill>
+                  <a:schemeClr val="bg2"/>
+                </a:solidFill>
+              </a:rPr>
+              <a:t>Sandbox runs accept a documented test PIN (SEC-10); it is disabled when NODE_ENV=production.</a:t>
             </a:r>
             <a:endParaRPr lang="en-US" sz="1600" dirty="0"/>
           </a:p>
@@ -7783,7 +7797,7 @@
                   <a:schemeClr val="tx1"/>
                 </a:solidFill>
               </a:rPr>
-              <a:t>Confirm</a:t>
+              <a:t>2FA &amp; confirm</a:t>
             </a:r>
             <a:endParaRPr lang="en-US" sz="1600" dirty="0"/>
           </a:p>
@@ -7819,7 +7833,7 @@
                   <a:schemeClr val="tx2"/>
                 </a:solidFill>
               </a:rPr>
-              <a:t>Student approves. Balance: 850,000 to 491,545.15 BDT.</a:t>
+              <a:t>OTP code + approval. Balance: 850,000 to 491,545.15 BDT.</a:t>
             </a:r>
             <a:endParaRPr lang="en-US" sz="1400" dirty="0"/>
           </a:p>
@@ -8467,7 +8481,7 @@
                 <a:gridCol w="1371600"/>
                 <a:gridCol w="1188720"/>
               </a:tblGrid>
-              <a:tr h="365760">
+              <a:tr h="283464">
                 <a:tc>
                   <a:txBody>
                     <a:bodyPr/>
@@ -8477,14 +8491,14 @@
                         <a:buNone/>
                       </a:pPr>
                       <a:r>
-                        <a:rPr lang="en-US" sz="1200" b="1" dirty="0">
+                        <a:rPr lang="en-US" sz="1100" b="1" dirty="0">
                           <a:solidFill>
                             <a:srgbClr val="FFFFFF"/>
                           </a:solidFill>
                         </a:rPr>
                         <a:t>Event</a:t>
                       </a:r>
-                      <a:endParaRPr lang="en-US" sz="1200" dirty="0"/>
+                      <a:endParaRPr lang="en-US" sz="1100" dirty="0"/>
                     </a:p>
                   </a:txBody>
                   <a:tcPr marL="91440" marR="91440" marT="0" marB="0" anchor="ctr">
@@ -8538,14 +8552,14 @@
                         <a:buNone/>
                       </a:pPr>
                       <a:r>
-                        <a:rPr lang="en-US" sz="1200" b="1" dirty="0">
+                        <a:rPr lang="en-US" sz="1100" b="1" dirty="0">
                           <a:solidFill>
                             <a:srgbClr val="FFFFFF"/>
                           </a:solidFill>
                         </a:rPr>
                         <a:t>Tier</a:t>
                       </a:r>
-                      <a:endParaRPr lang="en-US" sz="1200" dirty="0"/>
+                      <a:endParaRPr lang="en-US" sz="1100" dirty="0"/>
                     </a:p>
                   </a:txBody>
                   <a:tcPr marL="91440" marR="91440" marT="0" marB="0" anchor="ctr">
@@ -8599,14 +8613,14 @@
                         <a:buNone/>
                       </a:pPr>
                       <a:r>
-                        <a:rPr lang="en-US" sz="1200" b="1" dirty="0">
+                        <a:rPr lang="en-US" sz="1100" b="1" dirty="0">
                           <a:solidFill>
                             <a:srgbClr val="FFFFFF"/>
                           </a:solidFill>
                         </a:rPr>
                         <a:t>Result</a:t>
                       </a:r>
-                      <a:endParaRPr lang="en-US" sz="1200" dirty="0"/>
+                      <a:endParaRPr lang="en-US" sz="1100" dirty="0"/>
                     </a:p>
                   </a:txBody>
                   <a:tcPr marL="91440" marR="91440" marT="0" marB="0" anchor="ctr">
@@ -8652,7 +8666,7 @@
                   </a:tcPr>
                 </a:tc>
               </a:tr>
-              <a:tr h="365760">
+              <a:tr h="283464">
                 <a:tc>
                   <a:txBody>
                     <a:bodyPr/>
@@ -8662,14 +8676,14 @@
                         <a:buNone/>
                       </a:pPr>
                       <a:r>
-                        <a:rPr lang="en-US" sz="1200" dirty="0">
+                        <a:rPr lang="en-US" sz="1100" dirty="0">
                           <a:solidFill>
                             <a:srgbClr val="0B1226"/>
                           </a:solidFill>
                         </a:rPr>
-                        <a:t>ROUTE_COMPARISON</a:t>
+                        <a:t>AUTH_REGISTRATION_SUCCESS</a:t>
                       </a:r>
-                      <a:endParaRPr lang="en-US" sz="1200" dirty="0"/>
+                      <a:endParaRPr lang="en-US" sz="1100" dirty="0"/>
                     </a:p>
                   </a:txBody>
                   <a:tcPr marL="91440" marR="91440" marT="0" marB="0" anchor="ctr">
@@ -8723,14 +8737,14 @@
                         <a:buNone/>
                       </a:pPr>
                       <a:r>
-                        <a:rPr lang="en-US" sz="1200" dirty="0">
+                        <a:rPr lang="en-US" sz="1100" dirty="0">
                           <a:solidFill>
                             <a:srgbClr val="475569"/>
                           </a:solidFill>
                         </a:rPr>
                         <a:t>READ_ONLY</a:t>
                       </a:r>
-                      <a:endParaRPr lang="en-US" sz="1200" dirty="0"/>
+                      <a:endParaRPr lang="en-US" sz="1100" dirty="0"/>
                     </a:p>
                   </a:txBody>
                   <a:tcPr marL="91440" marR="91440" marT="0" marB="0" anchor="ctr">
@@ -8784,14 +8798,14 @@
                         <a:buNone/>
                       </a:pPr>
                       <a:r>
-                        <a:rPr lang="en-US" sz="1200" b="1" dirty="0">
+                        <a:rPr lang="en-US" sz="1100" b="1" dirty="0">
                           <a:solidFill>
                             <a:srgbClr val="15803D"/>
                           </a:solidFill>
                         </a:rPr>
                         <a:t>SUCCESS</a:t>
                       </a:r>
-                      <a:endParaRPr lang="en-US" sz="1200" dirty="0"/>
+                      <a:endParaRPr lang="en-US" sz="1100" dirty="0"/>
                     </a:p>
                   </a:txBody>
                   <a:tcPr marL="91440" marR="91440" marT="0" marB="0" anchor="ctr">
@@ -8837,7 +8851,7 @@
                   </a:tcPr>
                 </a:tc>
               </a:tr>
-              <a:tr h="365760">
+              <a:tr h="283464">
                 <a:tc>
                   <a:txBody>
                     <a:bodyPr/>
@@ -8847,14 +8861,14 @@
                         <a:buNone/>
                       </a:pPr>
                       <a:r>
-                        <a:rPr lang="en-US" sz="1200" dirty="0">
+                        <a:rPr lang="en-US" sz="1100" dirty="0">
                           <a:solidFill>
                             <a:srgbClr val="0B1226"/>
                           </a:solidFill>
                         </a:rPr>
-                        <a:t>DRAFT_CREATED</a:t>
+                        <a:t>ROUTE_COMPARISON</a:t>
                       </a:r>
-                      <a:endParaRPr lang="en-US" sz="1200" dirty="0"/>
+                      <a:endParaRPr lang="en-US" sz="1100" dirty="0"/>
                     </a:p>
                   </a:txBody>
                   <a:tcPr marL="91440" marR="91440" marT="0" marB="0" anchor="ctr">
@@ -8908,14 +8922,14 @@
                         <a:buNone/>
                       </a:pPr>
                       <a:r>
-                        <a:rPr lang="en-US" sz="1200" dirty="0">
+                        <a:rPr lang="en-US" sz="1100" dirty="0">
                           <a:solidFill>
                             <a:srgbClr val="475569"/>
                           </a:solidFill>
                         </a:rPr>
-                        <a:t>DRAFT</a:t>
+                        <a:t>READ_ONLY</a:t>
                       </a:r>
-                      <a:endParaRPr lang="en-US" sz="1200" dirty="0"/>
+                      <a:endParaRPr lang="en-US" sz="1100" dirty="0"/>
                     </a:p>
                   </a:txBody>
                   <a:tcPr marL="91440" marR="91440" marT="0" marB="0" anchor="ctr">
@@ -8969,14 +8983,14 @@
                         <a:buNone/>
                       </a:pPr>
                       <a:r>
-                        <a:rPr lang="en-US" sz="1200" b="1" dirty="0">
+                        <a:rPr lang="en-US" sz="1100" b="1" dirty="0">
                           <a:solidFill>
                             <a:srgbClr val="15803D"/>
                           </a:solidFill>
                         </a:rPr>
                         <a:t>SUCCESS</a:t>
                       </a:r>
-                      <a:endParaRPr lang="en-US" sz="1200" dirty="0"/>
+                      <a:endParaRPr lang="en-US" sz="1100" dirty="0"/>
                     </a:p>
                   </a:txBody>
                   <a:tcPr marL="91440" marR="91440" marT="0" marB="0" anchor="ctr">
@@ -9022,7 +9036,7 @@
                   </a:tcPr>
                 </a:tc>
               </a:tr>
-              <a:tr h="365760">
+              <a:tr h="283464">
                 <a:tc>
                   <a:txBody>
                     <a:bodyPr/>
@@ -9032,14 +9046,14 @@
                         <a:buNone/>
                       </a:pPr>
                       <a:r>
-                        <a:rPr lang="en-US" sz="1200" dirty="0">
+                        <a:rPr lang="en-US" sz="1100" dirty="0">
                           <a:solidFill>
                             <a:srgbClr val="0B1226"/>
                           </a:solidFill>
                         </a:rPr>
-                        <a:t>CONFIRM_SUCCESS</a:t>
+                        <a:t>AML_SANCTIONS_CLEARED</a:t>
                       </a:r>
-                      <a:endParaRPr lang="en-US" sz="1200" dirty="0"/>
+                      <a:endParaRPr lang="en-US" sz="1100" dirty="0"/>
                     </a:p>
                   </a:txBody>
                   <a:tcPr marL="91440" marR="91440" marT="0" marB="0" anchor="ctr">
@@ -9093,14 +9107,14 @@
                         <a:buNone/>
                       </a:pPr>
                       <a:r>
-                        <a:rPr lang="en-US" sz="1200" dirty="0">
+                        <a:rPr lang="en-US" sz="1100" dirty="0">
                           <a:solidFill>
                             <a:srgbClr val="475569"/>
                           </a:solidFill>
                         </a:rPr>
-                        <a:t>EXECUTE</a:t>
+                        <a:t>DRAFT</a:t>
                       </a:r>
-                      <a:endParaRPr lang="en-US" sz="1200" dirty="0"/>
+                      <a:endParaRPr lang="en-US" sz="1100" dirty="0"/>
                     </a:p>
                   </a:txBody>
                   <a:tcPr marL="91440" marR="91440" marT="0" marB="0" anchor="ctr">
@@ -9154,14 +9168,14 @@
                         <a:buNone/>
                       </a:pPr>
                       <a:r>
-                        <a:rPr lang="en-US" sz="1200" b="1" dirty="0">
+                        <a:rPr lang="en-US" sz="1100" b="1" dirty="0">
                           <a:solidFill>
                             <a:srgbClr val="15803D"/>
                           </a:solidFill>
                         </a:rPr>
                         <a:t>SUCCESS</a:t>
                       </a:r>
-                      <a:endParaRPr lang="en-US" sz="1200" dirty="0"/>
+                      <a:endParaRPr lang="en-US" sz="1100" dirty="0"/>
                     </a:p>
                   </a:txBody>
                   <a:tcPr marL="91440" marR="91440" marT="0" marB="0" anchor="ctr">
@@ -9207,7 +9221,7 @@
                   </a:tcPr>
                 </a:tc>
               </a:tr>
-              <a:tr h="365760">
+              <a:tr h="283464">
                 <a:tc>
                   <a:txBody>
                     <a:bodyPr/>
@@ -9217,14 +9231,14 @@
                         <a:buNone/>
                       </a:pPr>
                       <a:r>
-                        <a:rPr lang="en-US" sz="1200" dirty="0">
+                        <a:rPr lang="en-US" sz="1100" dirty="0">
                           <a:solidFill>
                             <a:srgbClr val="0B1226"/>
                           </a:solidFill>
                         </a:rPr>
-                        <a:t>TRANSFER_COMPENSATED</a:t>
+                        <a:t>DRAFT_CREATED</a:t>
                       </a:r>
-                      <a:endParaRPr lang="en-US" sz="1200" dirty="0"/>
+                      <a:endParaRPr lang="en-US" sz="1100" dirty="0"/>
                     </a:p>
                   </a:txBody>
                   <a:tcPr marL="91440" marR="91440" marT="0" marB="0" anchor="ctr">
@@ -9278,14 +9292,14 @@
                         <a:buNone/>
                       </a:pPr>
                       <a:r>
-                        <a:rPr lang="en-US" sz="1200" dirty="0">
+                        <a:rPr lang="en-US" sz="1100" dirty="0">
                           <a:solidFill>
                             <a:srgbClr val="475569"/>
                           </a:solidFill>
                         </a:rPr>
-                        <a:t>EXECUTE</a:t>
+                        <a:t>DRAFT</a:t>
                       </a:r>
-                      <a:endParaRPr lang="en-US" sz="1200" dirty="0"/>
+                      <a:endParaRPr lang="en-US" sz="1100" dirty="0"/>
                     </a:p>
                   </a:txBody>
                   <a:tcPr marL="91440" marR="91440" marT="0" marB="0" anchor="ctr">
@@ -9339,14 +9353,14 @@
                         <a:buNone/>
                       </a:pPr>
                       <a:r>
-                        <a:rPr lang="en-US" sz="1200" b="1" dirty="0">
+                        <a:rPr lang="en-US" sz="1100" b="1" dirty="0">
                           <a:solidFill>
-                            <a:srgbClr val="B45309"/>
+                            <a:srgbClr val="15803D"/>
                           </a:solidFill>
                         </a:rPr>
-                        <a:t>WARNING</a:t>
+                        <a:t>SUCCESS</a:t>
                       </a:r>
-                      <a:endParaRPr lang="en-US" sz="1200" dirty="0"/>
+                      <a:endParaRPr lang="en-US" sz="1100" dirty="0"/>
                     </a:p>
                   </a:txBody>
                   <a:tcPr marL="91440" marR="91440" marT="0" marB="0" anchor="ctr">
@@ -9392,7 +9406,7 @@
                   </a:tcPr>
                 </a:tc>
               </a:tr>
-              <a:tr h="365760">
+              <a:tr h="283464">
                 <a:tc>
                   <a:txBody>
                     <a:bodyPr/>
@@ -9402,14 +9416,14 @@
                         <a:buNone/>
                       </a:pPr>
                       <a:r>
-                        <a:rPr lang="en-US" sz="1200" dirty="0">
+                        <a:rPr lang="en-US" sz="1100" dirty="0">
                           <a:solidFill>
                             <a:srgbClr val="0B1226"/>
                           </a:solidFill>
                         </a:rPr>
-                        <a:t>SAFETY_LIMIT_TRIGGERED</a:t>
+                        <a:t>STEP_UP_OTP_ISSUED</a:t>
                       </a:r>
-                      <a:endParaRPr lang="en-US" sz="1200" dirty="0"/>
+                      <a:endParaRPr lang="en-US" sz="1100" dirty="0"/>
                     </a:p>
                   </a:txBody>
                   <a:tcPr marL="91440" marR="91440" marT="0" marB="0" anchor="ctr">
@@ -9463,14 +9477,14 @@
                         <a:buNone/>
                       </a:pPr>
                       <a:r>
-                        <a:rPr lang="en-US" sz="1200" dirty="0">
+                        <a:rPr lang="en-US" sz="1100" dirty="0">
                           <a:solidFill>
                             <a:srgbClr val="475569"/>
                           </a:solidFill>
                         </a:rPr>
-                        <a:t>DRAFT</a:t>
+                        <a:t>EXECUTE</a:t>
                       </a:r>
-                      <a:endParaRPr lang="en-US" sz="1200" dirty="0"/>
+                      <a:endParaRPr lang="en-US" sz="1100" dirty="0"/>
                     </a:p>
                   </a:txBody>
                   <a:tcPr marL="91440" marR="91440" marT="0" marB="0" anchor="ctr">
@@ -9524,14 +9538,14 @@
                         <a:buNone/>
                       </a:pPr>
                       <a:r>
-                        <a:rPr lang="en-US" sz="1200" b="1" dirty="0">
+                        <a:rPr lang="en-US" sz="1100" b="1" dirty="0">
                           <a:solidFill>
-                            <a:srgbClr val="B91C1C"/>
+                            <a:srgbClr val="15803D"/>
                           </a:solidFill>
                         </a:rPr>
-                        <a:t>BLOCKED</a:t>
+                        <a:t>SUCCESS</a:t>
                       </a:r>
-                      <a:endParaRPr lang="en-US" sz="1200" dirty="0"/>
+                      <a:endParaRPr lang="en-US" sz="1100" dirty="0"/>
                     </a:p>
                   </a:txBody>
                   <a:tcPr marL="91440" marR="91440" marT="0" marB="0" anchor="ctr">
@@ -9577,7 +9591,7 @@
                   </a:tcPr>
                 </a:tc>
               </a:tr>
-              <a:tr h="365760">
+              <a:tr h="283464">
                 <a:tc>
                   <a:txBody>
                     <a:bodyPr/>
@@ -9587,14 +9601,14 @@
                         <a:buNone/>
                       </a:pPr>
                       <a:r>
-                        <a:rPr lang="en-US" sz="1200" dirty="0">
+                        <a:rPr lang="en-US" sz="1100" dirty="0">
                           <a:solidFill>
                             <a:srgbClr val="0B1226"/>
                           </a:solidFill>
                         </a:rPr>
-                        <a:t>PROMPT_INJECTION_FLAGGED</a:t>
+                        <a:t>CONFIRM_SUCCESS</a:t>
                       </a:r>
-                      <a:endParaRPr lang="en-US" sz="1200" dirty="0"/>
+                      <a:endParaRPr lang="en-US" sz="1100" dirty="0"/>
                     </a:p>
                   </a:txBody>
                   <a:tcPr marL="91440" marR="91440" marT="0" marB="0" anchor="ctr">
@@ -9648,14 +9662,14 @@
                         <a:buNone/>
                       </a:pPr>
                       <a:r>
-                        <a:rPr lang="en-US" sz="1200" dirty="0">
+                        <a:rPr lang="en-US" sz="1100" dirty="0">
                           <a:solidFill>
                             <a:srgbClr val="475569"/>
                           </a:solidFill>
                         </a:rPr>
-                        <a:t>READ_ONLY</a:t>
+                        <a:t>EXECUTE</a:t>
                       </a:r>
-                      <a:endParaRPr lang="en-US" sz="1200" dirty="0"/>
+                      <a:endParaRPr lang="en-US" sz="1100" dirty="0"/>
                     </a:p>
                   </a:txBody>
                   <a:tcPr marL="91440" marR="91440" marT="0" marB="0" anchor="ctr">
@@ -9709,14 +9723,14 @@
                         <a:buNone/>
                       </a:pPr>
                       <a:r>
-                        <a:rPr lang="en-US" sz="1200" b="1" dirty="0">
+                        <a:rPr lang="en-US" sz="1100" b="1" dirty="0">
                           <a:solidFill>
-                            <a:srgbClr val="B45309"/>
+                            <a:srgbClr val="15803D"/>
                           </a:solidFill>
                         </a:rPr>
-                        <a:t>FLAGGED</a:t>
+                        <a:t>SUCCESS</a:t>
                       </a:r>
-                      <a:endParaRPr lang="en-US" sz="1200" dirty="0"/>
+                      <a:endParaRPr lang="en-US" sz="1100" dirty="0"/>
                     </a:p>
                   </a:txBody>
                   <a:tcPr marL="91440" marR="91440" marT="0" marB="0" anchor="ctr">
@@ -9762,7 +9776,7 @@
                   </a:tcPr>
                 </a:tc>
               </a:tr>
-              <a:tr h="365760">
+              <a:tr h="283464">
                 <a:tc>
                   <a:txBody>
                     <a:bodyPr/>
@@ -9772,14 +9786,14 @@
                         <a:buNone/>
                       </a:pPr>
                       <a:r>
-                        <a:rPr lang="en-US" sz="1200" dirty="0">
+                        <a:rPr lang="en-US" sz="1100" dirty="0">
                           <a:solidFill>
                             <a:srgbClr val="0B1226"/>
                           </a:solidFill>
                         </a:rPr>
-                        <a:t>PENETRATION_ATTACK_BLOCKED</a:t>
+                        <a:t>TRANSFER_COMPENSATED</a:t>
                       </a:r>
-                      <a:endParaRPr lang="en-US" sz="1200" dirty="0"/>
+                      <a:endParaRPr lang="en-US" sz="1100" dirty="0"/>
                     </a:p>
                   </a:txBody>
                   <a:tcPr marL="91440" marR="91440" marT="0" marB="0" anchor="ctr">
@@ -9833,14 +9847,14 @@
                         <a:buNone/>
                       </a:pPr>
                       <a:r>
-                        <a:rPr lang="en-US" sz="1200" dirty="0">
+                        <a:rPr lang="en-US" sz="1100" dirty="0">
                           <a:solidFill>
                             <a:srgbClr val="475569"/>
                           </a:solidFill>
                         </a:rPr>
-                        <a:t>READ_ONLY</a:t>
+                        <a:t>EXECUTE</a:t>
                       </a:r>
-                      <a:endParaRPr lang="en-US" sz="1200" dirty="0"/>
+                      <a:endParaRPr lang="en-US" sz="1100" dirty="0"/>
                     </a:p>
                   </a:txBody>
                   <a:tcPr marL="91440" marR="91440" marT="0" marB="0" anchor="ctr">
@@ -9894,14 +9908,199 @@
                         <a:buNone/>
                       </a:pPr>
                       <a:r>
-                        <a:rPr lang="en-US" sz="1200" b="1" dirty="0">
+                        <a:rPr lang="en-US" sz="1100" b="1" dirty="0">
+                          <a:solidFill>
+                            <a:srgbClr val="B45309"/>
+                          </a:solidFill>
+                        </a:rPr>
+                        <a:t>WARNING</a:t>
+                      </a:r>
+                      <a:endParaRPr lang="en-US" sz="1100" dirty="0"/>
+                    </a:p>
+                  </a:txBody>
+                  <a:tcPr marL="91440" marR="91440" marT="0" marB="0" anchor="ctr">
+                    <a:lnL w="6350" cap="flat" cmpd="sng" algn="ctr">
+                      <a:solidFill>
+                        <a:srgbClr val="CBD5E1"/>
+                      </a:solidFill>
+                      <a:prstDash val="solid"/>
+                      <a:round/>
+                      <a:headEnd type="none" w="med" len="med"/>
+                      <a:tailEnd type="none" w="med" len="med"/>
+                    </a:lnL>
+                    <a:lnR w="6350" cap="flat" cmpd="sng" algn="ctr">
+                      <a:solidFill>
+                        <a:srgbClr val="CBD5E1"/>
+                      </a:solidFill>
+                      <a:prstDash val="solid"/>
+                      <a:round/>
+                      <a:headEnd type="none" w="med" len="med"/>
+                      <a:tailEnd type="none" w="med" len="med"/>
+                    </a:lnR>
+                    <a:lnT w="6350" cap="flat" cmpd="sng" algn="ctr">
+                      <a:solidFill>
+                        <a:srgbClr val="CBD5E1"/>
+                      </a:solidFill>
+                      <a:prstDash val="solid"/>
+                      <a:round/>
+                      <a:headEnd type="none" w="med" len="med"/>
+                      <a:tailEnd type="none" w="med" len="med"/>
+                    </a:lnT>
+                    <a:lnB w="6350" cap="flat" cmpd="sng" algn="ctr">
+                      <a:solidFill>
+                        <a:srgbClr val="CBD5E1"/>
+                      </a:solidFill>
+                      <a:prstDash val="solid"/>
+                      <a:round/>
+                      <a:headEnd type="none" w="med" len="med"/>
+                      <a:tailEnd type="none" w="med" len="med"/>
+                    </a:lnB>
+                    <a:solidFill>
+                      <a:srgbClr val="FFFFFF"/>
+                    </a:solidFill>
+                  </a:tcPr>
+                </a:tc>
+              </a:tr>
+              <a:tr h="283464">
+                <a:tc>
+                  <a:txBody>
+                    <a:bodyPr/>
+                    <a:lstStyle/>
+                    <a:p>
+                      <a:pPr indent="0" marL="0">
+                        <a:buNone/>
+                      </a:pPr>
+                      <a:r>
+                        <a:rPr lang="en-US" sz="1100" dirty="0">
+                          <a:solidFill>
+                            <a:srgbClr val="0B1226"/>
+                          </a:solidFill>
+                        </a:rPr>
+                        <a:t>SAFETY_LIMIT_TRIGGERED</a:t>
+                      </a:r>
+                      <a:endParaRPr lang="en-US" sz="1100" dirty="0"/>
+                    </a:p>
+                  </a:txBody>
+                  <a:tcPr marL="91440" marR="91440" marT="0" marB="0" anchor="ctr">
+                    <a:lnL w="6350" cap="flat" cmpd="sng" algn="ctr">
+                      <a:solidFill>
+                        <a:srgbClr val="CBD5E1"/>
+                      </a:solidFill>
+                      <a:prstDash val="solid"/>
+                      <a:round/>
+                      <a:headEnd type="none" w="med" len="med"/>
+                      <a:tailEnd type="none" w="med" len="med"/>
+                    </a:lnL>
+                    <a:lnR w="6350" cap="flat" cmpd="sng" algn="ctr">
+                      <a:solidFill>
+                        <a:srgbClr val="CBD5E1"/>
+                      </a:solidFill>
+                      <a:prstDash val="solid"/>
+                      <a:round/>
+                      <a:headEnd type="none" w="med" len="med"/>
+                      <a:tailEnd type="none" w="med" len="med"/>
+                    </a:lnR>
+                    <a:lnT w="6350" cap="flat" cmpd="sng" algn="ctr">
+                      <a:solidFill>
+                        <a:srgbClr val="CBD5E1"/>
+                      </a:solidFill>
+                      <a:prstDash val="solid"/>
+                      <a:round/>
+                      <a:headEnd type="none" w="med" len="med"/>
+                      <a:tailEnd type="none" w="med" len="med"/>
+                    </a:lnT>
+                    <a:lnB w="6350" cap="flat" cmpd="sng" algn="ctr">
+                      <a:solidFill>
+                        <a:srgbClr val="CBD5E1"/>
+                      </a:solidFill>
+                      <a:prstDash val="solid"/>
+                      <a:round/>
+                      <a:headEnd type="none" w="med" len="med"/>
+                      <a:tailEnd type="none" w="med" len="med"/>
+                    </a:lnB>
+                    <a:solidFill>
+                      <a:srgbClr val="F1F5F9"/>
+                    </a:solidFill>
+                  </a:tcPr>
+                </a:tc>
+                <a:tc>
+                  <a:txBody>
+                    <a:bodyPr/>
+                    <a:lstStyle/>
+                    <a:p>
+                      <a:pPr indent="0" marL="0">
+                        <a:buNone/>
+                      </a:pPr>
+                      <a:r>
+                        <a:rPr lang="en-US" sz="1100" dirty="0">
+                          <a:solidFill>
+                            <a:srgbClr val="475569"/>
+                          </a:solidFill>
+                        </a:rPr>
+                        <a:t>DRAFT</a:t>
+                      </a:r>
+                      <a:endParaRPr lang="en-US" sz="1100" dirty="0"/>
+                    </a:p>
+                  </a:txBody>
+                  <a:tcPr marL="91440" marR="91440" marT="0" marB="0" anchor="ctr">
+                    <a:lnL w="6350" cap="flat" cmpd="sng" algn="ctr">
+                      <a:solidFill>
+                        <a:srgbClr val="CBD5E1"/>
+                      </a:solidFill>
+                      <a:prstDash val="solid"/>
+                      <a:round/>
+                      <a:headEnd type="none" w="med" len="med"/>
+                      <a:tailEnd type="none" w="med" len="med"/>
+                    </a:lnL>
+                    <a:lnR w="6350" cap="flat" cmpd="sng" algn="ctr">
+                      <a:solidFill>
+                        <a:srgbClr val="CBD5E1"/>
+                      </a:solidFill>
+                      <a:prstDash val="solid"/>
+                      <a:round/>
+                      <a:headEnd type="none" w="med" len="med"/>
+                      <a:tailEnd type="none" w="med" len="med"/>
+                    </a:lnR>
+                    <a:lnT w="6350" cap="flat" cmpd="sng" algn="ctr">
+                      <a:solidFill>
+                        <a:srgbClr val="CBD5E1"/>
+                      </a:solidFill>
+                      <a:prstDash val="solid"/>
+                      <a:round/>
+                      <a:headEnd type="none" w="med" len="med"/>
+                      <a:tailEnd type="none" w="med" len="med"/>
+                    </a:lnT>
+                    <a:lnB w="6350" cap="flat" cmpd="sng" algn="ctr">
+                      <a:solidFill>
+                        <a:srgbClr val="CBD5E1"/>
+                      </a:solidFill>
+                      <a:prstDash val="solid"/>
+                      <a:round/>
+                      <a:headEnd type="none" w="med" len="med"/>
+                      <a:tailEnd type="none" w="med" len="med"/>
+                    </a:lnB>
+                    <a:solidFill>
+                      <a:srgbClr val="F1F5F9"/>
+                    </a:solidFill>
+                  </a:tcPr>
+                </a:tc>
+                <a:tc>
+                  <a:txBody>
+                    <a:bodyPr/>
+                    <a:lstStyle/>
+                    <a:p>
+                      <a:pPr indent="0" marL="0">
+                        <a:buNone/>
+                      </a:pPr>
+                      <a:r>
+                        <a:rPr lang="en-US" sz="1100" b="1" dirty="0">
                           <a:solidFill>
                             <a:srgbClr val="B91C1C"/>
                           </a:solidFill>
                         </a:rPr>
                         <a:t>BLOCKED</a:t>
                       </a:r>
-                      <a:endParaRPr lang="en-US" sz="1200" dirty="0"/>
+                      <a:endParaRPr lang="en-US" sz="1100" dirty="0"/>
                     </a:p>
                   </a:txBody>
                   <a:tcPr marL="91440" marR="91440" marT="0" marB="0" anchor="ctr">
@@ -9942,7 +10141,377 @@
                       <a:tailEnd type="none" w="med" len="med"/>
                     </a:lnB>
                     <a:solidFill>
+                      <a:srgbClr val="F1F5F9"/>
+                    </a:solidFill>
+                  </a:tcPr>
+                </a:tc>
+              </a:tr>
+              <a:tr h="283464">
+                <a:tc>
+                  <a:txBody>
+                    <a:bodyPr/>
+                    <a:lstStyle/>
+                    <a:p>
+                      <a:pPr indent="0" marL="0">
+                        <a:buNone/>
+                      </a:pPr>
+                      <a:r>
+                        <a:rPr lang="en-US" sz="1100" dirty="0">
+                          <a:solidFill>
+                            <a:srgbClr val="0B1226"/>
+                          </a:solidFill>
+                        </a:rPr>
+                        <a:t>PROMPT_INJECTION_FLAGGED</a:t>
+                      </a:r>
+                      <a:endParaRPr lang="en-US" sz="1100" dirty="0"/>
+                    </a:p>
+                  </a:txBody>
+                  <a:tcPr marL="91440" marR="91440" marT="0" marB="0" anchor="ctr">
+                    <a:lnL w="6350" cap="flat" cmpd="sng" algn="ctr">
+                      <a:solidFill>
+                        <a:srgbClr val="CBD5E1"/>
+                      </a:solidFill>
+                      <a:prstDash val="solid"/>
+                      <a:round/>
+                      <a:headEnd type="none" w="med" len="med"/>
+                      <a:tailEnd type="none" w="med" len="med"/>
+                    </a:lnL>
+                    <a:lnR w="6350" cap="flat" cmpd="sng" algn="ctr">
+                      <a:solidFill>
+                        <a:srgbClr val="CBD5E1"/>
+                      </a:solidFill>
+                      <a:prstDash val="solid"/>
+                      <a:round/>
+                      <a:headEnd type="none" w="med" len="med"/>
+                      <a:tailEnd type="none" w="med" len="med"/>
+                    </a:lnR>
+                    <a:lnT w="6350" cap="flat" cmpd="sng" algn="ctr">
+                      <a:solidFill>
+                        <a:srgbClr val="CBD5E1"/>
+                      </a:solidFill>
+                      <a:prstDash val="solid"/>
+                      <a:round/>
+                      <a:headEnd type="none" w="med" len="med"/>
+                      <a:tailEnd type="none" w="med" len="med"/>
+                    </a:lnT>
+                    <a:lnB w="6350" cap="flat" cmpd="sng" algn="ctr">
+                      <a:solidFill>
+                        <a:srgbClr val="CBD5E1"/>
+                      </a:solidFill>
+                      <a:prstDash val="solid"/>
+                      <a:round/>
+                      <a:headEnd type="none" w="med" len="med"/>
+                      <a:tailEnd type="none" w="med" len="med"/>
+                    </a:lnB>
+                    <a:solidFill>
                       <a:srgbClr val="FFFFFF"/>
+                    </a:solidFill>
+                  </a:tcPr>
+                </a:tc>
+                <a:tc>
+                  <a:txBody>
+                    <a:bodyPr/>
+                    <a:lstStyle/>
+                    <a:p>
+                      <a:pPr indent="0" marL="0">
+                        <a:buNone/>
+                      </a:pPr>
+                      <a:r>
+                        <a:rPr lang="en-US" sz="1100" dirty="0">
+                          <a:solidFill>
+                            <a:srgbClr val="475569"/>
+                          </a:solidFill>
+                        </a:rPr>
+                        <a:t>READ_ONLY</a:t>
+                      </a:r>
+                      <a:endParaRPr lang="en-US" sz="1100" dirty="0"/>
+                    </a:p>
+                  </a:txBody>
+                  <a:tcPr marL="91440" marR="91440" marT="0" marB="0" anchor="ctr">
+                    <a:lnL w="6350" cap="flat" cmpd="sng" algn="ctr">
+                      <a:solidFill>
+                        <a:srgbClr val="CBD5E1"/>
+                      </a:solidFill>
+                      <a:prstDash val="solid"/>
+                      <a:round/>
+                      <a:headEnd type="none" w="med" len="med"/>
+                      <a:tailEnd type="none" w="med" len="med"/>
+                    </a:lnL>
+                    <a:lnR w="6350" cap="flat" cmpd="sng" algn="ctr">
+                      <a:solidFill>
+                        <a:srgbClr val="CBD5E1"/>
+                      </a:solidFill>
+                      <a:prstDash val="solid"/>
+                      <a:round/>
+                      <a:headEnd type="none" w="med" len="med"/>
+                      <a:tailEnd type="none" w="med" len="med"/>
+                    </a:lnR>
+                    <a:lnT w="6350" cap="flat" cmpd="sng" algn="ctr">
+                      <a:solidFill>
+                        <a:srgbClr val="CBD5E1"/>
+                      </a:solidFill>
+                      <a:prstDash val="solid"/>
+                      <a:round/>
+                      <a:headEnd type="none" w="med" len="med"/>
+                      <a:tailEnd type="none" w="med" len="med"/>
+                    </a:lnT>
+                    <a:lnB w="6350" cap="flat" cmpd="sng" algn="ctr">
+                      <a:solidFill>
+                        <a:srgbClr val="CBD5E1"/>
+                      </a:solidFill>
+                      <a:prstDash val="solid"/>
+                      <a:round/>
+                      <a:headEnd type="none" w="med" len="med"/>
+                      <a:tailEnd type="none" w="med" len="med"/>
+                    </a:lnB>
+                    <a:solidFill>
+                      <a:srgbClr val="FFFFFF"/>
+                    </a:solidFill>
+                  </a:tcPr>
+                </a:tc>
+                <a:tc>
+                  <a:txBody>
+                    <a:bodyPr/>
+                    <a:lstStyle/>
+                    <a:p>
+                      <a:pPr indent="0" marL="0">
+                        <a:buNone/>
+                      </a:pPr>
+                      <a:r>
+                        <a:rPr lang="en-US" sz="1100" b="1" dirty="0">
+                          <a:solidFill>
+                            <a:srgbClr val="B45309"/>
+                          </a:solidFill>
+                        </a:rPr>
+                        <a:t>FLAGGED</a:t>
+                      </a:r>
+                      <a:endParaRPr lang="en-US" sz="1100" dirty="0"/>
+                    </a:p>
+                  </a:txBody>
+                  <a:tcPr marL="91440" marR="91440" marT="0" marB="0" anchor="ctr">
+                    <a:lnL w="6350" cap="flat" cmpd="sng" algn="ctr">
+                      <a:solidFill>
+                        <a:srgbClr val="CBD5E1"/>
+                      </a:solidFill>
+                      <a:prstDash val="solid"/>
+                      <a:round/>
+                      <a:headEnd type="none" w="med" len="med"/>
+                      <a:tailEnd type="none" w="med" len="med"/>
+                    </a:lnL>
+                    <a:lnR w="6350" cap="flat" cmpd="sng" algn="ctr">
+                      <a:solidFill>
+                        <a:srgbClr val="CBD5E1"/>
+                      </a:solidFill>
+                      <a:prstDash val="solid"/>
+                      <a:round/>
+                      <a:headEnd type="none" w="med" len="med"/>
+                      <a:tailEnd type="none" w="med" len="med"/>
+                    </a:lnR>
+                    <a:lnT w="6350" cap="flat" cmpd="sng" algn="ctr">
+                      <a:solidFill>
+                        <a:srgbClr val="CBD5E1"/>
+                      </a:solidFill>
+                      <a:prstDash val="solid"/>
+                      <a:round/>
+                      <a:headEnd type="none" w="med" len="med"/>
+                      <a:tailEnd type="none" w="med" len="med"/>
+                    </a:lnT>
+                    <a:lnB w="6350" cap="flat" cmpd="sng" algn="ctr">
+                      <a:solidFill>
+                        <a:srgbClr val="CBD5E1"/>
+                      </a:solidFill>
+                      <a:prstDash val="solid"/>
+                      <a:round/>
+                      <a:headEnd type="none" w="med" len="med"/>
+                      <a:tailEnd type="none" w="med" len="med"/>
+                    </a:lnB>
+                    <a:solidFill>
+                      <a:srgbClr val="FFFFFF"/>
+                    </a:solidFill>
+                  </a:tcPr>
+                </a:tc>
+              </a:tr>
+              <a:tr h="283464">
+                <a:tc>
+                  <a:txBody>
+                    <a:bodyPr/>
+                    <a:lstStyle/>
+                    <a:p>
+                      <a:pPr indent="0" marL="0">
+                        <a:buNone/>
+                      </a:pPr>
+                      <a:r>
+                        <a:rPr lang="en-US" sz="1100" dirty="0">
+                          <a:solidFill>
+                            <a:srgbClr val="0B1226"/>
+                          </a:solidFill>
+                        </a:rPr>
+                        <a:t>PENETRATION_ATTACK_BLOCKED</a:t>
+                      </a:r>
+                      <a:endParaRPr lang="en-US" sz="1100" dirty="0"/>
+                    </a:p>
+                  </a:txBody>
+                  <a:tcPr marL="91440" marR="91440" marT="0" marB="0" anchor="ctr">
+                    <a:lnL w="6350" cap="flat" cmpd="sng" algn="ctr">
+                      <a:solidFill>
+                        <a:srgbClr val="CBD5E1"/>
+                      </a:solidFill>
+                      <a:prstDash val="solid"/>
+                      <a:round/>
+                      <a:headEnd type="none" w="med" len="med"/>
+                      <a:tailEnd type="none" w="med" len="med"/>
+                    </a:lnL>
+                    <a:lnR w="6350" cap="flat" cmpd="sng" algn="ctr">
+                      <a:solidFill>
+                        <a:srgbClr val="CBD5E1"/>
+                      </a:solidFill>
+                      <a:prstDash val="solid"/>
+                      <a:round/>
+                      <a:headEnd type="none" w="med" len="med"/>
+                      <a:tailEnd type="none" w="med" len="med"/>
+                    </a:lnR>
+                    <a:lnT w="6350" cap="flat" cmpd="sng" algn="ctr">
+                      <a:solidFill>
+                        <a:srgbClr val="CBD5E1"/>
+                      </a:solidFill>
+                      <a:prstDash val="solid"/>
+                      <a:round/>
+                      <a:headEnd type="none" w="med" len="med"/>
+                      <a:tailEnd type="none" w="med" len="med"/>
+                    </a:lnT>
+                    <a:lnB w="6350" cap="flat" cmpd="sng" algn="ctr">
+                      <a:solidFill>
+                        <a:srgbClr val="CBD5E1"/>
+                      </a:solidFill>
+                      <a:prstDash val="solid"/>
+                      <a:round/>
+                      <a:headEnd type="none" w="med" len="med"/>
+                      <a:tailEnd type="none" w="med" len="med"/>
+                    </a:lnB>
+                    <a:solidFill>
+                      <a:srgbClr val="F1F5F9"/>
+                    </a:solidFill>
+                  </a:tcPr>
+                </a:tc>
+                <a:tc>
+                  <a:txBody>
+                    <a:bodyPr/>
+                    <a:lstStyle/>
+                    <a:p>
+                      <a:pPr indent="0" marL="0">
+                        <a:buNone/>
+                      </a:pPr>
+                      <a:r>
+                        <a:rPr lang="en-US" sz="1100" dirty="0">
+                          <a:solidFill>
+                            <a:srgbClr val="475569"/>
+                          </a:solidFill>
+                        </a:rPr>
+                        <a:t>READ_ONLY</a:t>
+                      </a:r>
+                      <a:endParaRPr lang="en-US" sz="1100" dirty="0"/>
+                    </a:p>
+                  </a:txBody>
+                  <a:tcPr marL="91440" marR="91440" marT="0" marB="0" anchor="ctr">
+                    <a:lnL w="6350" cap="flat" cmpd="sng" algn="ctr">
+                      <a:solidFill>
+                        <a:srgbClr val="CBD5E1"/>
+                      </a:solidFill>
+                      <a:prstDash val="solid"/>
+                      <a:round/>
+                      <a:headEnd type="none" w="med" len="med"/>
+                      <a:tailEnd type="none" w="med" len="med"/>
+                    </a:lnL>
+                    <a:lnR w="6350" cap="flat" cmpd="sng" algn="ctr">
+                      <a:solidFill>
+                        <a:srgbClr val="CBD5E1"/>
+                      </a:solidFill>
+                      <a:prstDash val="solid"/>
+                      <a:round/>
+                      <a:headEnd type="none" w="med" len="med"/>
+                      <a:tailEnd type="none" w="med" len="med"/>
+                    </a:lnR>
+                    <a:lnT w="6350" cap="flat" cmpd="sng" algn="ctr">
+                      <a:solidFill>
+                        <a:srgbClr val="CBD5E1"/>
+                      </a:solidFill>
+                      <a:prstDash val="solid"/>
+                      <a:round/>
+                      <a:headEnd type="none" w="med" len="med"/>
+                      <a:tailEnd type="none" w="med" len="med"/>
+                    </a:lnT>
+                    <a:lnB w="6350" cap="flat" cmpd="sng" algn="ctr">
+                      <a:solidFill>
+                        <a:srgbClr val="CBD5E1"/>
+                      </a:solidFill>
+                      <a:prstDash val="solid"/>
+                      <a:round/>
+                      <a:headEnd type="none" w="med" len="med"/>
+                      <a:tailEnd type="none" w="med" len="med"/>
+                    </a:lnB>
+                    <a:solidFill>
+                      <a:srgbClr val="F1F5F9"/>
+                    </a:solidFill>
+                  </a:tcPr>
+                </a:tc>
+                <a:tc>
+                  <a:txBody>
+                    <a:bodyPr/>
+                    <a:lstStyle/>
+                    <a:p>
+                      <a:pPr indent="0" marL="0">
+                        <a:buNone/>
+                      </a:pPr>
+                      <a:r>
+                        <a:rPr lang="en-US" sz="1100" b="1" dirty="0">
+                          <a:solidFill>
+                            <a:srgbClr val="B91C1C"/>
+                          </a:solidFill>
+                        </a:rPr>
+                        <a:t>BLOCKED</a:t>
+                      </a:r>
+                      <a:endParaRPr lang="en-US" sz="1100" dirty="0"/>
+                    </a:p>
+                  </a:txBody>
+                  <a:tcPr marL="91440" marR="91440" marT="0" marB="0" anchor="ctr">
+                    <a:lnL w="6350" cap="flat" cmpd="sng" algn="ctr">
+                      <a:solidFill>
+                        <a:srgbClr val="CBD5E1"/>
+                      </a:solidFill>
+                      <a:prstDash val="solid"/>
+                      <a:round/>
+                      <a:headEnd type="none" w="med" len="med"/>
+                      <a:tailEnd type="none" w="med" len="med"/>
+                    </a:lnL>
+                    <a:lnR w="6350" cap="flat" cmpd="sng" algn="ctr">
+                      <a:solidFill>
+                        <a:srgbClr val="CBD5E1"/>
+                      </a:solidFill>
+                      <a:prstDash val="solid"/>
+                      <a:round/>
+                      <a:headEnd type="none" w="med" len="med"/>
+                      <a:tailEnd type="none" w="med" len="med"/>
+                    </a:lnR>
+                    <a:lnT w="6350" cap="flat" cmpd="sng" algn="ctr">
+                      <a:solidFill>
+                        <a:srgbClr val="CBD5E1"/>
+                      </a:solidFill>
+                      <a:prstDash val="solid"/>
+                      <a:round/>
+                      <a:headEnd type="none" w="med" len="med"/>
+                      <a:tailEnd type="none" w="med" len="med"/>
+                    </a:lnT>
+                    <a:lnB w="6350" cap="flat" cmpd="sng" algn="ctr">
+                      <a:solidFill>
+                        <a:srgbClr val="CBD5E1"/>
+                      </a:solidFill>
+                      <a:prstDash val="solid"/>
+                      <a:round/>
+                      <a:headEnd type="none" w="med" len="med"/>
+                      <a:tailEnd type="none" w="med" len="med"/>
+                    </a:lnB>
+                    <a:solidFill>
+                      <a:srgbClr val="F1F5F9"/>
                     </a:solidFill>
                   </a:tcPr>
                 </a:tc>
@@ -9959,7 +10528,7 @@
         </p:nvSpPr>
         <p:spPr>
           <a:xfrm>
-            <a:off x="457200" y="4343400"/>
+            <a:off x="457200" y="4480560"/>
             <a:ext cx="5303520" cy="228600"/>
           </a:xfrm>
           <a:prstGeom prst="rect">
@@ -9981,7 +10550,7 @@
                   <a:schemeClr val="tx2"/>
                 </a:solidFill>
               </a:rPr>
-              <a:t>Source: execution-evidence.json (sandbox export)</a:t>
+              <a:t>Key events from execution-evidence.json (sandbox export)</a:t>
             </a:r>
             <a:endParaRPr lang="en-US" sz="1100" dirty="0"/>
           </a:p>
@@ -10039,7 +10608,7 @@
                   <a:schemeClr val="accent6"/>
                 </a:solidFill>
               </a:rPr>
-              <a:t>9</a:t>
+              <a:t>12</a:t>
             </a:r>
             <a:endParaRPr lang="en-US" sz="5400" dirty="0"/>
           </a:p>
@@ -10603,7 +11172,7 @@
                   <a:schemeClr val="tx2"/>
                 </a:solidFill>
               </a:rPr>
-              <a:t>Consent and token needed</a:t>
+              <a:t>Token + 2FA OTP required</a:t>
             </a:r>
             <a:endParaRPr lang="en-US" sz="1400" dirty="0"/>
           </a:p>

</xml_diff>